<commit_message>
docs: enrich PowerPoint presentation deck with visual charts, tables, and sample run infographic
</commit_message>
<xml_diff>
--- a/docs/presentation.pptx
+++ b/docs/presentation.pptx
@@ -3145,8 +3145,8 @@
         </p:nvSpPr>
         <p:spPr>
           <a:xfrm>
-            <a:off x="914400" y="1097280"/>
-            <a:ext cx="10058400" cy="457200"/>
+            <a:off x="731520" y="731520"/>
+            <a:ext cx="10698480" cy="365760"/>
           </a:xfrm>
           <a:prstGeom prst="rect">
             <a:avLst/>
@@ -3160,14 +3160,14 @@
           <a:lstStyle/>
           <a:p>
             <a:pPr>
-              <a:defRPr sz="1200" b="1">
+              <a:defRPr sz="1100" b="1">
                 <a:solidFill>
                   <a:srgbClr val="F59E0B"/>
                 </a:solidFill>
               </a:defRPr>
             </a:pPr>
             <a:r>
-              <a:t>S&amp;P GLOBAL × CRISIL CAMPUS HACKATHON 2026</a:t>
+              <a:t>S&amp;P GLOBAL × CRISIL CAMPUS HACKATHON 2026 // CASE STUDY SUBMISSION</a:t>
             </a:r>
           </a:p>
         </p:txBody>
@@ -3180,8 +3180,8 @@
         </p:nvSpPr>
         <p:spPr>
           <a:xfrm>
-            <a:off x="914400" y="1645920"/>
-            <a:ext cx="10332720" cy="1645920"/>
+            <a:off x="731520" y="1188720"/>
+            <a:ext cx="10698480" cy="1645920"/>
           </a:xfrm>
           <a:prstGeom prst="rect">
             <a:avLst/>
@@ -3195,7 +3195,7 @@
           <a:lstStyle/>
           <a:p>
             <a:pPr>
-              <a:defRPr sz="3200" b="1">
+              <a:defRPr sz="3000" b="1">
                 <a:solidFill>
                   <a:srgbClr val="F2F4F8"/>
                 </a:solidFill>
@@ -3208,30 +3208,296 @@
           <a:p>
             <a:pPr>
               <a:spcBef>
-                <a:spcPts val="1000"/>
+                <a:spcPts val="800"/>
               </a:spcBef>
-              <a:defRPr sz="1500">
+              <a:defRPr sz="1400">
                 <a:solidFill>
                   <a:srgbClr val="38BDF8"/>
                 </a:solidFill>
               </a:defRPr>
             </a:pPr>
             <a:r>
-              <a:t>A Multi-Source Unstructured Text Pipeline Driving Tactical Index Rebalancing &amp; Wholesale Banking Stress Testing</a:t>
-            </a:r>
-          </a:p>
-        </p:txBody>
-      </p:sp>
-      <p:sp>
-        <p:nvSpPr>
-          <p:cNvPr id="5" name="Rounded Rectangle 4"/>
+              <a:t>A Multi-Source Unstructured Text Pipeline Powering Tactical Index Rebalancing &amp; Wholesale Banking Stress Testing</a:t>
+            </a:r>
+          </a:p>
+        </p:txBody>
+      </p:sp>
+      <p:graphicFrame>
+        <p:nvGraphicFramePr>
+          <p:cNvPr id="5" name="Table 4"/>
+          <p:cNvGraphicFramePr>
+            <a:graphicFrameLocks noGrp="1"/>
+          </p:cNvGraphicFramePr>
+          <p:nvPr/>
+        </p:nvGraphicFramePr>
+        <p:xfrm>
+          <a:off x="731520" y="3108960"/>
+          <a:ext cx="10698480" cy="2377440"/>
+        </p:xfrm>
+        <a:graphic>
+          <a:graphicData uri="http://schemas.openxmlformats.org/drawingml/2006/table">
+            <a:tbl>
+              <a:tblPr firstRow="1" bandRow="1">
+                <a:tableStyleId>{5C22544A-7EE6-4342-B048-85BDC9FD1C3A}</a:tableStyleId>
+              </a:tblPr>
+              <a:tblGrid>
+                <a:gridCol w="2926080"/>
+                <a:gridCol w="7772400"/>
+              </a:tblGrid>
+              <a:tr h="475488">
+                <a:tc>
+                  <a:txBody>
+                    <a:bodyPr/>
+                    <a:lstStyle/>
+                    <a:p>
+                      <a:pPr>
+                        <a:defRPr b="1" sz="1100">
+                          <a:solidFill>
+                            <a:srgbClr val="F59E0B"/>
+                          </a:solidFill>
+                        </a:defRPr>
+                      </a:pPr>
+                      <a:r>
+                        <a:t>Candidate Name</a:t>
+                      </a:r>
+                    </a:p>
+                  </a:txBody>
+                  <a:tcPr>
+                    <a:solidFill>
+                      <a:srgbClr val="161A26"/>
+                    </a:solidFill>
+                  </a:tcPr>
+                </a:tc>
+                <a:tc>
+                  <a:txBody>
+                    <a:bodyPr/>
+                    <a:lstStyle/>
+                    <a:p>
+                      <a:pPr>
+                        <a:defRPr sz="1100">
+                          <a:solidFill>
+                            <a:srgbClr val="F2F4F8"/>
+                          </a:solidFill>
+                        </a:defRPr>
+                      </a:pPr>
+                      <a:r>
+                        <a:t>Vedant Dilip Nalge</a:t>
+                      </a:r>
+                    </a:p>
+                  </a:txBody>
+                  <a:tcPr>
+                    <a:solidFill>
+                      <a:srgbClr val="1C2130"/>
+                    </a:solidFill>
+                  </a:tcPr>
+                </a:tc>
+              </a:tr>
+              <a:tr h="475488">
+                <a:tc>
+                  <a:txBody>
+                    <a:bodyPr/>
+                    <a:lstStyle/>
+                    <a:p>
+                      <a:pPr>
+                        <a:defRPr b="1" sz="1100">
+                          <a:solidFill>
+                            <a:srgbClr val="F59E0B"/>
+                          </a:solidFill>
+                        </a:defRPr>
+                      </a:pPr>
+                      <a:r>
+                        <a:t>College / Campus</a:t>
+                      </a:r>
+                    </a:p>
+                  </a:txBody>
+                  <a:tcPr>
+                    <a:solidFill>
+                      <a:srgbClr val="161A26"/>
+                    </a:solidFill>
+                  </a:tcPr>
+                </a:tc>
+                <a:tc>
+                  <a:txBody>
+                    <a:bodyPr/>
+                    <a:lstStyle/>
+                    <a:p>
+                      <a:pPr>
+                        <a:defRPr sz="1100">
+                          <a:solidFill>
+                            <a:srgbClr val="F2F4F8"/>
+                          </a:solidFill>
+                        </a:defRPr>
+                      </a:pPr>
+                      <a:r>
+                        <a:t>Indian Institute of Technology Madras (me22b162@smail.iitm.ac.in)</a:t>
+                      </a:r>
+                    </a:p>
+                  </a:txBody>
+                  <a:tcPr>
+                    <a:solidFill>
+                      <a:srgbClr val="1C2130"/>
+                    </a:solidFill>
+                  </a:tcPr>
+                </a:tc>
+              </a:tr>
+              <a:tr h="475488">
+                <a:tc>
+                  <a:txBody>
+                    <a:bodyPr/>
+                    <a:lstStyle/>
+                    <a:p>
+                      <a:pPr>
+                        <a:defRPr b="1" sz="1100">
+                          <a:solidFill>
+                            <a:srgbClr val="F59E0B"/>
+                          </a:solidFill>
+                        </a:defRPr>
+                      </a:pPr>
+                      <a:r>
+                        <a:t>Target Track</a:t>
+                      </a:r>
+                    </a:p>
+                  </a:txBody>
+                  <a:tcPr>
+                    <a:solidFill>
+                      <a:srgbClr val="161A26"/>
+                    </a:solidFill>
+                  </a:tcPr>
+                </a:tc>
+                <a:tc>
+                  <a:txBody>
+                    <a:bodyPr/>
+                    <a:lstStyle/>
+                    <a:p>
+                      <a:pPr>
+                        <a:defRPr sz="1100">
+                          <a:solidFill>
+                            <a:srgbClr val="F2F4F8"/>
+                          </a:solidFill>
+                        </a:defRPr>
+                      </a:pPr>
+                      <a:r>
+                        <a:t>AI/NLP Financial Risk Engine (FinBERT Continuous Sentiment &amp; 6-Class Taxonomy)</a:t>
+                      </a:r>
+                    </a:p>
+                  </a:txBody>
+                  <a:tcPr>
+                    <a:solidFill>
+                      <a:srgbClr val="1C2130"/>
+                    </a:solidFill>
+                  </a:tcPr>
+                </a:tc>
+              </a:tr>
+              <a:tr h="475488">
+                <a:tc>
+                  <a:txBody>
+                    <a:bodyPr/>
+                    <a:lstStyle/>
+                    <a:p>
+                      <a:pPr>
+                        <a:defRPr b="1" sz="1100">
+                          <a:solidFill>
+                            <a:srgbClr val="F59E0B"/>
+                          </a:solidFill>
+                        </a:defRPr>
+                      </a:pPr>
+                      <a:r>
+                        <a:t>Downstream Implementations</a:t>
+                      </a:r>
+                    </a:p>
+                  </a:txBody>
+                  <a:tcPr>
+                    <a:solidFill>
+                      <a:srgbClr val="161A26"/>
+                    </a:solidFill>
+                  </a:tcPr>
+                </a:tc>
+                <a:tc>
+                  <a:txBody>
+                    <a:bodyPr/>
+                    <a:lstStyle/>
+                    <a:p>
+                      <a:pPr>
+                        <a:defRPr sz="1100">
+                          <a:solidFill>
+                            <a:srgbClr val="F2F4F8"/>
+                          </a:solidFill>
+                        </a:defRPr>
+                      </a:pPr>
+                      <a:r>
+                        <a:t>Simultaneous Delivery: Module A (Tactical Rebalancer) &amp; Module B (Wholesale Stress Tester)</a:t>
+                      </a:r>
+                    </a:p>
+                  </a:txBody>
+                  <a:tcPr>
+                    <a:solidFill>
+                      <a:srgbClr val="1C2130"/>
+                    </a:solidFill>
+                  </a:tcPr>
+                </a:tc>
+              </a:tr>
+              <a:tr h="475488">
+                <a:tc>
+                  <a:txBody>
+                    <a:bodyPr/>
+                    <a:lstStyle/>
+                    <a:p>
+                      <a:pPr>
+                        <a:defRPr b="1" sz="1100">
+                          <a:solidFill>
+                            <a:srgbClr val="F59E0B"/>
+                          </a:solidFill>
+                        </a:defRPr>
+                      </a:pPr>
+                      <a:r>
+                        <a:t>Core Architecture</a:t>
+                      </a:r>
+                    </a:p>
+                  </a:txBody>
+                  <a:tcPr>
+                    <a:solidFill>
+                      <a:srgbClr val="161A26"/>
+                    </a:solidFill>
+                  </a:tcPr>
+                </a:tc>
+                <a:tc>
+                  <a:txBody>
+                    <a:bodyPr/>
+                    <a:lstStyle/>
+                    <a:p>
+                      <a:pPr>
+                        <a:defRPr sz="1100">
+                          <a:solidFill>
+                            <a:srgbClr val="F2F4F8"/>
+                          </a:solidFill>
+                        </a:defRPr>
+                      </a:pPr>
+                      <a:r>
+                        <a:t>FastAPI (Async REST) + SQLite (ACID Persistence) + Tailwind/Chart.js + ReportLab/PyPPTX</a:t>
+                      </a:r>
+                    </a:p>
+                  </a:txBody>
+                  <a:tcPr>
+                    <a:solidFill>
+                      <a:srgbClr val="1C2130"/>
+                    </a:solidFill>
+                  </a:tcPr>
+                </a:tc>
+              </a:tr>
+            </a:tbl>
+          </a:graphicData>
+        </a:graphic>
+      </p:graphicFrame>
+      <p:sp>
+        <p:nvSpPr>
+          <p:cNvPr id="6" name="Rounded Rectangle 5"/>
           <p:cNvSpPr/>
           <p:nvPr/>
         </p:nvSpPr>
         <p:spPr>
           <a:xfrm>
-            <a:off x="914400" y="3931920"/>
-            <a:ext cx="10360152" cy="2011680"/>
+            <a:off x="731520" y="5760720"/>
+            <a:ext cx="2057400" cy="502920"/>
           </a:xfrm>
           <a:prstGeom prst="roundRect">
             <a:avLst/>
@@ -3239,9 +3505,9 @@
           <a:solidFill>
             <a:srgbClr val="161A26"/>
           </a:solidFill>
-          <a:ln w="19050">
+          <a:ln w="12700">
             <a:solidFill>
-              <a:srgbClr val="262B38"/>
+              <a:srgbClr val="38BDF8"/>
             </a:solidFill>
           </a:ln>
         </p:spPr>
@@ -3260,78 +3526,234 @@
           </a:fontRef>
         </p:style>
         <p:txBody>
-          <a:bodyPr rtlCol="0" anchor="ctr" wrap="square" lIns="457200" tIns="274320"/>
+          <a:bodyPr rtlCol="0" anchor="ctr"/>
           <a:lstStyle/>
           <a:p>
             <a:pPr algn="ctr">
-              <a:defRPr sz="1300" b="1">
+              <a:defRPr sz="950" b="1">
+                <a:solidFill>
+                  <a:srgbClr val="38BDF8"/>
+                </a:solidFill>
+              </a:defRPr>
+            </a:pPr>
+            <a:r>
+              <a:t>Sub-25ms Inference</a:t>
+            </a:r>
+          </a:p>
+        </p:txBody>
+      </p:sp>
+      <p:sp>
+        <p:nvSpPr>
+          <p:cNvPr id="7" name="Rounded Rectangle 6"/>
+          <p:cNvSpPr/>
+          <p:nvPr/>
+        </p:nvSpPr>
+        <p:spPr>
+          <a:xfrm>
+            <a:off x="2907791" y="5760720"/>
+            <a:ext cx="2057400" cy="502920"/>
+          </a:xfrm>
+          <a:prstGeom prst="roundRect">
+            <a:avLst/>
+          </a:prstGeom>
+          <a:solidFill>
+            <a:srgbClr val="161A26"/>
+          </a:solidFill>
+          <a:ln w="12700">
+            <a:solidFill>
+              <a:srgbClr val="35C471"/>
+            </a:solidFill>
+          </a:ln>
+        </p:spPr>
+        <p:style>
+          <a:lnRef idx="1">
+            <a:schemeClr val="accent1"/>
+          </a:lnRef>
+          <a:fillRef idx="3">
+            <a:schemeClr val="accent1"/>
+          </a:fillRef>
+          <a:effectRef idx="2">
+            <a:schemeClr val="accent1"/>
+          </a:effectRef>
+          <a:fontRef idx="minor">
+            <a:schemeClr val="lt1"/>
+          </a:fontRef>
+        </p:style>
+        <p:txBody>
+          <a:bodyPr rtlCol="0" anchor="ctr"/>
+          <a:lstStyle/>
+          <a:p>
+            <a:pPr algn="ctr">
+              <a:defRPr sz="950" b="1">
+                <a:solidFill>
+                  <a:srgbClr val="35C471"/>
+                </a:solidFill>
+              </a:defRPr>
+            </a:pPr>
+            <a:r>
+              <a:t>Continuous Sentiment (-1 to +1)</a:t>
+            </a:r>
+          </a:p>
+        </p:txBody>
+      </p:sp>
+      <p:sp>
+        <p:nvSpPr>
+          <p:cNvPr id="8" name="Rounded Rectangle 7"/>
+          <p:cNvSpPr/>
+          <p:nvPr/>
+        </p:nvSpPr>
+        <p:spPr>
+          <a:xfrm>
+            <a:off x="5084064" y="5760720"/>
+            <a:ext cx="2057400" cy="502920"/>
+          </a:xfrm>
+          <a:prstGeom prst="roundRect">
+            <a:avLst/>
+          </a:prstGeom>
+          <a:solidFill>
+            <a:srgbClr val="161A26"/>
+          </a:solidFill>
+          <a:ln w="12700">
+            <a:solidFill>
+              <a:srgbClr val="EF4444"/>
+            </a:solidFill>
+          </a:ln>
+        </p:spPr>
+        <p:style>
+          <a:lnRef idx="1">
+            <a:schemeClr val="accent1"/>
+          </a:lnRef>
+          <a:fillRef idx="3">
+            <a:schemeClr val="accent1"/>
+          </a:fillRef>
+          <a:effectRef idx="2">
+            <a:schemeClr val="accent1"/>
+          </a:effectRef>
+          <a:fontRef idx="minor">
+            <a:schemeClr val="lt1"/>
+          </a:fontRef>
+        </p:style>
+        <p:txBody>
+          <a:bodyPr rtlCol="0" anchor="ctr"/>
+          <a:lstStyle/>
+          <a:p>
+            <a:pPr algn="ctr">
+              <a:defRPr sz="950" b="1">
+                <a:solidFill>
+                  <a:srgbClr val="EF4444"/>
+                </a:solidFill>
+              </a:defRPr>
+            </a:pPr>
+            <a:r>
+              <a:t>Basel III $1.0B Credit Book</a:t>
+            </a:r>
+          </a:p>
+        </p:txBody>
+      </p:sp>
+      <p:sp>
+        <p:nvSpPr>
+          <p:cNvPr id="9" name="Rounded Rectangle 8"/>
+          <p:cNvSpPr/>
+          <p:nvPr/>
+        </p:nvSpPr>
+        <p:spPr>
+          <a:xfrm>
+            <a:off x="7260336" y="5760720"/>
+            <a:ext cx="2057400" cy="502920"/>
+          </a:xfrm>
+          <a:prstGeom prst="roundRect">
+            <a:avLst/>
+          </a:prstGeom>
+          <a:solidFill>
+            <a:srgbClr val="161A26"/>
+          </a:solidFill>
+          <a:ln w="12700">
+            <a:solidFill>
+              <a:srgbClr val="F59E0B"/>
+            </a:solidFill>
+          </a:ln>
+        </p:spPr>
+        <p:style>
+          <a:lnRef idx="1">
+            <a:schemeClr val="accent1"/>
+          </a:lnRef>
+          <a:fillRef idx="3">
+            <a:schemeClr val="accent1"/>
+          </a:fillRef>
+          <a:effectRef idx="2">
+            <a:schemeClr val="accent1"/>
+          </a:effectRef>
+          <a:fontRef idx="minor">
+            <a:schemeClr val="lt1"/>
+          </a:fontRef>
+        </p:style>
+        <p:txBody>
+          <a:bodyPr rtlCol="0" anchor="ctr"/>
+          <a:lstStyle/>
+          <a:p>
+            <a:pPr algn="ctr">
+              <a:defRPr sz="950" b="1">
                 <a:solidFill>
                   <a:srgbClr val="F59E0B"/>
                 </a:solidFill>
               </a:defRPr>
             </a:pPr>
             <a:r>
-              <a:t>Candidate Details &amp; Project Scope</a:t>
-            </a:r>
-          </a:p>
-          <a:p>
-            <a:pPr>
-              <a:spcBef>
-                <a:spcPts val="500"/>
-              </a:spcBef>
-              <a:defRPr sz="1100">
+              <a:t>Dynamic Rebalancing (+34.2 bps)</a:t>
+            </a:r>
+          </a:p>
+        </p:txBody>
+      </p:sp>
+      <p:sp>
+        <p:nvSpPr>
+          <p:cNvPr id="10" name="Rounded Rectangle 9"/>
+          <p:cNvSpPr/>
+          <p:nvPr/>
+        </p:nvSpPr>
+        <p:spPr>
+          <a:xfrm>
+            <a:off x="9436608" y="5760720"/>
+            <a:ext cx="2057400" cy="502920"/>
+          </a:xfrm>
+          <a:prstGeom prst="roundRect">
+            <a:avLst/>
+          </a:prstGeom>
+          <a:solidFill>
+            <a:srgbClr val="161A26"/>
+          </a:solidFill>
+          <a:ln w="12700">
+            <a:solidFill>
+              <a:srgbClr val="F2F4F8"/>
+            </a:solidFill>
+          </a:ln>
+        </p:spPr>
+        <p:style>
+          <a:lnRef idx="1">
+            <a:schemeClr val="accent1"/>
+          </a:lnRef>
+          <a:fillRef idx="3">
+            <a:schemeClr val="accent1"/>
+          </a:fillRef>
+          <a:effectRef idx="2">
+            <a:schemeClr val="accent1"/>
+          </a:effectRef>
+          <a:fontRef idx="minor">
+            <a:schemeClr val="lt1"/>
+          </a:fontRef>
+        </p:style>
+        <p:txBody>
+          <a:bodyPr rtlCol="0" anchor="ctr"/>
+          <a:lstStyle/>
+          <a:p>
+            <a:pPr algn="ctr">
+              <a:defRPr sz="950" b="1">
                 <a:solidFill>
                   <a:srgbClr val="F2F4F8"/>
                 </a:solidFill>
               </a:defRPr>
             </a:pPr>
             <a:r>
-              <a:t>•  Candidate Name:  Vedant Dilip Nalge</a:t>
-            </a:r>
-          </a:p>
-          <a:p>
-            <a:pPr>
-              <a:spcBef>
-                <a:spcPts val="500"/>
-              </a:spcBef>
-              <a:defRPr sz="1100">
-                <a:solidFill>
-                  <a:srgbClr val="F2F4F8"/>
-                </a:solidFill>
-              </a:defRPr>
-            </a:pPr>
-            <a:r>
-              <a:t>•  College / Campus:  Indian Institute of Technology Madras (me22b162@smail.iitm.ac.in)</a:t>
-            </a:r>
-          </a:p>
-          <a:p>
-            <a:pPr>
-              <a:spcBef>
-                <a:spcPts val="500"/>
-              </a:spcBef>
-              <a:defRPr sz="1100">
-                <a:solidFill>
-                  <a:srgbClr val="F2F4F8"/>
-                </a:solidFill>
-              </a:defRPr>
-            </a:pPr>
-            <a:r>
-              <a:t>•  Target Track:  AI/NLP Risk Engine (Sub-25ms FinBERT Continuous Scoring &amp; 6-Taxonomy Classifier)</a:t>
-            </a:r>
-          </a:p>
-          <a:p>
-            <a:pPr>
-              <a:spcBef>
-                <a:spcPts val="500"/>
-              </a:spcBef>
-              <a:defRPr sz="1100">
-                <a:solidFill>
-                  <a:srgbClr val="F2F4F8"/>
-                </a:solidFill>
-              </a:defRPr>
-            </a:pPr>
-            <a:r>
-              <a:t>•  Downstream Modules:  Both Module A (Tactical Index Rebalancer) &amp; Module B (Wholesale Portfolio Stress Tester)</a:t>
+              <a:t>ISTC Obsidian Dark UI</a:t>
             </a:r>
           </a:p>
         </p:txBody>
@@ -3405,8 +3827,8 @@
         </p:nvSpPr>
         <p:spPr>
           <a:xfrm>
-            <a:off x="731520" y="457200"/>
-            <a:ext cx="10515600" cy="365760"/>
+            <a:off x="731520" y="365760"/>
+            <a:ext cx="10698480" cy="320040"/>
           </a:xfrm>
           <a:prstGeom prst="rect">
             <a:avLst/>
@@ -3441,8 +3863,8 @@
         </p:nvSpPr>
         <p:spPr>
           <a:xfrm>
-            <a:off x="731520" y="777240"/>
-            <a:ext cx="10515600" cy="731520"/>
+            <a:off x="731520" y="685800"/>
+            <a:ext cx="10698480" cy="640080"/>
           </a:xfrm>
           <a:prstGeom prst="rect">
             <a:avLst/>
@@ -3456,7 +3878,7 @@
           <a:lstStyle/>
           <a:p>
             <a:pPr>
-              <a:defRPr sz="2400" b="1">
+              <a:defRPr sz="2200" b="1">
                 <a:solidFill>
                   <a:srgbClr val="F2F4F8"/>
                 </a:solidFill>
@@ -3477,8 +3899,8 @@
         </p:nvSpPr>
         <p:spPr>
           <a:xfrm>
-            <a:off x="731520" y="1645920"/>
-            <a:ext cx="5120640" cy="4572000"/>
+            <a:off x="731520" y="1463040"/>
+            <a:ext cx="5212080" cy="4754880"/>
           </a:xfrm>
           <a:prstGeom prst="roundRect">
             <a:avLst/>
@@ -3486,7 +3908,7 @@
           <a:solidFill>
             <a:srgbClr val="161A26"/>
           </a:solidFill>
-          <a:ln>
+          <a:ln w="19050">
             <a:solidFill>
               <a:srgbClr val="EF4444"/>
             </a:solidFill>
@@ -3507,63 +3929,108 @@
           </a:fontRef>
         </p:style>
         <p:txBody>
-          <a:bodyPr rtlCol="0" anchor="ctr" lIns="365760" tIns="365760" wrap="square"/>
+          <a:bodyPr rtlCol="0" anchor="ctr" lIns="320040" tIns="320040" wrap="square"/>
           <a:lstStyle/>
           <a:p>
             <a:pPr algn="ctr">
-              <a:defRPr sz="1600" b="1">
+              <a:defRPr sz="1500" b="1">
                 <a:solidFill>
                   <a:srgbClr val="EF4444"/>
                 </a:solidFill>
               </a:defRPr>
             </a:pPr>
             <a:r>
-              <a:t>The Business Problem</a:t>
+              <a:t>The Financial Industry Problem</a:t>
             </a:r>
           </a:p>
           <a:p>
             <a:pPr>
               <a:spcBef>
-                <a:spcPts val="1400"/>
+                <a:spcPts val="1200"/>
               </a:spcBef>
-              <a:defRPr sz="1100">
-                <a:solidFill>
-                  <a:srgbClr val="F2F4F8"/>
+              <a:defRPr b="1" sz="1100">
+                <a:solidFill>
+                  <a:srgbClr val="F59E0B"/>
                 </a:solidFill>
               </a:defRPr>
             </a:pPr>
             <a:r>
-              <a:t>•  Lagged Disclosure Blind Spots: Traditional risk models rely predominantly on quarterly financial reports and delayed credit rating agency updates.</a:t>
+              <a:t>•  Lagged Quantitative Disclosures:</a:t>
             </a:r>
           </a:p>
           <a:p>
             <a:pPr>
               <a:spcBef>
-                <a:spcPts val="1400"/>
+                <a:spcPts val="300"/>
               </a:spcBef>
-              <a:defRPr sz="1100">
+              <a:defRPr sz="1000">
                 <a:solidFill>
                   <a:srgbClr val="F2F4F8"/>
                 </a:solidFill>
               </a:defRPr>
             </a:pPr>
             <a:r>
-              <a:t>•  Unstructured Narrative Overload: Financial institutions process millions of qualitative headlines, earnings wires, and retail social posts without automated quantification.</a:t>
+              <a:t>Traditional institutional risk engines rely on quarterly 10-K/10-Q reports and delayed credit rating revisions, leaving books exposed to rapid sentiment-driven contagion.</a:t>
             </a:r>
           </a:p>
           <a:p>
             <a:pPr>
               <a:spcBef>
-                <a:spcPts val="1400"/>
+                <a:spcPts val="1200"/>
               </a:spcBef>
-              <a:defRPr sz="1100">
+              <a:defRPr b="1" sz="1100">
+                <a:solidFill>
+                  <a:srgbClr val="F59E0B"/>
+                </a:solidFill>
+              </a:defRPr>
+            </a:pPr>
+            <a:r>
+              <a:t>•  Unstructured Text Deluge:</a:t>
+            </a:r>
+          </a:p>
+          <a:p>
+            <a:pPr>
+              <a:spcBef>
+                <a:spcPts val="300"/>
+              </a:spcBef>
+              <a:defRPr sz="1000">
                 <a:solidFill>
                   <a:srgbClr val="F2F4F8"/>
                 </a:solidFill>
               </a:defRPr>
             </a:pPr>
             <a:r>
-              <a:t>•  Disconnected Decision Silos: Qualitative research rarely flows synchronously into both asset allocation desks and wholesale balance sheet stress testing desks.</a:t>
+              <a:t>Asset managers and risk officers process millions of news wires, press releases, and retail messages daily without automated, machine-readable quantification.</a:t>
+            </a:r>
+          </a:p>
+          <a:p>
+            <a:pPr>
+              <a:spcBef>
+                <a:spcPts val="1200"/>
+              </a:spcBef>
+              <a:defRPr b="1" sz="1100">
+                <a:solidFill>
+                  <a:srgbClr val="F59E0B"/>
+                </a:solidFill>
+              </a:defRPr>
+            </a:pPr>
+            <a:r>
+              <a:t>•  Fragmented Decision Silos:</a:t>
+            </a:r>
+          </a:p>
+          <a:p>
+            <a:pPr>
+              <a:spcBef>
+                <a:spcPts val="300"/>
+              </a:spcBef>
+              <a:defRPr sz="1000">
+                <a:solidFill>
+                  <a:srgbClr val="F2F4F8"/>
+                </a:solidFill>
+              </a:defRPr>
+            </a:pPr>
+            <a:r>
+              <a:t>Market risk (tactical equity managers) and credit risk (wholesale banking CROs) operate on separate systems, preventing unified cross-asset crisis management.</a:t>
             </a:r>
           </a:p>
         </p:txBody>
@@ -3576,8 +4043,8 @@
         </p:nvSpPr>
         <p:spPr>
           <a:xfrm>
-            <a:off x="6217920" y="1645920"/>
-            <a:ext cx="5120640" cy="4572000"/>
+            <a:off x="6217920" y="1463040"/>
+            <a:ext cx="5212080" cy="4754880"/>
           </a:xfrm>
           <a:prstGeom prst="roundRect">
             <a:avLst/>
@@ -3585,7 +4052,7 @@
           <a:solidFill>
             <a:srgbClr val="161A26"/>
           </a:solidFill>
-          <a:ln>
+          <a:ln w="19050">
             <a:solidFill>
               <a:srgbClr val="35C471"/>
             </a:solidFill>
@@ -3606,63 +4073,108 @@
           </a:fontRef>
         </p:style>
         <p:txBody>
-          <a:bodyPr rtlCol="0" anchor="ctr" lIns="365760" tIns="365760" wrap="square"/>
+          <a:bodyPr rtlCol="0" anchor="ctr" lIns="320040" tIns="320040" wrap="square"/>
           <a:lstStyle/>
           <a:p>
             <a:pPr algn="ctr">
-              <a:defRPr sz="1600" b="1">
+              <a:defRPr sz="1500" b="1">
                 <a:solidFill>
                   <a:srgbClr val="35C471"/>
                 </a:solidFill>
               </a:defRPr>
             </a:pPr>
             <a:r>
-              <a:t>Our Solution Approach</a:t>
+              <a:t>Our AI/NLP Solution Approach</a:t>
             </a:r>
           </a:p>
           <a:p>
             <a:pPr>
               <a:spcBef>
-                <a:spcPts val="1400"/>
+                <a:spcPts val="1200"/>
               </a:spcBef>
-              <a:defRPr sz="1100">
-                <a:solidFill>
-                  <a:srgbClr val="F2F4F8"/>
+              <a:defRPr b="1" sz="1100">
+                <a:solidFill>
+                  <a:srgbClr val="38BDF8"/>
                 </a:solidFill>
               </a:defRPr>
             </a:pPr>
             <a:r>
-              <a:t>•  Real-Time Telemetry Pipeline: Continuous zero-cost streaming from Yahoo Finance RSS, ticker news, and public StockTwits social sentiment streams.</a:t>
+              <a:t>•  Continuous Multi-Source Ingestion:</a:t>
             </a:r>
           </a:p>
           <a:p>
             <a:pPr>
               <a:spcBef>
-                <a:spcPts val="1400"/>
+                <a:spcPts val="300"/>
               </a:spcBef>
-              <a:defRPr sz="1100">
+              <a:defRPr sz="1000">
                 <a:solidFill>
                   <a:srgbClr val="F2F4F8"/>
                 </a:solidFill>
               </a:defRPr>
             </a:pPr>
             <a:r>
-              <a:t>•  Tri-Factor Risk Signal Engine: Calibrated continuous Sentiment (-1.0 to +1.0), 6-class Financial Event Taxonomy, and Severity Impact (1 to 10).</a:t>
+              <a:t>Streams live financial news (Yahoo Finance RSS) and high-velocity retail sentiment (StockTwits API) with sub-25ms end-to-end processing.</a:t>
             </a:r>
           </a:p>
           <a:p>
             <a:pPr>
               <a:spcBef>
-                <a:spcPts val="1400"/>
+                <a:spcPts val="1200"/>
               </a:spcBef>
-              <a:defRPr sz="1100">
+              <a:defRPr b="1" sz="1100">
+                <a:solidFill>
+                  <a:srgbClr val="38BDF8"/>
+                </a:solidFill>
+              </a:defRPr>
+            </a:pPr>
+            <a:r>
+              <a:t>•  Tri-Factor Risk Telemetry:</a:t>
+            </a:r>
+          </a:p>
+          <a:p>
+            <a:pPr>
+              <a:spcBef>
+                <a:spcPts val="300"/>
+              </a:spcBef>
+              <a:defRPr sz="1000">
                 <a:solidFill>
                   <a:srgbClr val="F2F4F8"/>
                 </a:solidFill>
               </a:defRPr>
             </a:pPr>
             <a:r>
-              <a:t>•  Synchronous Dual Downstream Feeding: Directly drives real-time stock index rebalancing (Module A) while perturbing multi-factor shocks onto a $1.0B wholesale credit book (Module B).</a:t>
+              <a:t>Converts unstructured text into 3 calibrated signals: continuous Sentiment (-1.0 to +1.0), 6-class Financial Taxonomy, and Impact Severity (1 to 10).</a:t>
+            </a:r>
+          </a:p>
+          <a:p>
+            <a:pPr>
+              <a:spcBef>
+                <a:spcPts val="1200"/>
+              </a:spcBef>
+              <a:defRPr b="1" sz="1100">
+                <a:solidFill>
+                  <a:srgbClr val="38BDF8"/>
+                </a:solidFill>
+              </a:defRPr>
+            </a:pPr>
+            <a:r>
+              <a:t>•  Synchronous Dual Downstream Feeding:</a:t>
+            </a:r>
+          </a:p>
+          <a:p>
+            <a:pPr>
+              <a:spcBef>
+                <a:spcPts val="300"/>
+              </a:spcBef>
+              <a:defRPr sz="1000">
+                <a:solidFill>
+                  <a:srgbClr val="F2F4F8"/>
+                </a:solidFill>
+              </a:defRPr>
+            </a:pPr>
+            <a:r>
+              <a:t>Directly drives Module A (Tactical Index Rebalancer with 1%-18% bounds) and Module B (Wholesale Banking Stress Tester across $1.0B book) simultaneously.</a:t>
             </a:r>
           </a:p>
         </p:txBody>
@@ -3736,8 +4248,8 @@
         </p:nvSpPr>
         <p:spPr>
           <a:xfrm>
-            <a:off x="731520" y="457200"/>
-            <a:ext cx="10515600" cy="365760"/>
+            <a:off x="731520" y="365760"/>
+            <a:ext cx="10698480" cy="320040"/>
           </a:xfrm>
           <a:prstGeom prst="rect">
             <a:avLst/>
@@ -3772,8 +4284,8 @@
         </p:nvSpPr>
         <p:spPr>
           <a:xfrm>
-            <a:off x="731520" y="777240"/>
-            <a:ext cx="10515600" cy="731520"/>
+            <a:off x="731520" y="685800"/>
+            <a:ext cx="10698480" cy="640080"/>
           </a:xfrm>
           <a:prstGeom prst="rect">
             <a:avLst/>
@@ -3787,7 +4299,7 @@
           <a:lstStyle/>
           <a:p>
             <a:pPr>
-              <a:defRPr sz="2400" b="1">
+              <a:defRPr sz="2200" b="1">
                 <a:solidFill>
                   <a:srgbClr val="F2F4F8"/>
                 </a:solidFill>
@@ -3800,426 +4312,296 @@
           </a:p>
         </p:txBody>
       </p:sp>
-      <p:sp>
-        <p:nvSpPr>
-          <p:cNvPr id="5" name="Rounded Rectangle 4"/>
-          <p:cNvSpPr/>
+      <p:pic>
+        <p:nvPicPr>
+          <p:cNvPr id="5" name="Picture 4" descr="architecture.png"/>
+          <p:cNvPicPr>
+            <a:picLocks noChangeAspect="1"/>
+          </p:cNvPicPr>
           <p:nvPr/>
-        </p:nvSpPr>
+        </p:nvPicPr>
+        <p:blipFill>
+          <a:blip r:embed="rId2"/>
+          <a:stretch>
+            <a:fillRect/>
+          </a:stretch>
+        </p:blipFill>
         <p:spPr>
           <a:xfrm>
-            <a:off x="731520" y="1828800"/>
-            <a:ext cx="2011680" cy="4389120"/>
+            <a:off x="731520" y="1463040"/>
+            <a:ext cx="6217920" cy="4754880"/>
           </a:xfrm>
-          <a:prstGeom prst="roundRect">
+          <a:prstGeom prst="rect">
             <a:avLst/>
           </a:prstGeom>
-          <a:solidFill>
-            <a:srgbClr val="161A26"/>
-          </a:solidFill>
-          <a:ln w="19050">
-            <a:solidFill>
-              <a:srgbClr val="38BDF8"/>
-            </a:solidFill>
-          </a:ln>
         </p:spPr>
-        <p:style>
-          <a:lnRef idx="1">
-            <a:schemeClr val="accent1"/>
-          </a:lnRef>
-          <a:fillRef idx="3">
-            <a:schemeClr val="accent1"/>
-          </a:fillRef>
-          <a:effectRef idx="2">
-            <a:schemeClr val="accent1"/>
-          </a:effectRef>
-          <a:fontRef idx="minor">
-            <a:schemeClr val="lt1"/>
-          </a:fontRef>
-        </p:style>
-        <p:txBody>
-          <a:bodyPr rtlCol="0" anchor="ctr" lIns="182880" tIns="274320" wrap="square"/>
-          <a:lstStyle/>
-          <a:p>
-            <a:pPr algn="ctr">
-              <a:defRPr sz="1200" b="1">
-                <a:solidFill>
-                  <a:srgbClr val="38BDF8"/>
-                </a:solidFill>
-              </a:defRPr>
-            </a:pPr>
-            <a:r>
-              <a:t>1. INGESTION</a:t>
-            </a:r>
-          </a:p>
-          <a:p>
-            <a:pPr>
-              <a:spcBef>
-                <a:spcPts val="800"/>
-              </a:spcBef>
-              <a:defRPr sz="1000" b="1">
-                <a:solidFill>
-                  <a:srgbClr val="F2F4F8"/>
-                </a:solidFill>
-              </a:defRPr>
-            </a:pPr>
-            <a:r>
-              <a:t>Yahoo RSS + StockTwits + Crisis Replayer</a:t>
-            </a:r>
-          </a:p>
-          <a:p>
-            <a:pPr>
-              <a:spcBef>
-                <a:spcPts val="1000"/>
-              </a:spcBef>
-              <a:defRPr sz="950">
-                <a:solidFill>
-                  <a:srgbClr val="94A3B8"/>
-                </a:solidFill>
-              </a:defRPr>
-            </a:pPr>
-            <a:r>
-              <a:t>Live financial headlines, social sentiment streams, and deterministic historical templates.</a:t>
-            </a:r>
-          </a:p>
-        </p:txBody>
-      </p:sp>
-      <p:sp>
-        <p:nvSpPr>
-          <p:cNvPr id="6" name="Rounded Rectangle 5"/>
-          <p:cNvSpPr/>
+      </p:pic>
+      <p:graphicFrame>
+        <p:nvGraphicFramePr>
+          <p:cNvPr id="6" name="Table 5"/>
+          <p:cNvGraphicFramePr>
+            <a:graphicFrameLocks noGrp="1"/>
+          </p:cNvGraphicFramePr>
           <p:nvPr/>
-        </p:nvSpPr>
-        <p:spPr>
-          <a:xfrm>
-            <a:off x="2926080" y="1828800"/>
-            <a:ext cx="2011680" cy="4389120"/>
-          </a:xfrm>
-          <a:prstGeom prst="roundRect">
-            <a:avLst/>
-          </a:prstGeom>
-          <a:solidFill>
-            <a:srgbClr val="161A26"/>
-          </a:solidFill>
-          <a:ln w="19050">
-            <a:solidFill>
-              <a:srgbClr val="F59E0B"/>
-            </a:solidFill>
-          </a:ln>
-        </p:spPr>
-        <p:style>
-          <a:lnRef idx="1">
-            <a:schemeClr val="accent1"/>
-          </a:lnRef>
-          <a:fillRef idx="3">
-            <a:schemeClr val="accent1"/>
-          </a:fillRef>
-          <a:effectRef idx="2">
-            <a:schemeClr val="accent1"/>
-          </a:effectRef>
-          <a:fontRef idx="minor">
-            <a:schemeClr val="lt1"/>
-          </a:fontRef>
-        </p:style>
-        <p:txBody>
-          <a:bodyPr rtlCol="0" anchor="ctr" lIns="182880" tIns="274320" wrap="square"/>
-          <a:lstStyle/>
-          <a:p>
-            <a:pPr algn="ctr">
-              <a:defRPr sz="1200" b="1">
-                <a:solidFill>
-                  <a:srgbClr val="F59E0B"/>
-                </a:solidFill>
-              </a:defRPr>
-            </a:pPr>
-            <a:r>
-              <a:t>2. NLP ENGINE</a:t>
-            </a:r>
-          </a:p>
-          <a:p>
-            <a:pPr>
-              <a:spcBef>
-                <a:spcPts val="800"/>
-              </a:spcBef>
-              <a:defRPr sz="1000" b="1">
-                <a:solidFill>
-                  <a:srgbClr val="F2F4F8"/>
-                </a:solidFill>
-              </a:defRPr>
-            </a:pPr>
-            <a:r>
-              <a:t>FinBERT + Loughran Scorer + NER</a:t>
-            </a:r>
-          </a:p>
-          <a:p>
-            <a:pPr>
-              <a:spcBef>
-                <a:spcPts val="1000"/>
-              </a:spcBef>
-              <a:defRPr sz="950">
-                <a:solidFill>
-                  <a:srgbClr val="94A3B8"/>
-                </a:solidFill>
-              </a:defRPr>
-            </a:pPr>
-            <a:r>
-              <a:t>Continuous sentiment (-1 to +1), 6-class classification, severity scoring (1 to 10).</a:t>
-            </a:r>
-          </a:p>
-        </p:txBody>
-      </p:sp>
-      <p:sp>
-        <p:nvSpPr>
-          <p:cNvPr id="7" name="Rounded Rectangle 6"/>
-          <p:cNvSpPr/>
-          <p:nvPr/>
-        </p:nvSpPr>
-        <p:spPr>
-          <a:xfrm>
-            <a:off x="5120640" y="1828800"/>
-            <a:ext cx="2011680" cy="4389120"/>
-          </a:xfrm>
-          <a:prstGeom prst="roundRect">
-            <a:avLst/>
-          </a:prstGeom>
-          <a:solidFill>
-            <a:srgbClr val="161A26"/>
-          </a:solidFill>
-          <a:ln w="19050">
-            <a:solidFill>
-              <a:srgbClr val="F2F4F8"/>
-            </a:solidFill>
-          </a:ln>
-        </p:spPr>
-        <p:style>
-          <a:lnRef idx="1">
-            <a:schemeClr val="accent1"/>
-          </a:lnRef>
-          <a:fillRef idx="3">
-            <a:schemeClr val="accent1"/>
-          </a:fillRef>
-          <a:effectRef idx="2">
-            <a:schemeClr val="accent1"/>
-          </a:effectRef>
-          <a:fontRef idx="minor">
-            <a:schemeClr val="lt1"/>
-          </a:fontRef>
-        </p:style>
-        <p:txBody>
-          <a:bodyPr rtlCol="0" anchor="ctr" lIns="182880" tIns="274320" wrap="square"/>
-          <a:lstStyle/>
-          <a:p>
-            <a:pPr algn="ctr">
-              <a:defRPr sz="1200" b="1">
-                <a:solidFill>
-                  <a:srgbClr val="F2F4F8"/>
-                </a:solidFill>
-              </a:defRPr>
-            </a:pPr>
-            <a:r>
-              <a:t>3. REST API &amp; DB</a:t>
-            </a:r>
-          </a:p>
-          <a:p>
-            <a:pPr>
-              <a:spcBef>
-                <a:spcPts val="800"/>
-              </a:spcBef>
-              <a:defRPr sz="1000" b="1">
-                <a:solidFill>
-                  <a:srgbClr val="F2F4F8"/>
-                </a:solidFill>
-              </a:defRPr>
-            </a:pPr>
-            <a:r>
-              <a:t>FastAPI + SQLite + JWT Security</a:t>
-            </a:r>
-          </a:p>
-          <a:p>
-            <a:pPr>
-              <a:spcBef>
-                <a:spcPts val="1000"/>
-              </a:spcBef>
-              <a:defRPr sz="950">
-                <a:solidFill>
-                  <a:srgbClr val="94A3B8"/>
-                </a:solidFill>
-              </a:defRPr>
-            </a:pPr>
-            <a:r>
-              <a:t>ACID database persistence, signal audit ledger, PBKDF2 role-based authorization.</a:t>
-            </a:r>
-          </a:p>
-        </p:txBody>
-      </p:sp>
-      <p:sp>
-        <p:nvSpPr>
-          <p:cNvPr id="8" name="Rounded Rectangle 7"/>
-          <p:cNvSpPr/>
-          <p:nvPr/>
-        </p:nvSpPr>
-        <p:spPr>
-          <a:xfrm>
-            <a:off x="7315199" y="1828800"/>
-            <a:ext cx="2011680" cy="4389120"/>
-          </a:xfrm>
-          <a:prstGeom prst="roundRect">
-            <a:avLst/>
-          </a:prstGeom>
-          <a:solidFill>
-            <a:srgbClr val="161A26"/>
-          </a:solidFill>
-          <a:ln w="19050">
-            <a:solidFill>
-              <a:srgbClr val="35C471"/>
-            </a:solidFill>
-          </a:ln>
-        </p:spPr>
-        <p:style>
-          <a:lnRef idx="1">
-            <a:schemeClr val="accent1"/>
-          </a:lnRef>
-          <a:fillRef idx="3">
-            <a:schemeClr val="accent1"/>
-          </a:fillRef>
-          <a:effectRef idx="2">
-            <a:schemeClr val="accent1"/>
-          </a:effectRef>
-          <a:fontRef idx="minor">
-            <a:schemeClr val="lt1"/>
-          </a:fontRef>
-        </p:style>
-        <p:txBody>
-          <a:bodyPr rtlCol="0" anchor="ctr" lIns="182880" tIns="274320" wrap="square"/>
-          <a:lstStyle/>
-          <a:p>
-            <a:pPr algn="ctr">
-              <a:defRPr sz="1200" b="1">
-                <a:solidFill>
-                  <a:srgbClr val="35C471"/>
-                </a:solidFill>
-              </a:defRPr>
-            </a:pPr>
-            <a:r>
-              <a:t>4. MODULE A</a:t>
-            </a:r>
-          </a:p>
-          <a:p>
-            <a:pPr>
-              <a:spcBef>
-                <a:spcPts val="800"/>
-              </a:spcBef>
-              <a:defRPr sz="1000" b="1">
-                <a:solidFill>
-                  <a:srgbClr val="F2F4F8"/>
-                </a:solidFill>
-              </a:defRPr>
-            </a:pPr>
-            <a:r>
-              <a:t>Tactical Index Rebalancer</a:t>
-            </a:r>
-          </a:p>
-          <a:p>
-            <a:pPr>
-              <a:spcBef>
-                <a:spcPts val="1000"/>
-              </a:spcBef>
-              <a:defRPr sz="950">
-                <a:solidFill>
-                  <a:srgbClr val="94A3B8"/>
-                </a:solidFill>
-              </a:defRPr>
-            </a:pPr>
-            <a:r>
-              <a:t>Quadratic sentiment optimization across 15 blue-chips, 1%-18% regulatory limits.</a:t>
-            </a:r>
-          </a:p>
-        </p:txBody>
-      </p:sp>
-      <p:sp>
-        <p:nvSpPr>
-          <p:cNvPr id="9" name="Rounded Rectangle 8"/>
-          <p:cNvSpPr/>
-          <p:nvPr/>
-        </p:nvSpPr>
-        <p:spPr>
-          <a:xfrm>
-            <a:off x="9509760" y="1828800"/>
-            <a:ext cx="2011680" cy="4389120"/>
-          </a:xfrm>
-          <a:prstGeom prst="roundRect">
-            <a:avLst/>
-          </a:prstGeom>
-          <a:solidFill>
-            <a:srgbClr val="161A26"/>
-          </a:solidFill>
-          <a:ln w="19050">
-            <a:solidFill>
-              <a:srgbClr val="EF4444"/>
-            </a:solidFill>
-          </a:ln>
-        </p:spPr>
-        <p:style>
-          <a:lnRef idx="1">
-            <a:schemeClr val="accent1"/>
-          </a:lnRef>
-          <a:fillRef idx="3">
-            <a:schemeClr val="accent1"/>
-          </a:fillRef>
-          <a:effectRef idx="2">
-            <a:schemeClr val="accent1"/>
-          </a:effectRef>
-          <a:fontRef idx="minor">
-            <a:schemeClr val="lt1"/>
-          </a:fontRef>
-        </p:style>
-        <p:txBody>
-          <a:bodyPr rtlCol="0" anchor="ctr" lIns="182880" tIns="274320" wrap="square"/>
-          <a:lstStyle/>
-          <a:p>
-            <a:pPr algn="ctr">
-              <a:defRPr sz="1200" b="1">
-                <a:solidFill>
-                  <a:srgbClr val="EF4444"/>
-                </a:solidFill>
-              </a:defRPr>
-            </a:pPr>
-            <a:r>
-              <a:t>5. MODULE B</a:t>
-            </a:r>
-          </a:p>
-          <a:p>
-            <a:pPr>
-              <a:spcBef>
-                <a:spcPts val="800"/>
-              </a:spcBef>
-              <a:defRPr sz="1000" b="1">
-                <a:solidFill>
-                  <a:srgbClr val="F2F4F8"/>
-                </a:solidFill>
-              </a:defRPr>
-            </a:pPr>
-            <a:r>
-              <a:t>Wholesale Stress Tester ($1.0B)</a:t>
-            </a:r>
-          </a:p>
-          <a:p>
-            <a:pPr>
-              <a:spcBef>
-                <a:spcPts val="1000"/>
-              </a:spcBef>
-              <a:defRPr sz="950">
-                <a:solidFill>
-                  <a:srgbClr val="94A3B8"/>
-                </a:solidFill>
-              </a:defRPr>
-            </a:pPr>
-            <a:r>
-              <a:t>Basel III Expected Loss on loans, duration-convexity on bonds, waterfall degradation.</a:t>
-            </a:r>
-          </a:p>
-        </p:txBody>
-      </p:sp>
+        </p:nvGraphicFramePr>
+        <p:xfrm>
+          <a:off x="7132320" y="1463040"/>
+          <a:ext cx="4297680" cy="4754880"/>
+        </p:xfrm>
+        <a:graphic>
+          <a:graphicData uri="http://schemas.openxmlformats.org/drawingml/2006/table">
+            <a:tbl>
+              <a:tblPr firstRow="1" bandRow="1">
+                <a:tableStyleId>{5C22544A-7EE6-4342-B048-85BDC9FD1C3A}</a:tableStyleId>
+              </a:tblPr>
+              <a:tblGrid>
+                <a:gridCol w="1371600"/>
+                <a:gridCol w="2926080"/>
+              </a:tblGrid>
+              <a:tr h="950976">
+                <a:tc>
+                  <a:txBody>
+                    <a:bodyPr/>
+                    <a:lstStyle/>
+                    <a:p>
+                      <a:pPr>
+                        <a:defRPr b="1" sz="1050">
+                          <a:solidFill>
+                            <a:srgbClr val="F59E0B"/>
+                          </a:solidFill>
+                        </a:defRPr>
+                      </a:pPr>
+                      <a:r>
+                        <a:t>1. Ingestion</a:t>
+                      </a:r>
+                    </a:p>
+                  </a:txBody>
+                  <a:tcPr>
+                    <a:solidFill>
+                      <a:srgbClr val="161A26"/>
+                    </a:solidFill>
+                  </a:tcPr>
+                </a:tc>
+                <a:tc>
+                  <a:txBody>
+                    <a:bodyPr/>
+                    <a:lstStyle/>
+                    <a:p>
+                      <a:pPr>
+                        <a:defRPr sz="950">
+                          <a:solidFill>
+                            <a:srgbClr val="F2F4F8"/>
+                          </a:solidFill>
+                        </a:defRPr>
+                      </a:pPr>
+                      <a:r>
+                        <a:t>Yahoo RSS + StockTwits REST + 6 Curated Historical Crisis Replayers for deterministic jury review.</a:t>
+                      </a:r>
+                    </a:p>
+                  </a:txBody>
+                  <a:tcPr>
+                    <a:solidFill>
+                      <a:srgbClr val="1C2130"/>
+                    </a:solidFill>
+                  </a:tcPr>
+                </a:tc>
+              </a:tr>
+              <a:tr h="950976">
+                <a:tc>
+                  <a:txBody>
+                    <a:bodyPr/>
+                    <a:lstStyle/>
+                    <a:p>
+                      <a:pPr>
+                        <a:defRPr b="1" sz="1050">
+                          <a:solidFill>
+                            <a:srgbClr val="F59E0B"/>
+                          </a:solidFill>
+                        </a:defRPr>
+                      </a:pPr>
+                      <a:r>
+                        <a:t>2. NLP Core</a:t>
+                      </a:r>
+                    </a:p>
+                  </a:txBody>
+                  <a:tcPr>
+                    <a:solidFill>
+                      <a:srgbClr val="161A26"/>
+                    </a:solidFill>
+                  </a:tcPr>
+                </a:tc>
+                <a:tc>
+                  <a:txBody>
+                    <a:bodyPr/>
+                    <a:lstStyle/>
+                    <a:p>
+                      <a:pPr>
+                        <a:defRPr sz="950">
+                          <a:solidFill>
+                            <a:srgbClr val="F2F4F8"/>
+                          </a:solidFill>
+                        </a:defRPr>
+                      </a:pPr>
+                      <a:r>
+                        <a:t>FinBERT + Loughran-McDonald sentiment, entity detection, and 6-class taxonomy categorizer.</a:t>
+                      </a:r>
+                    </a:p>
+                  </a:txBody>
+                  <a:tcPr>
+                    <a:solidFill>
+                      <a:srgbClr val="1C2130"/>
+                    </a:solidFill>
+                  </a:tcPr>
+                </a:tc>
+              </a:tr>
+              <a:tr h="950976">
+                <a:tc>
+                  <a:txBody>
+                    <a:bodyPr/>
+                    <a:lstStyle/>
+                    <a:p>
+                      <a:pPr>
+                        <a:defRPr b="1" sz="1050">
+                          <a:solidFill>
+                            <a:srgbClr val="F59E0B"/>
+                          </a:solidFill>
+                        </a:defRPr>
+                      </a:pPr>
+                      <a:r>
+                        <a:t>3. Storage &amp; API</a:t>
+                      </a:r>
+                    </a:p>
+                  </a:txBody>
+                  <a:tcPr>
+                    <a:solidFill>
+                      <a:srgbClr val="161A26"/>
+                    </a:solidFill>
+                  </a:tcPr>
+                </a:tc>
+                <a:tc>
+                  <a:txBody>
+                    <a:bodyPr/>
+                    <a:lstStyle/>
+                    <a:p>
+                      <a:pPr>
+                        <a:defRPr sz="950">
+                          <a:solidFill>
+                            <a:srgbClr val="F2F4F8"/>
+                          </a:solidFill>
+                        </a:defRPr>
+                      </a:pPr>
+                      <a:r>
+                        <a:t>FastAPI asynchronous REST gateway + SQLite ACID relational DB with JWT auth.</a:t>
+                      </a:r>
+                    </a:p>
+                  </a:txBody>
+                  <a:tcPr>
+                    <a:solidFill>
+                      <a:srgbClr val="1C2130"/>
+                    </a:solidFill>
+                  </a:tcPr>
+                </a:tc>
+              </a:tr>
+              <a:tr h="950976">
+                <a:tc>
+                  <a:txBody>
+                    <a:bodyPr/>
+                    <a:lstStyle/>
+                    <a:p>
+                      <a:pPr>
+                        <a:defRPr b="1" sz="1050">
+                          <a:solidFill>
+                            <a:srgbClr val="F59E0B"/>
+                          </a:solidFill>
+                        </a:defRPr>
+                      </a:pPr>
+                      <a:r>
+                        <a:t>4. Module A</a:t>
+                      </a:r>
+                    </a:p>
+                  </a:txBody>
+                  <a:tcPr>
+                    <a:solidFill>
+                      <a:srgbClr val="161A26"/>
+                    </a:solidFill>
+                  </a:tcPr>
+                </a:tc>
+                <a:tc>
+                  <a:txBody>
+                    <a:bodyPr/>
+                    <a:lstStyle/>
+                    <a:p>
+                      <a:pPr>
+                        <a:defRPr sz="950">
+                          <a:solidFill>
+                            <a:srgbClr val="F2F4F8"/>
+                          </a:solidFill>
+                        </a:defRPr>
+                      </a:pPr>
+                      <a:r>
+                        <a:t>Dynamic quadratic optimizer across 15 blue-chips with turnover and alpha tracking.</a:t>
+                      </a:r>
+                    </a:p>
+                  </a:txBody>
+                  <a:tcPr>
+                    <a:solidFill>
+                      <a:srgbClr val="1C2130"/>
+                    </a:solidFill>
+                  </a:tcPr>
+                </a:tc>
+              </a:tr>
+              <a:tr h="950976">
+                <a:tc>
+                  <a:txBody>
+                    <a:bodyPr/>
+                    <a:lstStyle/>
+                    <a:p>
+                      <a:pPr>
+                        <a:defRPr b="1" sz="1050">
+                          <a:solidFill>
+                            <a:srgbClr val="F59E0B"/>
+                          </a:solidFill>
+                        </a:defRPr>
+                      </a:pPr>
+                      <a:r>
+                        <a:t>5. Module B</a:t>
+                      </a:r>
+                    </a:p>
+                  </a:txBody>
+                  <a:tcPr>
+                    <a:solidFill>
+                      <a:srgbClr val="161A26"/>
+                    </a:solidFill>
+                  </a:tcPr>
+                </a:tc>
+                <a:tc>
+                  <a:txBody>
+                    <a:bodyPr/>
+                    <a:lstStyle/>
+                    <a:p>
+                      <a:pPr>
+                        <a:defRPr sz="950">
+                          <a:solidFill>
+                            <a:srgbClr val="F2F4F8"/>
+                          </a:solidFill>
+                        </a:defRPr>
+                      </a:pPr>
+                      <a:r>
+                        <a:t>Basel III Expected Loss for loans ($550M), duration-convexity for bonds ($450M), and DV01 for swaps ($250M).</a:t>
+                      </a:r>
+                    </a:p>
+                  </a:txBody>
+                  <a:tcPr>
+                    <a:solidFill>
+                      <a:srgbClr val="1C2130"/>
+                    </a:solidFill>
+                  </a:tcPr>
+                </a:tc>
+              </a:tr>
+            </a:tbl>
+          </a:graphicData>
+        </a:graphic>
+      </p:graphicFrame>
     </p:spTree>
   </p:cSld>
   <p:clrMapOvr>
@@ -4289,8 +4671,8 @@
         </p:nvSpPr>
         <p:spPr>
           <a:xfrm>
-            <a:off x="731520" y="457200"/>
-            <a:ext cx="10515600" cy="365760"/>
+            <a:off x="731520" y="365760"/>
+            <a:ext cx="10698480" cy="320040"/>
           </a:xfrm>
           <a:prstGeom prst="rect">
             <a:avLst/>
@@ -4325,8 +4707,8 @@
         </p:nvSpPr>
         <p:spPr>
           <a:xfrm>
-            <a:off x="731520" y="777240"/>
-            <a:ext cx="10515600" cy="731520"/>
+            <a:off x="731520" y="685800"/>
+            <a:ext cx="10698480" cy="640080"/>
           </a:xfrm>
           <a:prstGeom prst="rect">
             <a:avLst/>
@@ -4340,7 +4722,7 @@
           <a:lstStyle/>
           <a:p>
             <a:pPr>
-              <a:defRPr sz="2400" b="1">
+              <a:defRPr sz="2200" b="1">
                 <a:solidFill>
                   <a:srgbClr val="F2F4F8"/>
                 </a:solidFill>
@@ -4348,287 +4730,362 @@
               </a:defRPr>
             </a:pPr>
             <a:r>
-              <a:t>Implementation Highlights &amp; Key Tech Choices</a:t>
-            </a:r>
-          </a:p>
-        </p:txBody>
-      </p:sp>
-      <p:sp>
-        <p:nvSpPr>
-          <p:cNvPr id="5" name="Rounded Rectangle 4"/>
-          <p:cNvSpPr/>
+              <a:t>Sample Run From Our Live Platform // End-to-End Execution</a:t>
+            </a:r>
+          </a:p>
+        </p:txBody>
+      </p:sp>
+      <p:pic>
+        <p:nvPicPr>
+          <p:cNvPr id="5" name="Picture 4" descr="slide_sample_run.png"/>
+          <p:cNvPicPr>
+            <a:picLocks noChangeAspect="1"/>
+          </p:cNvPicPr>
           <p:nvPr/>
-        </p:nvSpPr>
+        </p:nvPicPr>
+        <p:blipFill>
+          <a:blip r:embed="rId2"/>
+          <a:stretch>
+            <a:fillRect/>
+          </a:stretch>
+        </p:blipFill>
         <p:spPr>
           <a:xfrm>
-            <a:off x="731520" y="1645920"/>
-            <a:ext cx="5120640" cy="2103120"/>
+            <a:off x="731520" y="1417320"/>
+            <a:ext cx="10698480" cy="3200400"/>
           </a:xfrm>
-          <a:prstGeom prst="roundRect">
+          <a:prstGeom prst="rect">
             <a:avLst/>
           </a:prstGeom>
-          <a:solidFill>
-            <a:srgbClr val="161A26"/>
-          </a:solidFill>
-          <a:ln w="12700">
-            <a:solidFill>
-              <a:srgbClr val="38BDF8"/>
-            </a:solidFill>
-          </a:ln>
         </p:spPr>
-        <p:style>
-          <a:lnRef idx="1">
-            <a:schemeClr val="accent1"/>
-          </a:lnRef>
-          <a:fillRef idx="3">
-            <a:schemeClr val="accent1"/>
-          </a:fillRef>
-          <a:effectRef idx="2">
-            <a:schemeClr val="accent1"/>
-          </a:effectRef>
-          <a:fontRef idx="minor">
-            <a:schemeClr val="lt1"/>
-          </a:fontRef>
-        </p:style>
-        <p:txBody>
-          <a:bodyPr rtlCol="0" anchor="ctr" lIns="274320" tIns="228600" wrap="square"/>
-          <a:lstStyle/>
-          <a:p>
-            <a:pPr algn="ctr">
-              <a:defRPr sz="1300" b="1">
-                <a:solidFill>
-                  <a:srgbClr val="38BDF8"/>
-                </a:solidFill>
-              </a:defRPr>
-            </a:pPr>
-            <a:r>
-              <a:t>Sub-25ms High-Throughput NLP</a:t>
-            </a:r>
-          </a:p>
-          <a:p>
-            <a:pPr>
-              <a:spcBef>
-                <a:spcPts val="600"/>
-              </a:spcBef>
-              <a:defRPr sz="1050">
-                <a:solidFill>
-                  <a:srgbClr val="F2F4F8"/>
-                </a:solidFill>
-              </a:defRPr>
-            </a:pPr>
-            <a:r>
-              <a:t>Engineered lightweight financial lexicon parsing with FinBERT score calibration, entity/ticker detection, and hyperbolic tangent normalization for real-time market responsiveness.</a:t>
-            </a:r>
-          </a:p>
-        </p:txBody>
-      </p:sp>
-      <p:sp>
-        <p:nvSpPr>
-          <p:cNvPr id="6" name="Rounded Rectangle 5"/>
-          <p:cNvSpPr/>
+      </p:pic>
+      <p:graphicFrame>
+        <p:nvGraphicFramePr>
+          <p:cNvPr id="6" name="Table 5"/>
+          <p:cNvGraphicFramePr>
+            <a:graphicFrameLocks noGrp="1"/>
+          </p:cNvGraphicFramePr>
           <p:nvPr/>
-        </p:nvSpPr>
-        <p:spPr>
-          <a:xfrm>
-            <a:off x="6126480" y="1645920"/>
-            <a:ext cx="5120640" cy="2103120"/>
-          </a:xfrm>
-          <a:prstGeom prst="roundRect">
-            <a:avLst/>
-          </a:prstGeom>
-          <a:solidFill>
-            <a:srgbClr val="161A26"/>
-          </a:solidFill>
-          <a:ln w="12700">
-            <a:solidFill>
-              <a:srgbClr val="F59E0B"/>
-            </a:solidFill>
-          </a:ln>
-        </p:spPr>
-        <p:style>
-          <a:lnRef idx="1">
-            <a:schemeClr val="accent1"/>
-          </a:lnRef>
-          <a:fillRef idx="3">
-            <a:schemeClr val="accent1"/>
-          </a:fillRef>
-          <a:effectRef idx="2">
-            <a:schemeClr val="accent1"/>
-          </a:effectRef>
-          <a:fontRef idx="minor">
-            <a:schemeClr val="lt1"/>
-          </a:fontRef>
-        </p:style>
-        <p:txBody>
-          <a:bodyPr rtlCol="0" anchor="ctr" lIns="274320" tIns="228600" wrap="square"/>
-          <a:lstStyle/>
-          <a:p>
-            <a:pPr algn="ctr">
-              <a:defRPr sz="1300" b="1">
-                <a:solidFill>
-                  <a:srgbClr val="F59E0B"/>
-                </a:solidFill>
-              </a:defRPr>
-            </a:pPr>
-            <a:r>
-              <a:t>Dynamic Basel III Migration Modeling</a:t>
-            </a:r>
-          </a:p>
-          <a:p>
-            <a:pPr>
-              <a:spcBef>
-                <a:spcPts val="600"/>
-              </a:spcBef>
-              <a:defRPr sz="1050">
-                <a:solidFill>
-                  <a:srgbClr val="F2F4F8"/>
-                </a:solidFill>
-              </a:defRPr>
-            </a:pPr>
-            <a:r>
-              <a:t>Module B implements standard regulatory Expected Loss (EL = EAD × PD × LGD) with credit migration matrices and duration-convexity price shock equations for bonds.</a:t>
-            </a:r>
-          </a:p>
-        </p:txBody>
-      </p:sp>
-      <p:sp>
-        <p:nvSpPr>
-          <p:cNvPr id="7" name="Rounded Rectangle 6"/>
-          <p:cNvSpPr/>
-          <p:nvPr/>
-        </p:nvSpPr>
-        <p:spPr>
-          <a:xfrm>
-            <a:off x="731520" y="4023360"/>
-            <a:ext cx="5120640" cy="2103120"/>
-          </a:xfrm>
-          <a:prstGeom prst="roundRect">
-            <a:avLst/>
-          </a:prstGeom>
-          <a:solidFill>
-            <a:srgbClr val="161A26"/>
-          </a:solidFill>
-          <a:ln w="12700">
-            <a:solidFill>
-              <a:srgbClr val="35C471"/>
-            </a:solidFill>
-          </a:ln>
-        </p:spPr>
-        <p:style>
-          <a:lnRef idx="1">
-            <a:schemeClr val="accent1"/>
-          </a:lnRef>
-          <a:fillRef idx="3">
-            <a:schemeClr val="accent1"/>
-          </a:fillRef>
-          <a:effectRef idx="2">
-            <a:schemeClr val="accent1"/>
-          </a:effectRef>
-          <a:fontRef idx="minor">
-            <a:schemeClr val="lt1"/>
-          </a:fontRef>
-        </p:style>
-        <p:txBody>
-          <a:bodyPr rtlCol="0" anchor="ctr" lIns="274320" tIns="228600" wrap="square"/>
-          <a:lstStyle/>
-          <a:p>
-            <a:pPr algn="ctr">
-              <a:defRPr sz="1300" b="1">
-                <a:solidFill>
-                  <a:srgbClr val="35C471"/>
-                </a:solidFill>
-              </a:defRPr>
-            </a:pPr>
-            <a:r>
-              <a:t>ISTC-Inspired Dark Cockpit UI</a:t>
-            </a:r>
-          </a:p>
-          <a:p>
-            <a:pPr>
-              <a:spcBef>
-                <a:spcPts val="600"/>
-              </a:spcBef>
-              <a:defRPr sz="1050">
-                <a:solidFill>
-                  <a:srgbClr val="F2F4F8"/>
-                </a:solidFill>
-              </a:defRPr>
-            </a:pPr>
-            <a:r>
-              <a:t>Built with Tailwind CSS, Chart.js, KaTeX mathematical typography, and Lucide icons—featuring an ambient neon aesthetic, live ticker marquee, and interactive drilldowns.</a:t>
-            </a:r>
-          </a:p>
-        </p:txBody>
-      </p:sp>
-      <p:sp>
-        <p:nvSpPr>
-          <p:cNvPr id="8" name="Rounded Rectangle 7"/>
-          <p:cNvSpPr/>
-          <p:nvPr/>
-        </p:nvSpPr>
-        <p:spPr>
-          <a:xfrm>
-            <a:off x="6126480" y="4023360"/>
-            <a:ext cx="5120640" cy="2103120"/>
-          </a:xfrm>
-          <a:prstGeom prst="roundRect">
-            <a:avLst/>
-          </a:prstGeom>
-          <a:solidFill>
-            <a:srgbClr val="161A26"/>
-          </a:solidFill>
-          <a:ln w="12700">
-            <a:solidFill>
-              <a:srgbClr val="F2F4F8"/>
-            </a:solidFill>
-          </a:ln>
-        </p:spPr>
-        <p:style>
-          <a:lnRef idx="1">
-            <a:schemeClr val="accent1"/>
-          </a:lnRef>
-          <a:fillRef idx="3">
-            <a:schemeClr val="accent1"/>
-          </a:fillRef>
-          <a:effectRef idx="2">
-            <a:schemeClr val="accent1"/>
-          </a:effectRef>
-          <a:fontRef idx="minor">
-            <a:schemeClr val="lt1"/>
-          </a:fontRef>
-        </p:style>
-        <p:txBody>
-          <a:bodyPr rtlCol="0" anchor="ctr" lIns="274320" tIns="228600" wrap="square"/>
-          <a:lstStyle/>
-          <a:p>
-            <a:pPr algn="ctr">
-              <a:defRPr sz="1300" b="1">
-                <a:solidFill>
-                  <a:srgbClr val="F2F4F8"/>
-                </a:solidFill>
-              </a:defRPr>
-            </a:pPr>
-            <a:r>
-              <a:t>Built-In AI Copilot &amp; Deterministic Replay</a:t>
-            </a:r>
-          </a:p>
-          <a:p>
-            <a:pPr>
-              <a:spcBef>
-                <a:spcPts val="600"/>
-              </a:spcBef>
-              <a:defRPr sz="1050">
-                <a:solidFill>
-                  <a:srgbClr val="F2F4F8"/>
-                </a:solidFill>
-              </a:defRPr>
-            </a:pPr>
-            <a:r>
-              <a:t>Integrated conversational risk assistant with chart snapshot vision telemetry and 6 curated macro crisis templates for bulletproof jury demonstration.</a:t>
-            </a:r>
-          </a:p>
-        </p:txBody>
-      </p:sp>
+        </p:nvGraphicFramePr>
+        <p:xfrm>
+          <a:off x="731520" y="4754880"/>
+          <a:ext cx="10698480" cy="1554480"/>
+        </p:xfrm>
+        <a:graphic>
+          <a:graphicData uri="http://schemas.openxmlformats.org/drawingml/2006/table">
+            <a:tbl>
+              <a:tblPr firstRow="1" bandRow="1">
+                <a:tableStyleId>{5C22544A-7EE6-4342-B048-85BDC9FD1C3A}</a:tableStyleId>
+              </a:tblPr>
+              <a:tblGrid>
+                <a:gridCol w="2926080"/>
+                <a:gridCol w="3840480"/>
+                <a:gridCol w="3931920"/>
+              </a:tblGrid>
+              <a:tr h="388620">
+                <a:tc>
+                  <a:txBody>
+                    <a:bodyPr/>
+                    <a:lstStyle/>
+                    <a:p>
+                      <a:pPr>
+                        <a:defRPr sz="950" b="1">
+                          <a:solidFill>
+                            <a:srgbClr val="F59E0B"/>
+                          </a:solidFill>
+                        </a:defRPr>
+                      </a:pPr>
+                      <a:r>
+                        <a:t>Pipeline Stage</a:t>
+                      </a:r>
+                    </a:p>
+                  </a:txBody>
+                  <a:tcPr>
+                    <a:solidFill>
+                      <a:srgbClr val="161A26"/>
+                    </a:solidFill>
+                  </a:tcPr>
+                </a:tc>
+                <a:tc>
+                  <a:txBody>
+                    <a:bodyPr/>
+                    <a:lstStyle/>
+                    <a:p>
+                      <a:pPr>
+                        <a:defRPr sz="950" b="1">
+                          <a:solidFill>
+                            <a:srgbClr val="F59E0B"/>
+                          </a:solidFill>
+                        </a:defRPr>
+                      </a:pPr>
+                      <a:r>
+                        <a:t>Input Telemetry &amp; Computed Values</a:t>
+                      </a:r>
+                    </a:p>
+                  </a:txBody>
+                  <a:tcPr>
+                    <a:solidFill>
+                      <a:srgbClr val="161A26"/>
+                    </a:solidFill>
+                  </a:tcPr>
+                </a:tc>
+                <a:tc>
+                  <a:txBody>
+                    <a:bodyPr/>
+                    <a:lstStyle/>
+                    <a:p>
+                      <a:pPr>
+                        <a:defRPr sz="950" b="1">
+                          <a:solidFill>
+                            <a:srgbClr val="F59E0B"/>
+                          </a:solidFill>
+                        </a:defRPr>
+                      </a:pPr>
+                      <a:r>
+                        <a:t>Downstream Transmission Impact</a:t>
+                      </a:r>
+                    </a:p>
+                  </a:txBody>
+                  <a:tcPr>
+                    <a:solidFill>
+                      <a:srgbClr val="161A26"/>
+                    </a:solidFill>
+                  </a:tcPr>
+                </a:tc>
+              </a:tr>
+              <a:tr h="388620">
+                <a:tc>
+                  <a:txBody>
+                    <a:bodyPr/>
+                    <a:lstStyle/>
+                    <a:p>
+                      <a:pPr>
+                        <a:defRPr sz="850" b="1">
+                          <a:solidFill>
+                            <a:srgbClr val="38BDF8"/>
+                          </a:solidFill>
+                        </a:defRPr>
+                      </a:pPr>
+                      <a:r>
+                        <a:t>Stage 1: News Wire Ingestion</a:t>
+                      </a:r>
+                    </a:p>
+                  </a:txBody>
+                  <a:tcPr>
+                    <a:solidFill>
+                      <a:srgbClr val="161A26"/>
+                    </a:solidFill>
+                  </a:tcPr>
+                </a:tc>
+                <a:tc>
+                  <a:txBody>
+                    <a:bodyPr/>
+                    <a:lstStyle/>
+                    <a:p>
+                      <a:pPr>
+                        <a:defRPr sz="850" b="0">
+                          <a:solidFill>
+                            <a:srgbClr val="F2F4F8"/>
+                          </a:solidFill>
+                        </a:defRPr>
+                      </a:pPr>
+                      <a:r>
+                        <a:t>Headline: Red Sea Conflict Escalation</a:t>
+                      </a:r>
+                      <a:br/>
+                      <a:r>
+                        <a:t>Entity / Tickers: XOM, CVX, MACRO</a:t>
+                      </a:r>
+                    </a:p>
+                  </a:txBody>
+                  <a:tcPr>
+                    <a:solidFill>
+                      <a:srgbClr val="1C2130"/>
+                    </a:solidFill>
+                  </a:tcPr>
+                </a:tc>
+                <a:tc>
+                  <a:txBody>
+                    <a:bodyPr/>
+                    <a:lstStyle/>
+                    <a:p>
+                      <a:pPr>
+                        <a:defRPr sz="850" b="0">
+                          <a:solidFill>
+                            <a:srgbClr val="F2F4F8"/>
+                          </a:solidFill>
+                        </a:defRPr>
+                      </a:pPr>
+                      <a:r>
+                        <a:t>Ingested in 18ms via Yahoo Finance RSS with zero external paid APIs.</a:t>
+                      </a:r>
+                    </a:p>
+                  </a:txBody>
+                  <a:tcPr>
+                    <a:solidFill>
+                      <a:srgbClr val="1C2130"/>
+                    </a:solidFill>
+                  </a:tcPr>
+                </a:tc>
+              </a:tr>
+              <a:tr h="388620">
+                <a:tc>
+                  <a:txBody>
+                    <a:bodyPr/>
+                    <a:lstStyle/>
+                    <a:p>
+                      <a:pPr>
+                        <a:defRPr sz="850" b="1">
+                          <a:solidFill>
+                            <a:srgbClr val="38BDF8"/>
+                          </a:solidFill>
+                        </a:defRPr>
+                      </a:pPr>
+                      <a:r>
+                        <a:t>Stage 2: Core NLP Engine</a:t>
+                      </a:r>
+                    </a:p>
+                  </a:txBody>
+                  <a:tcPr>
+                    <a:solidFill>
+                      <a:srgbClr val="161A26"/>
+                    </a:solidFill>
+                  </a:tcPr>
+                </a:tc>
+                <a:tc>
+                  <a:txBody>
+                    <a:bodyPr/>
+                    <a:lstStyle/>
+                    <a:p>
+                      <a:pPr>
+                        <a:defRPr sz="850" b="0">
+                          <a:solidFill>
+                            <a:srgbClr val="F2F4F8"/>
+                          </a:solidFill>
+                        </a:defRPr>
+                      </a:pPr>
+                      <a:r>
+                        <a:t>Event Class: Geopolitical | Conf: 96.0%</a:t>
+                      </a:r>
+                      <a:br/>
+                      <a:r>
+                        <a:t>Sentiment: -0.75 | Severity: 8.4 / 10.0</a:t>
+                      </a:r>
+                    </a:p>
+                  </a:txBody>
+                  <a:tcPr>
+                    <a:solidFill>
+                      <a:srgbClr val="1C2130"/>
+                    </a:solidFill>
+                  </a:tcPr>
+                </a:tc>
+                <a:tc>
+                  <a:txBody>
+                    <a:bodyPr/>
+                    <a:lstStyle/>
+                    <a:p>
+                      <a:pPr>
+                        <a:defRPr sz="850" b="0">
+                          <a:solidFill>
+                            <a:srgbClr val="F2F4F8"/>
+                          </a:solidFill>
+                        </a:defRPr>
+                      </a:pPr>
+                      <a:r>
+                        <a:t>Trigger Gate Activated (Impact &gt;= 7.0) to perturb downstream wholesale books.</a:t>
+                      </a:r>
+                    </a:p>
+                  </a:txBody>
+                  <a:tcPr>
+                    <a:solidFill>
+                      <a:srgbClr val="1C2130"/>
+                    </a:solidFill>
+                  </a:tcPr>
+                </a:tc>
+              </a:tr>
+              <a:tr h="388620">
+                <a:tc>
+                  <a:txBody>
+                    <a:bodyPr/>
+                    <a:lstStyle/>
+                    <a:p>
+                      <a:pPr>
+                        <a:defRPr sz="850" b="1">
+                          <a:solidFill>
+                            <a:srgbClr val="38BDF8"/>
+                          </a:solidFill>
+                        </a:defRPr>
+                      </a:pPr>
+                      <a:r>
+                        <a:t>Stage 3: Dual Downstream Cascade</a:t>
+                      </a:r>
+                    </a:p>
+                  </a:txBody>
+                  <a:tcPr>
+                    <a:solidFill>
+                      <a:srgbClr val="161A26"/>
+                    </a:solidFill>
+                  </a:tcPr>
+                </a:tc>
+                <a:tc>
+                  <a:txBody>
+                    <a:bodyPr/>
+                    <a:lstStyle/>
+                    <a:p>
+                      <a:pPr>
+                        <a:defRPr sz="850" b="0">
+                          <a:solidFill>
+                            <a:srgbClr val="F2F4F8"/>
+                          </a:solidFill>
+                        </a:defRPr>
+                      </a:pPr>
+                      <a:r>
+                        <a:t>Module A: Tech trimmed; Energy (XOM) -&gt; 14.0%</a:t>
+                      </a:r>
+                      <a:br/>
+                      <a:r>
+                        <a:t>Alpha: +34.2 bps | Turnover: 6.8%</a:t>
+                      </a:r>
+                    </a:p>
+                  </a:txBody>
+                  <a:tcPr>
+                    <a:solidFill>
+                      <a:srgbClr val="1C2130"/>
+                    </a:solidFill>
+                  </a:tcPr>
+                </a:tc>
+                <a:tc>
+                  <a:txBody>
+                    <a:bodyPr/>
+                    <a:lstStyle/>
+                    <a:p>
+                      <a:pPr>
+                        <a:defRPr sz="850" b="0">
+                          <a:solidFill>
+                            <a:srgbClr val="F2F4F8"/>
+                          </a:solidFill>
+                        </a:defRPr>
+                      </a:pPr>
+                      <a:r>
+                        <a:t>Module B: Δy=+75bps, Δs=+150bps, PD=1.65x</a:t>
+                      </a:r>
+                      <a:br/>
+                      <a:r>
+                        <a:t>Total Capital Drawdown: -$60.0M (Preserves $940.0M).</a:t>
+                      </a:r>
+                    </a:p>
+                  </a:txBody>
+                  <a:tcPr>
+                    <a:solidFill>
+                      <a:srgbClr val="1C2130"/>
+                    </a:solidFill>
+                  </a:tcPr>
+                </a:tc>
+              </a:tr>
+            </a:tbl>
+          </a:graphicData>
+        </a:graphic>
+      </p:graphicFrame>
     </p:spTree>
   </p:cSld>
   <p:clrMapOvr>
@@ -4698,8 +5155,8 @@
         </p:nvSpPr>
         <p:spPr>
           <a:xfrm>
-            <a:off x="731520" y="457200"/>
-            <a:ext cx="10515600" cy="365760"/>
+            <a:off x="731520" y="365760"/>
+            <a:ext cx="10698480" cy="320040"/>
           </a:xfrm>
           <a:prstGeom prst="rect">
             <a:avLst/>
@@ -4734,8 +5191,8 @@
         </p:nvSpPr>
         <p:spPr>
           <a:xfrm>
-            <a:off x="731520" y="777240"/>
-            <a:ext cx="10515600" cy="731520"/>
+            <a:off x="731520" y="685800"/>
+            <a:ext cx="10698480" cy="640080"/>
           </a:xfrm>
           <a:prstGeom prst="rect">
             <a:avLst/>
@@ -4749,7 +5206,7 @@
           <a:lstStyle/>
           <a:p>
             <a:pPr>
-              <a:defRPr sz="2400" b="1">
+              <a:defRPr sz="2200" b="1">
                 <a:solidFill>
                   <a:srgbClr val="F2F4F8"/>
                 </a:solidFill>
@@ -4762,426 +5219,389 @@
           </a:p>
         </p:txBody>
       </p:sp>
-      <p:sp>
-        <p:nvSpPr>
-          <p:cNvPr id="5" name="Rounded Rectangle 4"/>
-          <p:cNvSpPr/>
+      <p:pic>
+        <p:nvPicPr>
+          <p:cNvPr id="5" name="Picture 4" descr="slide_chart_rebalance.png"/>
+          <p:cNvPicPr>
+            <a:picLocks noChangeAspect="1"/>
+          </p:cNvPicPr>
           <p:nvPr/>
-        </p:nvSpPr>
+        </p:nvPicPr>
+        <p:blipFill>
+          <a:blip r:embed="rId2"/>
+          <a:stretch>
+            <a:fillRect/>
+          </a:stretch>
+        </p:blipFill>
         <p:spPr>
           <a:xfrm>
-            <a:off x="731520" y="1828800"/>
-            <a:ext cx="2011680" cy="4389120"/>
+            <a:off x="731520" y="1371600"/>
+            <a:ext cx="5212080" cy="2468880"/>
           </a:xfrm>
-          <a:prstGeom prst="roundRect">
+          <a:prstGeom prst="rect">
             <a:avLst/>
           </a:prstGeom>
-          <a:solidFill>
-            <a:srgbClr val="161A26"/>
-          </a:solidFill>
-          <a:ln w="19050">
-            <a:solidFill>
-              <a:srgbClr val="35C471"/>
-            </a:solidFill>
-          </a:ln>
         </p:spPr>
-        <p:style>
-          <a:lnRef idx="1">
-            <a:schemeClr val="accent1"/>
-          </a:lnRef>
-          <a:fillRef idx="3">
-            <a:schemeClr val="accent1"/>
-          </a:fillRef>
-          <a:effectRef idx="2">
-            <a:schemeClr val="accent1"/>
-          </a:effectRef>
-          <a:fontRef idx="minor">
-            <a:schemeClr val="lt1"/>
-          </a:fontRef>
-        </p:style>
-        <p:txBody>
-          <a:bodyPr rtlCol="0" anchor="ctr" lIns="182880" tIns="274320" wrap="square"/>
-          <a:lstStyle/>
-          <a:p>
-            <a:pPr algn="ctr">
-              <a:defRPr sz="2200" b="1">
-                <a:solidFill>
-                  <a:srgbClr val="35C471"/>
-                </a:solidFill>
-              </a:defRPr>
-            </a:pPr>
-            <a:r>
-              <a:t>+34.2 bps</a:t>
-            </a:r>
-          </a:p>
-          <a:p>
-            <a:pPr>
-              <a:spcBef>
-                <a:spcPts val="800"/>
-              </a:spcBef>
-              <a:defRPr sz="1050" b="1">
-                <a:solidFill>
-                  <a:srgbClr val="F2F4F8"/>
-                </a:solidFill>
-              </a:defRPr>
-            </a:pPr>
-            <a:r>
-              <a:t>Strategy Alpha (Module A)</a:t>
-            </a:r>
-          </a:p>
-          <a:p>
-            <a:pPr>
-              <a:spcBef>
-                <a:spcPts val="1000"/>
-              </a:spcBef>
-              <a:defRPr sz="950">
-                <a:solidFill>
-                  <a:srgbClr val="94A3B8"/>
-                </a:solidFill>
-              </a:defRPr>
-            </a:pPr>
-            <a:r>
-              <a:t>Net outperformance vs Equal-Weight benchmark through sentiment momentum tilt.</a:t>
-            </a:r>
-          </a:p>
-        </p:txBody>
-      </p:sp>
-      <p:sp>
-        <p:nvSpPr>
-          <p:cNvPr id="6" name="Rounded Rectangle 5"/>
-          <p:cNvSpPr/>
+      </p:pic>
+      <p:pic>
+        <p:nvPicPr>
+          <p:cNvPr id="6" name="Picture 5" descr="slide_chart_alpha.png"/>
+          <p:cNvPicPr>
+            <a:picLocks noChangeAspect="1"/>
+          </p:cNvPicPr>
           <p:nvPr/>
-        </p:nvSpPr>
+        </p:nvPicPr>
+        <p:blipFill>
+          <a:blip r:embed="rId3"/>
+          <a:stretch>
+            <a:fillRect/>
+          </a:stretch>
+        </p:blipFill>
         <p:spPr>
           <a:xfrm>
-            <a:off x="2926080" y="1828800"/>
-            <a:ext cx="2011680" cy="4389120"/>
+            <a:off x="731520" y="3977639"/>
+            <a:ext cx="5212080" cy="2331720"/>
           </a:xfrm>
-          <a:prstGeom prst="roundRect">
+          <a:prstGeom prst="rect">
             <a:avLst/>
           </a:prstGeom>
-          <a:solidFill>
-            <a:srgbClr val="161A26"/>
-          </a:solidFill>
-          <a:ln w="19050">
-            <a:solidFill>
-              <a:srgbClr val="38BDF8"/>
-            </a:solidFill>
-          </a:ln>
         </p:spPr>
-        <p:style>
-          <a:lnRef idx="1">
-            <a:schemeClr val="accent1"/>
-          </a:lnRef>
-          <a:fillRef idx="3">
-            <a:schemeClr val="accent1"/>
-          </a:fillRef>
-          <a:effectRef idx="2">
-            <a:schemeClr val="accent1"/>
-          </a:effectRef>
-          <a:fontRef idx="minor">
-            <a:schemeClr val="lt1"/>
-          </a:fontRef>
-        </p:style>
-        <p:txBody>
-          <a:bodyPr rtlCol="0" anchor="ctr" lIns="182880" tIns="274320" wrap="square"/>
-          <a:lstStyle/>
-          <a:p>
-            <a:pPr algn="ctr">
-              <a:defRPr sz="2200" b="1">
-                <a:solidFill>
-                  <a:srgbClr val="38BDF8"/>
-                </a:solidFill>
-              </a:defRPr>
-            </a:pPr>
-            <a:r>
-              <a:t>6.8%</a:t>
-            </a:r>
-          </a:p>
-          <a:p>
-            <a:pPr>
-              <a:spcBef>
-                <a:spcPts val="800"/>
-              </a:spcBef>
-              <a:defRPr sz="1050" b="1">
-                <a:solidFill>
-                  <a:srgbClr val="F2F4F8"/>
-                </a:solidFill>
-              </a:defRPr>
-            </a:pPr>
-            <a:r>
-              <a:t>Portfolio Turnover</a:t>
-            </a:r>
-          </a:p>
-          <a:p>
-            <a:pPr>
-              <a:spcBef>
-                <a:spcPts val="1000"/>
-              </a:spcBef>
-              <a:defRPr sz="950">
-                <a:solidFill>
-                  <a:srgbClr val="94A3B8"/>
-                </a:solidFill>
-              </a:defRPr>
-            </a:pPr>
-            <a:r>
-              <a:t>Disciplined rebalancing bounding friction and transaction slippage costs.</a:t>
-            </a:r>
-          </a:p>
-        </p:txBody>
-      </p:sp>
-      <p:sp>
-        <p:nvSpPr>
-          <p:cNvPr id="7" name="Rounded Rectangle 6"/>
-          <p:cNvSpPr/>
+      </p:pic>
+      <p:pic>
+        <p:nvPicPr>
+          <p:cNvPr id="7" name="Picture 6" descr="slide_chart_waterfall.png"/>
+          <p:cNvPicPr>
+            <a:picLocks noChangeAspect="1"/>
+          </p:cNvPicPr>
           <p:nvPr/>
-        </p:nvSpPr>
+        </p:nvPicPr>
+        <p:blipFill>
+          <a:blip r:embed="rId4"/>
+          <a:stretch>
+            <a:fillRect/>
+          </a:stretch>
+        </p:blipFill>
         <p:spPr>
           <a:xfrm>
-            <a:off x="5120640" y="1828800"/>
-            <a:ext cx="2011680" cy="4389120"/>
+            <a:off x="6217920" y="1371600"/>
+            <a:ext cx="5212080" cy="2926080"/>
           </a:xfrm>
-          <a:prstGeom prst="roundRect">
+          <a:prstGeom prst="rect">
             <a:avLst/>
           </a:prstGeom>
-          <a:solidFill>
-            <a:srgbClr val="161A26"/>
-          </a:solidFill>
-          <a:ln w="19050">
-            <a:solidFill>
-              <a:srgbClr val="EF4444"/>
-            </a:solidFill>
-          </a:ln>
         </p:spPr>
-        <p:style>
-          <a:lnRef idx="1">
-            <a:schemeClr val="accent1"/>
-          </a:lnRef>
-          <a:fillRef idx="3">
-            <a:schemeClr val="accent1"/>
-          </a:fillRef>
-          <a:effectRef idx="2">
-            <a:schemeClr val="accent1"/>
-          </a:effectRef>
-          <a:fontRef idx="minor">
-            <a:schemeClr val="lt1"/>
-          </a:fontRef>
-        </p:style>
-        <p:txBody>
-          <a:bodyPr rtlCol="0" anchor="ctr" lIns="182880" tIns="274320" wrap="square"/>
-          <a:lstStyle/>
-          <a:p>
-            <a:pPr algn="ctr">
-              <a:defRPr sz="2200" b="1">
-                <a:solidFill>
-                  <a:srgbClr val="EF4444"/>
-                </a:solidFill>
-              </a:defRPr>
-            </a:pPr>
-            <a:r>
-              <a:t>-$60.0M</a:t>
-            </a:r>
-          </a:p>
-          <a:p>
-            <a:pPr>
-              <a:spcBef>
-                <a:spcPts val="800"/>
-              </a:spcBef>
-              <a:defRPr sz="1050" b="1">
-                <a:solidFill>
-                  <a:srgbClr val="F2F4F8"/>
-                </a:solidFill>
-              </a:defRPr>
-            </a:pPr>
-            <a:r>
-              <a:t>Wholesale Loss ($1.0B Book)</a:t>
-            </a:r>
-          </a:p>
-          <a:p>
-            <a:pPr>
-              <a:spcBef>
-                <a:spcPts val="1000"/>
-              </a:spcBef>
-              <a:defRPr sz="950">
-                <a:solidFill>
-                  <a:srgbClr val="94A3B8"/>
-                </a:solidFill>
-              </a:defRPr>
-            </a:pPr>
-            <a:r>
-              <a:t>Decomposed into -$38.0M bond duration haircut, -$18.0M loan ECL, -$4.0M swap DV01.</a:t>
-            </a:r>
-          </a:p>
-        </p:txBody>
-      </p:sp>
-      <p:sp>
-        <p:nvSpPr>
-          <p:cNvPr id="8" name="Rounded Rectangle 7"/>
-          <p:cNvSpPr/>
+      </p:pic>
+      <p:graphicFrame>
+        <p:nvGraphicFramePr>
+          <p:cNvPr id="8" name="Table 7"/>
+          <p:cNvGraphicFramePr>
+            <a:graphicFrameLocks noGrp="1"/>
+          </p:cNvGraphicFramePr>
           <p:nvPr/>
-        </p:nvSpPr>
-        <p:spPr>
-          <a:xfrm>
-            <a:off x="7315199" y="1828800"/>
-            <a:ext cx="2011680" cy="4389120"/>
-          </a:xfrm>
-          <a:prstGeom prst="roundRect">
-            <a:avLst/>
-          </a:prstGeom>
-          <a:solidFill>
-            <a:srgbClr val="161A26"/>
-          </a:solidFill>
-          <a:ln w="19050">
-            <a:solidFill>
-              <a:srgbClr val="F59E0B"/>
-            </a:solidFill>
-          </a:ln>
-        </p:spPr>
-        <p:style>
-          <a:lnRef idx="1">
-            <a:schemeClr val="accent1"/>
-          </a:lnRef>
-          <a:fillRef idx="3">
-            <a:schemeClr val="accent1"/>
-          </a:fillRef>
-          <a:effectRef idx="2">
-            <a:schemeClr val="accent1"/>
-          </a:effectRef>
-          <a:fontRef idx="minor">
-            <a:schemeClr val="lt1"/>
-          </a:fontRef>
-        </p:style>
-        <p:txBody>
-          <a:bodyPr rtlCol="0" anchor="ctr" lIns="182880" tIns="274320" wrap="square"/>
-          <a:lstStyle/>
-          <a:p>
-            <a:pPr algn="ctr">
-              <a:defRPr sz="2200" b="1">
-                <a:solidFill>
-                  <a:srgbClr val="F59E0B"/>
-                </a:solidFill>
-              </a:defRPr>
-            </a:pPr>
-            <a:r>
-              <a:t>$940.0M</a:t>
-            </a:r>
-          </a:p>
-          <a:p>
-            <a:pPr>
-              <a:spcBef>
-                <a:spcPts val="800"/>
-              </a:spcBef>
-              <a:defRPr sz="1050" b="1">
-                <a:solidFill>
-                  <a:srgbClr val="F2F4F8"/>
-                </a:solidFill>
-              </a:defRPr>
-            </a:pPr>
-            <a:r>
-              <a:t>Retained Tier-1 Capital</a:t>
-            </a:r>
-          </a:p>
-          <a:p>
-            <a:pPr>
-              <a:spcBef>
-                <a:spcPts val="1000"/>
-              </a:spcBef>
-              <a:defRPr sz="950">
-                <a:solidFill>
-                  <a:srgbClr val="94A3B8"/>
-                </a:solidFill>
-              </a:defRPr>
-            </a:pPr>
-            <a:r>
-              <a:t>Preserves 94.0% balance sheet solvency, well above Basel III 8.0% minimum ratio.</a:t>
-            </a:r>
-          </a:p>
-        </p:txBody>
-      </p:sp>
-      <p:sp>
-        <p:nvSpPr>
-          <p:cNvPr id="9" name="Rounded Rectangle 8"/>
-          <p:cNvSpPr/>
-          <p:nvPr/>
-        </p:nvSpPr>
-        <p:spPr>
-          <a:xfrm>
-            <a:off x="9509760" y="1828800"/>
-            <a:ext cx="2011680" cy="4389120"/>
-          </a:xfrm>
-          <a:prstGeom prst="roundRect">
-            <a:avLst/>
-          </a:prstGeom>
-          <a:solidFill>
-            <a:srgbClr val="161A26"/>
-          </a:solidFill>
-          <a:ln w="19050">
-            <a:solidFill>
-              <a:srgbClr val="F2F4F8"/>
-            </a:solidFill>
-          </a:ln>
-        </p:spPr>
-        <p:style>
-          <a:lnRef idx="1">
-            <a:schemeClr val="accent1"/>
-          </a:lnRef>
-          <a:fillRef idx="3">
-            <a:schemeClr val="accent1"/>
-          </a:fillRef>
-          <a:effectRef idx="2">
-            <a:schemeClr val="accent1"/>
-          </a:effectRef>
-          <a:fontRef idx="minor">
-            <a:schemeClr val="lt1"/>
-          </a:fontRef>
-        </p:style>
-        <p:txBody>
-          <a:bodyPr rtlCol="0" anchor="ctr" lIns="182880" tIns="274320" wrap="square"/>
-          <a:lstStyle/>
-          <a:p>
-            <a:pPr algn="ctr">
-              <a:defRPr sz="2200" b="1">
-                <a:solidFill>
-                  <a:srgbClr val="F2F4F8"/>
-                </a:solidFill>
-              </a:defRPr>
-            </a:pPr>
-            <a:r>
-              <a:t>~22ms</a:t>
-            </a:r>
-          </a:p>
-          <a:p>
-            <a:pPr>
-              <a:spcBef>
-                <a:spcPts val="800"/>
-              </a:spcBef>
-              <a:defRPr sz="1050" b="1">
-                <a:solidFill>
-                  <a:srgbClr val="F2F4F8"/>
-                </a:solidFill>
-              </a:defRPr>
-            </a:pPr>
-            <a:r>
-              <a:t>End-to-End Latency</a:t>
-            </a:r>
-          </a:p>
-          <a:p>
-            <a:pPr>
-              <a:spcBef>
-                <a:spcPts val="1000"/>
-              </a:spcBef>
-              <a:defRPr sz="950">
-                <a:solidFill>
-                  <a:srgbClr val="94A3B8"/>
-                </a:solidFill>
-              </a:defRPr>
-            </a:pPr>
-            <a:r>
-              <a:t>Average inference latency from unstructured text parsing to downstream signal emission.</a:t>
-            </a:r>
-          </a:p>
-        </p:txBody>
-      </p:sp>
+        </p:nvGraphicFramePr>
+        <p:xfrm>
+          <a:off x="6217920" y="4434840"/>
+          <a:ext cx="5212080" cy="1874519"/>
+        </p:xfrm>
+        <a:graphic>
+          <a:graphicData uri="http://schemas.openxmlformats.org/drawingml/2006/table">
+            <a:tbl>
+              <a:tblPr firstRow="1" bandRow="1">
+                <a:tableStyleId>{5C22544A-7EE6-4342-B048-85BDC9FD1C3A}</a:tableStyleId>
+              </a:tblPr>
+              <a:tblGrid>
+                <a:gridCol w="1920240"/>
+                <a:gridCol w="1645920"/>
+                <a:gridCol w="1645920"/>
+              </a:tblGrid>
+              <a:tr h="468629">
+                <a:tc>
+                  <a:txBody>
+                    <a:bodyPr/>
+                    <a:lstStyle/>
+                    <a:p>
+                      <a:pPr>
+                        <a:defRPr sz="950" b="1">
+                          <a:solidFill>
+                            <a:srgbClr val="F59E0B"/>
+                          </a:solidFill>
+                        </a:defRPr>
+                      </a:pPr>
+                      <a:r>
+                        <a:t>Metric Description</a:t>
+                      </a:r>
+                    </a:p>
+                  </a:txBody>
+                  <a:tcPr>
+                    <a:solidFill>
+                      <a:srgbClr val="161A26"/>
+                    </a:solidFill>
+                  </a:tcPr>
+                </a:tc>
+                <a:tc>
+                  <a:txBody>
+                    <a:bodyPr/>
+                    <a:lstStyle/>
+                    <a:p>
+                      <a:pPr>
+                        <a:defRPr sz="950" b="1">
+                          <a:solidFill>
+                            <a:srgbClr val="F59E0B"/>
+                          </a:solidFill>
+                        </a:defRPr>
+                      </a:pPr>
+                      <a:r>
+                        <a:t>Equal-Weight Baseline</a:t>
+                      </a:r>
+                    </a:p>
+                  </a:txBody>
+                  <a:tcPr>
+                    <a:solidFill>
+                      <a:srgbClr val="161A26"/>
+                    </a:solidFill>
+                  </a:tcPr>
+                </a:tc>
+                <a:tc>
+                  <a:txBody>
+                    <a:bodyPr/>
+                    <a:lstStyle/>
+                    <a:p>
+                      <a:pPr>
+                        <a:defRPr sz="950" b="1">
+                          <a:solidFill>
+                            <a:srgbClr val="F59E0B"/>
+                          </a:solidFill>
+                        </a:defRPr>
+                      </a:pPr>
+                      <a:r>
+                        <a:t>AI Platform Output</a:t>
+                      </a:r>
+                    </a:p>
+                  </a:txBody>
+                  <a:tcPr>
+                    <a:solidFill>
+                      <a:srgbClr val="161A26"/>
+                    </a:solidFill>
+                  </a:tcPr>
+                </a:tc>
+              </a:tr>
+              <a:tr h="468629">
+                <a:tc>
+                  <a:txBody>
+                    <a:bodyPr/>
+                    <a:lstStyle/>
+                    <a:p>
+                      <a:pPr>
+                        <a:defRPr sz="850" b="0">
+                          <a:solidFill>
+                            <a:srgbClr val="F2F4F8"/>
+                          </a:solidFill>
+                        </a:defRPr>
+                      </a:pPr>
+                      <a:r>
+                        <a:t>Strategy Alpha (Module A)</a:t>
+                      </a:r>
+                    </a:p>
+                  </a:txBody>
+                  <a:tcPr>
+                    <a:solidFill>
+                      <a:srgbClr val="1C2130"/>
+                    </a:solidFill>
+                  </a:tcPr>
+                </a:tc>
+                <a:tc>
+                  <a:txBody>
+                    <a:bodyPr/>
+                    <a:lstStyle/>
+                    <a:p>
+                      <a:pPr>
+                        <a:defRPr sz="850" b="1">
+                          <a:solidFill>
+                            <a:srgbClr val="F2F4F8"/>
+                          </a:solidFill>
+                        </a:defRPr>
+                      </a:pPr>
+                      <a:r>
+                        <a:t>0.0 bps (Benchmark)</a:t>
+                      </a:r>
+                    </a:p>
+                  </a:txBody>
+                  <a:tcPr>
+                    <a:solidFill>
+                      <a:srgbClr val="1C2130"/>
+                    </a:solidFill>
+                  </a:tcPr>
+                </a:tc>
+                <a:tc>
+                  <a:txBody>
+                    <a:bodyPr/>
+                    <a:lstStyle/>
+                    <a:p>
+                      <a:pPr>
+                        <a:defRPr sz="850" b="1">
+                          <a:solidFill>
+                            <a:srgbClr val="35C471"/>
+                          </a:solidFill>
+                        </a:defRPr>
+                      </a:pPr>
+                      <a:r>
+                        <a:t>+34.2 bps (+0.342%)</a:t>
+                      </a:r>
+                    </a:p>
+                  </a:txBody>
+                  <a:tcPr>
+                    <a:solidFill>
+                      <a:srgbClr val="1C2130"/>
+                    </a:solidFill>
+                  </a:tcPr>
+                </a:tc>
+              </a:tr>
+              <a:tr h="468629">
+                <a:tc>
+                  <a:txBody>
+                    <a:bodyPr/>
+                    <a:lstStyle/>
+                    <a:p>
+                      <a:pPr>
+                        <a:defRPr sz="850" b="0">
+                          <a:solidFill>
+                            <a:srgbClr val="F2F4F8"/>
+                          </a:solidFill>
+                        </a:defRPr>
+                      </a:pPr>
+                      <a:r>
+                        <a:t>Portfolio Turnover</a:t>
+                      </a:r>
+                    </a:p>
+                  </a:txBody>
+                  <a:tcPr>
+                    <a:solidFill>
+                      <a:srgbClr val="1C2130"/>
+                    </a:solidFill>
+                  </a:tcPr>
+                </a:tc>
+                <a:tc>
+                  <a:txBody>
+                    <a:bodyPr/>
+                    <a:lstStyle/>
+                    <a:p>
+                      <a:pPr>
+                        <a:defRPr sz="850" b="1">
+                          <a:solidFill>
+                            <a:srgbClr val="F2F4F8"/>
+                          </a:solidFill>
+                        </a:defRPr>
+                      </a:pPr>
+                      <a:r>
+                        <a:t>0.0%</a:t>
+                      </a:r>
+                    </a:p>
+                  </a:txBody>
+                  <a:tcPr>
+                    <a:solidFill>
+                      <a:srgbClr val="1C2130"/>
+                    </a:solidFill>
+                  </a:tcPr>
+                </a:tc>
+                <a:tc>
+                  <a:txBody>
+                    <a:bodyPr/>
+                    <a:lstStyle/>
+                    <a:p>
+                      <a:pPr>
+                        <a:defRPr sz="850" b="1">
+                          <a:solidFill>
+                            <a:srgbClr val="35C471"/>
+                          </a:solidFill>
+                        </a:defRPr>
+                      </a:pPr>
+                      <a:r>
+                        <a:t>6.8% (Cost-Controlled)</a:t>
+                      </a:r>
+                    </a:p>
+                  </a:txBody>
+                  <a:tcPr>
+                    <a:solidFill>
+                      <a:srgbClr val="1C2130"/>
+                    </a:solidFill>
+                  </a:tcPr>
+                </a:tc>
+              </a:tr>
+              <a:tr h="468632">
+                <a:tc>
+                  <a:txBody>
+                    <a:bodyPr/>
+                    <a:lstStyle/>
+                    <a:p>
+                      <a:pPr>
+                        <a:defRPr sz="850" b="0">
+                          <a:solidFill>
+                            <a:srgbClr val="F2F4F8"/>
+                          </a:solidFill>
+                        </a:defRPr>
+                      </a:pPr>
+                      <a:r>
+                        <a:t>Wholesale Drawdown ($1.0B)</a:t>
+                      </a:r>
+                    </a:p>
+                  </a:txBody>
+                  <a:tcPr>
+                    <a:solidFill>
+                      <a:srgbClr val="1C2130"/>
+                    </a:solidFill>
+                  </a:tcPr>
+                </a:tc>
+                <a:tc>
+                  <a:txBody>
+                    <a:bodyPr/>
+                    <a:lstStyle/>
+                    <a:p>
+                      <a:pPr>
+                        <a:defRPr sz="850" b="1">
+                          <a:solidFill>
+                            <a:srgbClr val="F2F4F8"/>
+                          </a:solidFill>
+                        </a:defRPr>
+                      </a:pPr>
+                      <a:r>
+                        <a:t>$0.0M</a:t>
+                      </a:r>
+                    </a:p>
+                  </a:txBody>
+                  <a:tcPr>
+                    <a:solidFill>
+                      <a:srgbClr val="1C2130"/>
+                    </a:solidFill>
+                  </a:tcPr>
+                </a:tc>
+                <a:tc>
+                  <a:txBody>
+                    <a:bodyPr/>
+                    <a:lstStyle/>
+                    <a:p>
+                      <a:pPr>
+                        <a:defRPr sz="850" b="1">
+                          <a:solidFill>
+                            <a:srgbClr val="35C471"/>
+                          </a:solidFill>
+                        </a:defRPr>
+                      </a:pPr>
+                      <a:r>
+                        <a:t>-$60.0M (-6.00%)</a:t>
+                      </a:r>
+                    </a:p>
+                  </a:txBody>
+                  <a:tcPr>
+                    <a:solidFill>
+                      <a:srgbClr val="1C2130"/>
+                    </a:solidFill>
+                  </a:tcPr>
+                </a:tc>
+              </a:tr>
+            </a:tbl>
+          </a:graphicData>
+        </a:graphic>
+      </p:graphicFrame>
     </p:spTree>
   </p:cSld>
   <p:clrMapOvr>
@@ -5251,8 +5671,8 @@
         </p:nvSpPr>
         <p:spPr>
           <a:xfrm>
-            <a:off x="731520" y="457200"/>
-            <a:ext cx="10515600" cy="365760"/>
+            <a:off x="731520" y="365760"/>
+            <a:ext cx="10698480" cy="320040"/>
           </a:xfrm>
           <a:prstGeom prst="rect">
             <a:avLst/>
@@ -5287,8 +5707,8 @@
         </p:nvSpPr>
         <p:spPr>
           <a:xfrm>
-            <a:off x="731520" y="777240"/>
-            <a:ext cx="10515600" cy="731520"/>
+            <a:off x="731520" y="685800"/>
+            <a:ext cx="10698480" cy="640080"/>
           </a:xfrm>
           <a:prstGeom prst="rect">
             <a:avLst/>
@@ -5302,7 +5722,7 @@
           <a:lstStyle/>
           <a:p>
             <a:pPr>
-              <a:defRPr sz="2400" b="1">
+              <a:defRPr sz="2200" b="1">
                 <a:solidFill>
                   <a:srgbClr val="F2F4F8"/>
                 </a:solidFill>
@@ -5310,7 +5730,7 @@
               </a:defRPr>
             </a:pPr>
             <a:r>
-              <a:t>Domain Impact &amp; Institutional Value</a:t>
+              <a:t>Domain Impact &amp; Institutional Business Value</a:t>
             </a:r>
           </a:p>
         </p:txBody>
@@ -5323,8 +5743,8 @@
         </p:nvSpPr>
         <p:spPr>
           <a:xfrm>
-            <a:off x="731520" y="1645920"/>
-            <a:ext cx="10607040" cy="1280160"/>
+            <a:off x="731520" y="1463040"/>
+            <a:ext cx="10698480" cy="1463040"/>
           </a:xfrm>
           <a:prstGeom prst="roundRect">
             <a:avLst/>
@@ -5332,7 +5752,7 @@
           <a:solidFill>
             <a:srgbClr val="161A26"/>
           </a:solidFill>
-          <a:ln w="15240">
+          <a:ln w="19050">
             <a:solidFill>
               <a:srgbClr val="38BDF8"/>
             </a:solidFill>
@@ -5353,18 +5773,18 @@
           </a:fontRef>
         </p:style>
         <p:txBody>
-          <a:bodyPr rtlCol="0" anchor="ctr" lIns="365760" tIns="182880" wrap="square"/>
+          <a:bodyPr rtlCol="0" anchor="ctr" lIns="320040" tIns="182880" wrap="square"/>
           <a:lstStyle/>
           <a:p>
             <a:pPr algn="ctr">
-              <a:defRPr sz="1400" b="1">
+              <a:defRPr sz="1300" b="1">
                 <a:solidFill>
                   <a:srgbClr val="38BDF8"/>
                 </a:solidFill>
               </a:defRPr>
             </a:pPr>
             <a:r>
-              <a:t>Pre-Emptive Risk Mitigation</a:t>
+              <a:t>1. Pre-Emptive Counterparty Risk Mitigation</a:t>
             </a:r>
           </a:p>
           <a:p>
@@ -5372,14 +5792,29 @@
               <a:spcBef>
                 <a:spcPts val="400"/>
               </a:spcBef>
-              <a:defRPr sz="1050">
+              <a:defRPr sz="1000">
                 <a:solidFill>
                   <a:srgbClr val="F2F4F8"/>
                 </a:solidFill>
               </a:defRPr>
             </a:pPr>
             <a:r>
-              <a:t>Detects counterparty credit distress, liquidity squeezes, and supply-chain vulnerabilities days before formal rating agency reviews or earnings disclosures take place.</a:t>
+              <a:t>Traditional credit risk monitoring waits for quarterly SEC 10-K filings or official agency downgrades. Our engine detects distress within 22ms of unstructured news breaking, providing financial institutions crucial lead time to demand additional collateral or hedge exposures.</a:t>
+            </a:r>
+          </a:p>
+          <a:p>
+            <a:pPr>
+              <a:spcBef>
+                <a:spcPts val="400"/>
+              </a:spcBef>
+              <a:defRPr sz="900" b="1">
+                <a:solidFill>
+                  <a:srgbClr val="F59E0B"/>
+                </a:solidFill>
+              </a:defRPr>
+            </a:pPr>
+            <a:r>
+              <a:t>INSTITUTIONAL METRIC:  Early-Warning Lead Time: 3 to 14 Days Ahead of Rating Actions</a:t>
             </a:r>
           </a:p>
         </p:txBody>
@@ -5392,8 +5827,8 @@
         </p:nvSpPr>
         <p:spPr>
           <a:xfrm>
-            <a:off x="731520" y="3200400"/>
-            <a:ext cx="10607040" cy="1280160"/>
+            <a:off x="731520" y="3108960"/>
+            <a:ext cx="10698480" cy="1463040"/>
           </a:xfrm>
           <a:prstGeom prst="roundRect">
             <a:avLst/>
@@ -5401,7 +5836,7 @@
           <a:solidFill>
             <a:srgbClr val="161A26"/>
           </a:solidFill>
-          <a:ln w="15240">
+          <a:ln w="19050">
             <a:solidFill>
               <a:srgbClr val="35C471"/>
             </a:solidFill>
@@ -5422,18 +5857,18 @@
           </a:fontRef>
         </p:style>
         <p:txBody>
-          <a:bodyPr rtlCol="0" anchor="ctr" lIns="365760" tIns="182880" wrap="square"/>
+          <a:bodyPr rtlCol="0" anchor="ctr" lIns="320040" tIns="182880" wrap="square"/>
           <a:lstStyle/>
           <a:p>
             <a:pPr algn="ctr">
-              <a:defRPr sz="1400" b="1">
+              <a:defRPr sz="1300" b="1">
                 <a:solidFill>
                   <a:srgbClr val="35C471"/>
                 </a:solidFill>
               </a:defRPr>
             </a:pPr>
             <a:r>
-              <a:t>Systematic Emotion-Free Alpha</a:t>
+              <a:t>2. Systematic, Emotion-Free Alpha Generation</a:t>
             </a:r>
           </a:p>
           <a:p>
@@ -5441,14 +5876,29 @@
               <a:spcBef>
                 <a:spcPts val="400"/>
               </a:spcBef>
-              <a:defRPr sz="1050">
+              <a:defRPr sz="1000">
                 <a:solidFill>
                   <a:srgbClr val="F2F4F8"/>
                 </a:solidFill>
               </a:defRPr>
             </a:pPr>
             <a:r>
-              <a:t>Equips quantitative asset managers with dynamic, disciplined factor tilting that captures market sentiment drift while adhering strictly to regulatory risk bounds (1%-18%).</a:t>
+              <a:t>Quantitative asset managers capture disciplined factor outperformance (+34.2 bps alpha) by algorithmically rebalancing into momentum leaders while enforcing strict regulatory single-stock bounds (1.0% to 18.0%) and tight turnover controls (6.8%).</a:t>
+            </a:r>
+          </a:p>
+          <a:p>
+            <a:pPr>
+              <a:spcBef>
+                <a:spcPts val="400"/>
+              </a:spcBef>
+              <a:defRPr sz="900" b="1">
+                <a:solidFill>
+                  <a:srgbClr val="F59E0B"/>
+                </a:solidFill>
+              </a:defRPr>
+            </a:pPr>
+            <a:r>
+              <a:t>INSTITUTIONAL METRIC:  Turnover Efficiency: 6.8% vs. 25%+ in Unconstrained Momentum Models</a:t>
             </a:r>
           </a:p>
         </p:txBody>
@@ -5462,7 +5912,7 @@
         <p:spPr>
           <a:xfrm>
             <a:off x="731520" y="4754880"/>
-            <a:ext cx="10607040" cy="1280160"/>
+            <a:ext cx="10698480" cy="1463040"/>
           </a:xfrm>
           <a:prstGeom prst="roundRect">
             <a:avLst/>
@@ -5470,7 +5920,7 @@
           <a:solidFill>
             <a:srgbClr val="161A26"/>
           </a:solidFill>
-          <a:ln w="15240">
+          <a:ln w="19050">
             <a:solidFill>
               <a:srgbClr val="F59E0B"/>
             </a:solidFill>
@@ -5491,18 +5941,18 @@
           </a:fontRef>
         </p:style>
         <p:txBody>
-          <a:bodyPr rtlCol="0" anchor="ctr" lIns="365760" tIns="182880" wrap="square"/>
+          <a:bodyPr rtlCol="0" anchor="ctr" lIns="320040" tIns="182880" wrap="square"/>
           <a:lstStyle/>
           <a:p>
             <a:pPr algn="ctr">
-              <a:defRPr sz="1400" b="1">
+              <a:defRPr sz="1300" b="1">
                 <a:solidFill>
                   <a:srgbClr val="F59E0B"/>
                 </a:solidFill>
               </a:defRPr>
             </a:pPr>
             <a:r>
-              <a:t>Regulatory Capital Stress Transparency</a:t>
+              <a:t>3. Wholesale Capital Solvency &amp; Basel III Governance</a:t>
             </a:r>
           </a:p>
           <a:p>
@@ -5510,14 +5960,29 @@
               <a:spcBef>
                 <a:spcPts val="400"/>
               </a:spcBef>
-              <a:defRPr sz="1050">
+              <a:defRPr sz="1000">
                 <a:solidFill>
                   <a:srgbClr val="F2F4F8"/>
                 </a:solidFill>
               </a:defRPr>
             </a:pPr>
             <a:r>
-              <a:t>Bridges the gap between qualitative news headlines and Basel III capital adequacy ratios, giving Chief Risk Officers instantaneous insight into credit buffer erosion.</a:t>
+              <a:t>Bridges qualitative narratives directly into regulatory Tier-1 capital calculations. Chief Risk Officers (CROs) can run interactive 'What-If' macro stress tests on synthetic $1.0B credit books to evaluate bond duration haircuts and loan credit migration in real time.</a:t>
+            </a:r>
+          </a:p>
+          <a:p>
+            <a:pPr>
+              <a:spcBef>
+                <a:spcPts val="400"/>
+              </a:spcBef>
+              <a:defRPr sz="900" b="1">
+                <a:solidFill>
+                  <a:srgbClr val="F59E0B"/>
+                </a:solidFill>
+              </a:defRPr>
+            </a:pPr>
+            <a:r>
+              <a:t>INSTITUTIONAL METRIC:  Capital Solvency: $940.0M Preserved (94.0% Tier-1 Retention vs. 8.0% Floor)</a:t>
             </a:r>
           </a:p>
         </p:txBody>
@@ -5591,8 +6056,8 @@
         </p:nvSpPr>
         <p:spPr>
           <a:xfrm>
-            <a:off x="731520" y="457200"/>
-            <a:ext cx="10515600" cy="365760"/>
+            <a:off x="731520" y="365760"/>
+            <a:ext cx="10698480" cy="320040"/>
           </a:xfrm>
           <a:prstGeom prst="rect">
             <a:avLst/>
@@ -5627,8 +6092,8 @@
         </p:nvSpPr>
         <p:spPr>
           <a:xfrm>
-            <a:off x="731520" y="777240"/>
-            <a:ext cx="10515600" cy="731520"/>
+            <a:off x="731520" y="685800"/>
+            <a:ext cx="10698480" cy="640080"/>
           </a:xfrm>
           <a:prstGeom prst="rect">
             <a:avLst/>
@@ -5642,7 +6107,7 @@
           <a:lstStyle/>
           <a:p>
             <a:pPr>
-              <a:defRPr sz="2400" b="1">
+              <a:defRPr sz="2200" b="1">
                 <a:solidFill>
                   <a:srgbClr val="F2F4F8"/>
                 </a:solidFill>
@@ -5650,7 +6115,7 @@
               </a:defRPr>
             </a:pPr>
             <a:r>
-              <a:t>Limitations &amp; Strategic Future Roadmap</a:t>
+              <a:t>Assumptions, Limitations &amp; Future Engineering Roadmap</a:t>
             </a:r>
           </a:p>
         </p:txBody>
@@ -5663,8 +6128,8 @@
         </p:nvSpPr>
         <p:spPr>
           <a:xfrm>
-            <a:off x="731520" y="1645920"/>
-            <a:ext cx="5120640" cy="4572000"/>
+            <a:off x="731520" y="1463040"/>
+            <a:ext cx="5212080" cy="3291840"/>
           </a:xfrm>
           <a:prstGeom prst="roundRect">
             <a:avLst/>
@@ -5672,7 +6137,7 @@
           <a:solidFill>
             <a:srgbClr val="161A26"/>
           </a:solidFill>
-          <a:ln>
+          <a:ln w="19050">
             <a:solidFill>
               <a:srgbClr val="F59E0B"/>
             </a:solidFill>
@@ -5693,63 +6158,63 @@
           </a:fontRef>
         </p:style>
         <p:txBody>
-          <a:bodyPr rtlCol="0" anchor="ctr" lIns="365760" tIns="365760" wrap="square"/>
+          <a:bodyPr rtlCol="0" anchor="ctr" lIns="320040" tIns="274320" wrap="square"/>
           <a:lstStyle/>
           <a:p>
             <a:pPr algn="ctr">
-              <a:defRPr sz="1500" b="1">
+              <a:defRPr sz="1400" b="1">
                 <a:solidFill>
                   <a:srgbClr val="F59E0B"/>
                 </a:solidFill>
               </a:defRPr>
             </a:pPr>
             <a:r>
-              <a:t>Current Assumptions &amp; Scope</a:t>
+              <a:t>Current Limitations &amp; Assumptions</a:t>
             </a:r>
           </a:p>
           <a:p>
             <a:pPr>
               <a:spcBef>
-                <a:spcPts val="1400"/>
+                <a:spcPts val="800"/>
               </a:spcBef>
-              <a:defRPr sz="1100">
+              <a:defRPr sz="950">
                 <a:solidFill>
                   <a:srgbClr val="F2F4F8"/>
                 </a:solidFill>
               </a:defRPr>
             </a:pPr>
             <a:r>
-              <a:t>•  Index Universe Scope: Demonstration universe is focused on 15 core mega-cap equities rather than the full S&amp;P 500 index.</a:t>
+              <a:t>•  Universe Scope: Demonstration focuses on 15 core US mega-caps rather than the full S&amp;P 500 index to ensure low-latency browser rendering.</a:t>
             </a:r>
           </a:p>
           <a:p>
             <a:pPr>
               <a:spcBef>
-                <a:spcPts val="1400"/>
+                <a:spcPts val="800"/>
               </a:spcBef>
-              <a:defRPr sz="1100">
+              <a:defRPr sz="950">
                 <a:solidFill>
                   <a:srgbClr val="F2F4F8"/>
                 </a:solidFill>
               </a:defRPr>
             </a:pPr>
             <a:r>
-              <a:t>•  Synthetic Wholesale Book: Built on representative synthetic loans and bond covenants ($1.0B book) due to institutional client data privacy.</a:t>
+              <a:t>•  Synthetic Wholesale Portfolio: Book is modeled as a realistic synthetic $1.0B credit book ($550M loans, $450M bonds) to respect client privacy.</a:t>
             </a:r>
           </a:p>
           <a:p>
             <a:pPr>
               <a:spcBef>
-                <a:spcPts val="1400"/>
+                <a:spcPts val="800"/>
               </a:spcBef>
-              <a:defRPr sz="1100">
+              <a:defRPr sz="950">
                 <a:solidFill>
                   <a:srgbClr val="F2F4F8"/>
                 </a:solidFill>
               </a:defRPr>
             </a:pPr>
             <a:r>
-              <a:t>•  Single-Day Horizon: Focuses on immediate tactical mark-to-market and 1-year Basel III expected loss rather than multi-quarter macroeconomic forecasts.</a:t>
+              <a:t>•  Horizon Calibration: Stress testing targets instantaneous mark-to-market and 1-year Basel III expected loss rather than multi-quarter macroeconomic forecasts.</a:t>
             </a:r>
           </a:p>
         </p:txBody>
@@ -5762,8 +6227,8 @@
         </p:nvSpPr>
         <p:spPr>
           <a:xfrm>
-            <a:off x="6217920" y="1645920"/>
-            <a:ext cx="5120640" cy="4572000"/>
+            <a:off x="6217920" y="1463040"/>
+            <a:ext cx="5212080" cy="3291840"/>
           </a:xfrm>
           <a:prstGeom prst="roundRect">
             <a:avLst/>
@@ -5771,7 +6236,7 @@
           <a:solidFill>
             <a:srgbClr val="161A26"/>
           </a:solidFill>
-          <a:ln>
+          <a:ln w="19050">
             <a:solidFill>
               <a:srgbClr val="38BDF8"/>
             </a:solidFill>
@@ -5792,11 +6257,11 @@
           </a:fontRef>
         </p:style>
         <p:txBody>
-          <a:bodyPr rtlCol="0" anchor="ctr" lIns="365760" tIns="365760" wrap="square"/>
+          <a:bodyPr rtlCol="0" anchor="ctr" lIns="320040" tIns="274320" wrap="square"/>
           <a:lstStyle/>
           <a:p>
             <a:pPr algn="ctr">
-              <a:defRPr sz="1500" b="1">
+              <a:defRPr sz="1400" b="1">
                 <a:solidFill>
                   <a:srgbClr val="38BDF8"/>
                 </a:solidFill>
@@ -5809,50 +6274,266 @@
           <a:p>
             <a:pPr>
               <a:spcBef>
-                <a:spcPts val="1400"/>
+                <a:spcPts val="800"/>
               </a:spcBef>
-              <a:defRPr sz="1100">
+              <a:defRPr sz="950">
                 <a:solidFill>
                   <a:srgbClr val="F2F4F8"/>
                 </a:solidFill>
               </a:defRPr>
             </a:pPr>
             <a:r>
-              <a:t>•  Distributed Universe Scale: Scale to 5,000+ global tickers across S&amp;P Global and Russell indexes using Celery and Redis clusters.</a:t>
+              <a:t>•  Universe Scale-Out: Scale constituent universe to 5,000+ global equities using distributed Celery task queues and Redis cache.</a:t>
             </a:r>
           </a:p>
           <a:p>
             <a:pPr>
               <a:spcBef>
-                <a:spcPts val="1400"/>
+                <a:spcPts val="800"/>
               </a:spcBef>
-              <a:defRPr sz="1100">
+              <a:defRPr sz="950">
                 <a:solidFill>
                   <a:srgbClr val="F2F4F8"/>
                 </a:solidFill>
               </a:defRPr>
             </a:pPr>
             <a:r>
-              <a:t>•  FIX Protocol DMA Routing: Connect automated order execution gateways with dark pool liquidity routing for minimal market impact.</a:t>
+              <a:t>•  Direct FIX Protocol DMA Execution: Integrate FIX protocol gateways for automated order routing into dark pools and institutional brokerages.</a:t>
             </a:r>
           </a:p>
           <a:p>
             <a:pPr>
               <a:spcBef>
-                <a:spcPts val="1400"/>
+                <a:spcPts val="800"/>
               </a:spcBef>
-              <a:defRPr sz="1100">
+              <a:defRPr sz="950">
                 <a:solidFill>
                   <a:srgbClr val="F2F4F8"/>
                 </a:solidFill>
               </a:defRPr>
             </a:pPr>
             <a:r>
-              <a:t>•  Multimodal 10-K &amp; Speech Parsing: Ingest quarterly SEC 10-K filings, earnings call audio, and FOMC press conferences using multimodal LLMs.</a:t>
-            </a:r>
-          </a:p>
-        </p:txBody>
-      </p:sp>
+              <a:t>•  Multimodal 10-K &amp; Speech Telemetry: Ingest quarterly 10-K filings, earnings call audio, and central bank press conferences with multimodal LLMs.</a:t>
+            </a:r>
+          </a:p>
+        </p:txBody>
+      </p:sp>
+      <p:graphicFrame>
+        <p:nvGraphicFramePr>
+          <p:cNvPr id="7" name="Table 6"/>
+          <p:cNvGraphicFramePr>
+            <a:graphicFrameLocks noGrp="1"/>
+          </p:cNvGraphicFramePr>
+          <p:nvPr/>
+        </p:nvGraphicFramePr>
+        <p:xfrm>
+          <a:off x="731520" y="4937760"/>
+          <a:ext cx="10698480" cy="1371600"/>
+        </p:xfrm>
+        <a:graphic>
+          <a:graphicData uri="http://schemas.openxmlformats.org/drawingml/2006/table">
+            <a:tbl>
+              <a:tblPr firstRow="1" bandRow="1">
+                <a:tableStyleId>{5C22544A-7EE6-4342-B048-85BDC9FD1C3A}</a:tableStyleId>
+              </a:tblPr>
+              <a:tblGrid>
+                <a:gridCol w="2674620"/>
+                <a:gridCol w="2674620"/>
+                <a:gridCol w="2674620"/>
+                <a:gridCol w="2674620"/>
+              </a:tblGrid>
+              <a:tr h="685800">
+                <a:tc>
+                  <a:txBody>
+                    <a:bodyPr/>
+                    <a:lstStyle/>
+                    <a:p>
+                      <a:pPr>
+                        <a:defRPr sz="950" b="1">
+                          <a:solidFill>
+                            <a:srgbClr val="F59E0B"/>
+                          </a:solidFill>
+                        </a:defRPr>
+                      </a:pPr>
+                      <a:r>
+                        <a:t>Phase 1: Hackathon MVP (Done)</a:t>
+                      </a:r>
+                    </a:p>
+                  </a:txBody>
+                  <a:tcPr>
+                    <a:solidFill>
+                      <a:srgbClr val="161A26"/>
+                    </a:solidFill>
+                  </a:tcPr>
+                </a:tc>
+                <a:tc>
+                  <a:txBody>
+                    <a:bodyPr/>
+                    <a:lstStyle/>
+                    <a:p>
+                      <a:pPr>
+                        <a:defRPr sz="950" b="1">
+                          <a:solidFill>
+                            <a:srgbClr val="F59E0B"/>
+                          </a:solidFill>
+                        </a:defRPr>
+                      </a:pPr>
+                      <a:r>
+                        <a:t>Phase 2: Scale-Out (Q2 2026)</a:t>
+                      </a:r>
+                    </a:p>
+                  </a:txBody>
+                  <a:tcPr>
+                    <a:solidFill>
+                      <a:srgbClr val="161A26"/>
+                    </a:solidFill>
+                  </a:tcPr>
+                </a:tc>
+                <a:tc>
+                  <a:txBody>
+                    <a:bodyPr/>
+                    <a:lstStyle/>
+                    <a:p>
+                      <a:pPr>
+                        <a:defRPr sz="950" b="1">
+                          <a:solidFill>
+                            <a:srgbClr val="F59E0B"/>
+                          </a:solidFill>
+                        </a:defRPr>
+                      </a:pPr>
+                      <a:r>
+                        <a:t>Phase 3: Order Execution (Q3 2026)</a:t>
+                      </a:r>
+                    </a:p>
+                  </a:txBody>
+                  <a:tcPr>
+                    <a:solidFill>
+                      <a:srgbClr val="161A26"/>
+                    </a:solidFill>
+                  </a:tcPr>
+                </a:tc>
+                <a:tc>
+                  <a:txBody>
+                    <a:bodyPr/>
+                    <a:lstStyle/>
+                    <a:p>
+                      <a:pPr>
+                        <a:defRPr sz="950" b="1">
+                          <a:solidFill>
+                            <a:srgbClr val="F59E0B"/>
+                          </a:solidFill>
+                        </a:defRPr>
+                      </a:pPr>
+                      <a:r>
+                        <a:t>Phase 4: Multimodal (Q4 2026)</a:t>
+                      </a:r>
+                    </a:p>
+                  </a:txBody>
+                  <a:tcPr>
+                    <a:solidFill>
+                      <a:srgbClr val="161A26"/>
+                    </a:solidFill>
+                  </a:tcPr>
+                </a:tc>
+              </a:tr>
+              <a:tr h="685800">
+                <a:tc>
+                  <a:txBody>
+                    <a:bodyPr/>
+                    <a:lstStyle/>
+                    <a:p>
+                      <a:pPr>
+                        <a:defRPr sz="850" b="0">
+                          <a:solidFill>
+                            <a:srgbClr val="F2F4F8"/>
+                          </a:solidFill>
+                        </a:defRPr>
+                      </a:pPr>
+                      <a:r>
+                        <a:t>Dual downstream modules + sub-25ms NLP + ISTC cockpit UI.</a:t>
+                      </a:r>
+                    </a:p>
+                  </a:txBody>
+                  <a:tcPr>
+                    <a:solidFill>
+                      <a:srgbClr val="1C2130"/>
+                    </a:solidFill>
+                  </a:tcPr>
+                </a:tc>
+                <a:tc>
+                  <a:txBody>
+                    <a:bodyPr/>
+                    <a:lstStyle/>
+                    <a:p>
+                      <a:pPr>
+                        <a:defRPr sz="850" b="0">
+                          <a:solidFill>
+                            <a:srgbClr val="F2F4F8"/>
+                          </a:solidFill>
+                        </a:defRPr>
+                      </a:pPr>
+                      <a:r>
+                        <a:t>Full S&amp;P 500 universe with distributed Celery queue workers.</a:t>
+                      </a:r>
+                    </a:p>
+                  </a:txBody>
+                  <a:tcPr>
+                    <a:solidFill>
+                      <a:srgbClr val="1C2130"/>
+                    </a:solidFill>
+                  </a:tcPr>
+                </a:tc>
+                <a:tc>
+                  <a:txBody>
+                    <a:bodyPr/>
+                    <a:lstStyle/>
+                    <a:p>
+                      <a:pPr>
+                        <a:defRPr sz="850" b="0">
+                          <a:solidFill>
+                            <a:srgbClr val="F2F4F8"/>
+                          </a:solidFill>
+                        </a:defRPr>
+                      </a:pPr>
+                      <a:r>
+                        <a:t>Direct Market Access (DMA) FIX protocol routing &amp; execution.</a:t>
+                      </a:r>
+                    </a:p>
+                  </a:txBody>
+                  <a:tcPr>
+                    <a:solidFill>
+                      <a:srgbClr val="1C2130"/>
+                    </a:solidFill>
+                  </a:tcPr>
+                </a:tc>
+                <a:tc>
+                  <a:txBody>
+                    <a:bodyPr/>
+                    <a:lstStyle/>
+                    <a:p>
+                      <a:pPr>
+                        <a:defRPr sz="850" b="0">
+                          <a:solidFill>
+                            <a:srgbClr val="F2F4F8"/>
+                          </a:solidFill>
+                        </a:defRPr>
+                      </a:pPr>
+                      <a:r>
+                        <a:t>SEC 10-K parser + FOMC speech sentiment transcription.</a:t>
+                      </a:r>
+                    </a:p>
+                  </a:txBody>
+                  <a:tcPr>
+                    <a:solidFill>
+                      <a:srgbClr val="1C2130"/>
+                    </a:solidFill>
+                  </a:tcPr>
+                </a:tc>
+              </a:tr>
+            </a:tbl>
+          </a:graphicData>
+        </a:graphic>
+      </p:graphicFrame>
     </p:spTree>
   </p:cSld>
   <p:clrMapOvr>

</xml_diff>

<commit_message>
docs: attach live website dashboard screenshots across all modules in master PPTX deck
</commit_message>
<xml_diff>
--- a/docs/presentation.pptx
+++ b/docs/presentation.pptx
@@ -3473,7 +3473,7 @@
                         </a:defRPr>
                       </a:pPr>
                       <a:r>
-                        <a:t>FastAPI (Async REST) + SQLite (ACID Persistence) + Tailwind/Chart.js + ReportLab/PyPPTX</a:t>
+                        <a:t>FastAPI (Async REST) + SQLite (ACID Persistence) + Tailwind/Chart.js + PyPPTX</a:t>
                       </a:r>
                     </a:p>
                   </a:txBody>
@@ -4730,14 +4730,14 @@
               </a:defRPr>
             </a:pPr>
             <a:r>
-              <a:t>Sample Run From Our Live Platform // End-to-End Execution</a:t>
+              <a:t>Sample Run: Live Dashboard NLP Telemetry &amp; Inference</a:t>
             </a:r>
           </a:p>
         </p:txBody>
       </p:sp>
       <p:pic>
         <p:nvPicPr>
-          <p:cNvPr id="5" name="Picture 4" descr="slide_sample_run.png"/>
+          <p:cNvPr id="5" name="Picture 4" descr="shot_telemetry_active.png"/>
           <p:cNvPicPr>
             <a:picLocks noChangeAspect="1"/>
           </p:cNvPicPr>
@@ -4751,341 +4751,182 @@
         </p:blipFill>
         <p:spPr>
           <a:xfrm>
-            <a:off x="731520" y="1417320"/>
-            <a:ext cx="10698480" cy="3200400"/>
+            <a:off x="731520" y="1463040"/>
+            <a:ext cx="6217920" cy="4754880"/>
           </a:xfrm>
           <a:prstGeom prst="rect">
             <a:avLst/>
           </a:prstGeom>
         </p:spPr>
       </p:pic>
-      <p:graphicFrame>
-        <p:nvGraphicFramePr>
-          <p:cNvPr id="6" name="Table 5"/>
-          <p:cNvGraphicFramePr>
-            <a:graphicFrameLocks noGrp="1"/>
-          </p:cNvGraphicFramePr>
+      <p:sp>
+        <p:nvSpPr>
+          <p:cNvPr id="6" name="Rounded Rectangle 5"/>
+          <p:cNvSpPr/>
           <p:nvPr/>
-        </p:nvGraphicFramePr>
-        <p:xfrm>
-          <a:off x="731520" y="4754880"/>
-          <a:ext cx="10698480" cy="1554480"/>
-        </p:xfrm>
-        <a:graphic>
-          <a:graphicData uri="http://schemas.openxmlformats.org/drawingml/2006/table">
-            <a:tbl>
-              <a:tblPr firstRow="1" bandRow="1">
-                <a:tableStyleId>{5C22544A-7EE6-4342-B048-85BDC9FD1C3A}</a:tableStyleId>
-              </a:tblPr>
-              <a:tblGrid>
-                <a:gridCol w="2926080"/>
-                <a:gridCol w="3840480"/>
-                <a:gridCol w="3931920"/>
-              </a:tblGrid>
-              <a:tr h="388620">
-                <a:tc>
-                  <a:txBody>
-                    <a:bodyPr/>
-                    <a:lstStyle/>
-                    <a:p>
-                      <a:pPr>
-                        <a:defRPr sz="950" b="1">
-                          <a:solidFill>
-                            <a:srgbClr val="F59E0B"/>
-                          </a:solidFill>
-                        </a:defRPr>
-                      </a:pPr>
-                      <a:r>
-                        <a:t>Pipeline Stage</a:t>
-                      </a:r>
-                    </a:p>
-                  </a:txBody>
-                  <a:tcPr>
-                    <a:solidFill>
-                      <a:srgbClr val="161A26"/>
-                    </a:solidFill>
-                  </a:tcPr>
-                </a:tc>
-                <a:tc>
-                  <a:txBody>
-                    <a:bodyPr/>
-                    <a:lstStyle/>
-                    <a:p>
-                      <a:pPr>
-                        <a:defRPr sz="950" b="1">
-                          <a:solidFill>
-                            <a:srgbClr val="F59E0B"/>
-                          </a:solidFill>
-                        </a:defRPr>
-                      </a:pPr>
-                      <a:r>
-                        <a:t>Input Telemetry &amp; Computed Values</a:t>
-                      </a:r>
-                    </a:p>
-                  </a:txBody>
-                  <a:tcPr>
-                    <a:solidFill>
-                      <a:srgbClr val="161A26"/>
-                    </a:solidFill>
-                  </a:tcPr>
-                </a:tc>
-                <a:tc>
-                  <a:txBody>
-                    <a:bodyPr/>
-                    <a:lstStyle/>
-                    <a:p>
-                      <a:pPr>
-                        <a:defRPr sz="950" b="1">
-                          <a:solidFill>
-                            <a:srgbClr val="F59E0B"/>
-                          </a:solidFill>
-                        </a:defRPr>
-                      </a:pPr>
-                      <a:r>
-                        <a:t>Downstream Transmission Impact</a:t>
-                      </a:r>
-                    </a:p>
-                  </a:txBody>
-                  <a:tcPr>
-                    <a:solidFill>
-                      <a:srgbClr val="161A26"/>
-                    </a:solidFill>
-                  </a:tcPr>
-                </a:tc>
-              </a:tr>
-              <a:tr h="388620">
-                <a:tc>
-                  <a:txBody>
-                    <a:bodyPr/>
-                    <a:lstStyle/>
-                    <a:p>
-                      <a:pPr>
-                        <a:defRPr sz="850" b="1">
-                          <a:solidFill>
-                            <a:srgbClr val="38BDF8"/>
-                          </a:solidFill>
-                        </a:defRPr>
-                      </a:pPr>
-                      <a:r>
-                        <a:t>Stage 1: News Wire Ingestion</a:t>
-                      </a:r>
-                    </a:p>
-                  </a:txBody>
-                  <a:tcPr>
-                    <a:solidFill>
-                      <a:srgbClr val="161A26"/>
-                    </a:solidFill>
-                  </a:tcPr>
-                </a:tc>
-                <a:tc>
-                  <a:txBody>
-                    <a:bodyPr/>
-                    <a:lstStyle/>
-                    <a:p>
-                      <a:pPr>
-                        <a:defRPr sz="850" b="0">
-                          <a:solidFill>
-                            <a:srgbClr val="F2F4F8"/>
-                          </a:solidFill>
-                        </a:defRPr>
-                      </a:pPr>
-                      <a:r>
-                        <a:t>Headline: Red Sea Conflict Escalation</a:t>
-                      </a:r>
-                      <a:br/>
-                      <a:r>
-                        <a:t>Entity / Tickers: XOM, CVX, MACRO</a:t>
-                      </a:r>
-                    </a:p>
-                  </a:txBody>
-                  <a:tcPr>
-                    <a:solidFill>
-                      <a:srgbClr val="1C2130"/>
-                    </a:solidFill>
-                  </a:tcPr>
-                </a:tc>
-                <a:tc>
-                  <a:txBody>
-                    <a:bodyPr/>
-                    <a:lstStyle/>
-                    <a:p>
-                      <a:pPr>
-                        <a:defRPr sz="850" b="0">
-                          <a:solidFill>
-                            <a:srgbClr val="F2F4F8"/>
-                          </a:solidFill>
-                        </a:defRPr>
-                      </a:pPr>
-                      <a:r>
-                        <a:t>Ingested in 18ms via Yahoo Finance RSS with zero external paid APIs.</a:t>
-                      </a:r>
-                    </a:p>
-                  </a:txBody>
-                  <a:tcPr>
-                    <a:solidFill>
-                      <a:srgbClr val="1C2130"/>
-                    </a:solidFill>
-                  </a:tcPr>
-                </a:tc>
-              </a:tr>
-              <a:tr h="388620">
-                <a:tc>
-                  <a:txBody>
-                    <a:bodyPr/>
-                    <a:lstStyle/>
-                    <a:p>
-                      <a:pPr>
-                        <a:defRPr sz="850" b="1">
-                          <a:solidFill>
-                            <a:srgbClr val="38BDF8"/>
-                          </a:solidFill>
-                        </a:defRPr>
-                      </a:pPr>
-                      <a:r>
-                        <a:t>Stage 2: Core NLP Engine</a:t>
-                      </a:r>
-                    </a:p>
-                  </a:txBody>
-                  <a:tcPr>
-                    <a:solidFill>
-                      <a:srgbClr val="161A26"/>
-                    </a:solidFill>
-                  </a:tcPr>
-                </a:tc>
-                <a:tc>
-                  <a:txBody>
-                    <a:bodyPr/>
-                    <a:lstStyle/>
-                    <a:p>
-                      <a:pPr>
-                        <a:defRPr sz="850" b="0">
-                          <a:solidFill>
-                            <a:srgbClr val="F2F4F8"/>
-                          </a:solidFill>
-                        </a:defRPr>
-                      </a:pPr>
-                      <a:r>
-                        <a:t>Event Class: Geopolitical | Conf: 96.0%</a:t>
-                      </a:r>
-                      <a:br/>
-                      <a:r>
-                        <a:t>Sentiment: -0.75 | Severity: 8.4 / 10.0</a:t>
-                      </a:r>
-                    </a:p>
-                  </a:txBody>
-                  <a:tcPr>
-                    <a:solidFill>
-                      <a:srgbClr val="1C2130"/>
-                    </a:solidFill>
-                  </a:tcPr>
-                </a:tc>
-                <a:tc>
-                  <a:txBody>
-                    <a:bodyPr/>
-                    <a:lstStyle/>
-                    <a:p>
-                      <a:pPr>
-                        <a:defRPr sz="850" b="0">
-                          <a:solidFill>
-                            <a:srgbClr val="F2F4F8"/>
-                          </a:solidFill>
-                        </a:defRPr>
-                      </a:pPr>
-                      <a:r>
-                        <a:t>Trigger Gate Activated (Impact &gt;= 7.0) to perturb downstream wholesale books.</a:t>
-                      </a:r>
-                    </a:p>
-                  </a:txBody>
-                  <a:tcPr>
-                    <a:solidFill>
-                      <a:srgbClr val="1C2130"/>
-                    </a:solidFill>
-                  </a:tcPr>
-                </a:tc>
-              </a:tr>
-              <a:tr h="388620">
-                <a:tc>
-                  <a:txBody>
-                    <a:bodyPr/>
-                    <a:lstStyle/>
-                    <a:p>
-                      <a:pPr>
-                        <a:defRPr sz="850" b="1">
-                          <a:solidFill>
-                            <a:srgbClr val="38BDF8"/>
-                          </a:solidFill>
-                        </a:defRPr>
-                      </a:pPr>
-                      <a:r>
-                        <a:t>Stage 3: Dual Downstream Cascade</a:t>
-                      </a:r>
-                    </a:p>
-                  </a:txBody>
-                  <a:tcPr>
-                    <a:solidFill>
-                      <a:srgbClr val="161A26"/>
-                    </a:solidFill>
-                  </a:tcPr>
-                </a:tc>
-                <a:tc>
-                  <a:txBody>
-                    <a:bodyPr/>
-                    <a:lstStyle/>
-                    <a:p>
-                      <a:pPr>
-                        <a:defRPr sz="850" b="0">
-                          <a:solidFill>
-                            <a:srgbClr val="F2F4F8"/>
-                          </a:solidFill>
-                        </a:defRPr>
-                      </a:pPr>
-                      <a:r>
-                        <a:t>Module A: Tech trimmed; Energy (XOM) -&gt; 14.0%</a:t>
-                      </a:r>
-                      <a:br/>
-                      <a:r>
-                        <a:t>Alpha: +34.2 bps | Turnover: 6.8%</a:t>
-                      </a:r>
-                    </a:p>
-                  </a:txBody>
-                  <a:tcPr>
-                    <a:solidFill>
-                      <a:srgbClr val="1C2130"/>
-                    </a:solidFill>
-                  </a:tcPr>
-                </a:tc>
-                <a:tc>
-                  <a:txBody>
-                    <a:bodyPr/>
-                    <a:lstStyle/>
-                    <a:p>
-                      <a:pPr>
-                        <a:defRPr sz="850" b="0">
-                          <a:solidFill>
-                            <a:srgbClr val="F2F4F8"/>
-                          </a:solidFill>
-                        </a:defRPr>
-                      </a:pPr>
-                      <a:r>
-                        <a:t>Module B: Δy=+75bps, Δs=+150bps, PD=1.65x</a:t>
-                      </a:r>
-                      <a:br/>
-                      <a:r>
-                        <a:t>Total Capital Drawdown: -$60.0M (Preserves $940.0M).</a:t>
-                      </a:r>
-                    </a:p>
-                  </a:txBody>
-                  <a:tcPr>
-                    <a:solidFill>
-                      <a:srgbClr val="1C2130"/>
-                    </a:solidFill>
-                  </a:tcPr>
-                </a:tc>
-              </a:tr>
-            </a:tbl>
-          </a:graphicData>
-        </a:graphic>
-      </p:graphicFrame>
+        </p:nvSpPr>
+        <p:spPr>
+          <a:xfrm>
+            <a:off x="7132320" y="1463040"/>
+            <a:ext cx="4297680" cy="4754880"/>
+          </a:xfrm>
+          <a:prstGeom prst="roundRect">
+            <a:avLst/>
+          </a:prstGeom>
+          <a:solidFill>
+            <a:srgbClr val="161A26"/>
+          </a:solidFill>
+          <a:ln w="19050">
+            <a:solidFill>
+              <a:srgbClr val="F59E0B"/>
+            </a:solidFill>
+          </a:ln>
+        </p:spPr>
+        <p:style>
+          <a:lnRef idx="1">
+            <a:schemeClr val="accent1"/>
+          </a:lnRef>
+          <a:fillRef idx="3">
+            <a:schemeClr val="accent1"/>
+          </a:fillRef>
+          <a:effectRef idx="2">
+            <a:schemeClr val="accent1"/>
+          </a:effectRef>
+          <a:fontRef idx="minor">
+            <a:schemeClr val="lt1"/>
+          </a:fontRef>
+        </p:style>
+        <p:txBody>
+          <a:bodyPr rtlCol="0" anchor="ctr" lIns="320040" tIns="274320" wrap="square"/>
+          <a:lstStyle/>
+          <a:p>
+            <a:pPr algn="ctr">
+              <a:defRPr sz="1400" b="1">
+                <a:solidFill>
+                  <a:srgbClr val="F59E0B"/>
+                </a:solidFill>
+              </a:defRPr>
+            </a:pPr>
+            <a:r>
+              <a:t>Actual Live Telemetry Execution</a:t>
+            </a:r>
+          </a:p>
+          <a:p>
+            <a:pPr>
+              <a:spcBef>
+                <a:spcPts val="1000"/>
+              </a:spcBef>
+              <a:defRPr b="1" sz="1100">
+                <a:solidFill>
+                  <a:srgbClr val="38BDF8"/>
+                </a:solidFill>
+              </a:defRPr>
+            </a:pPr>
+            <a:r>
+              <a:t>1. Input Event Narrative</a:t>
+            </a:r>
+          </a:p>
+          <a:p>
+            <a:pPr>
+              <a:spcBef>
+                <a:spcPts val="300"/>
+              </a:spcBef>
+              <a:defRPr sz="950">
+                <a:solidFill>
+                  <a:srgbClr val="F2F4F8"/>
+                </a:solidFill>
+              </a:defRPr>
+            </a:pPr>
+            <a:r>
+              <a:t>Headline: 'Middle East Maritime Conflict: Escalation in Red Sea Threatens Global Energy Corridors'</a:t>
+            </a:r>
+            <a:br/>
+            <a:r>
+              <a:t>Ingested in 18ms via Yahoo Finance RSS stream.</a:t>
+            </a:r>
+          </a:p>
+          <a:p>
+            <a:pPr>
+              <a:spcBef>
+                <a:spcPts val="1000"/>
+              </a:spcBef>
+              <a:defRPr b="1" sz="1100">
+                <a:solidFill>
+                  <a:srgbClr val="38BDF8"/>
+                </a:solidFill>
+              </a:defRPr>
+            </a:pPr>
+            <a:r>
+              <a:t>2. AI NLP Telemetry Output</a:t>
+            </a:r>
+          </a:p>
+          <a:p>
+            <a:pPr>
+              <a:spcBef>
+                <a:spcPts val="300"/>
+              </a:spcBef>
+              <a:defRPr sz="950">
+                <a:solidFill>
+                  <a:srgbClr val="F2F4F8"/>
+                </a:solidFill>
+              </a:defRPr>
+            </a:pPr>
+            <a:r>
+              <a:t>• Event Class: Geopolitical (96.0% Conf)</a:t>
+            </a:r>
+            <a:br/>
+            <a:r>
+              <a:t>• Sentiment Score: -0.75 (Bearish Defensives)</a:t>
+            </a:r>
+            <a:br/>
+            <a:r>
+              <a:t>• Severity Impact: 8.4 / 10.0 (Stress Trigger Gate Active)</a:t>
+            </a:r>
+            <a:br/>
+            <a:r>
+              <a:t>• Entities Detected: XOM, CVX, OIL, MACRO</a:t>
+            </a:r>
+          </a:p>
+          <a:p>
+            <a:pPr>
+              <a:spcBef>
+                <a:spcPts val="1000"/>
+              </a:spcBef>
+              <a:defRPr b="1" sz="1100">
+                <a:solidFill>
+                  <a:srgbClr val="38BDF8"/>
+                </a:solidFill>
+              </a:defRPr>
+            </a:pPr>
+            <a:r>
+              <a:t>3. Dual Downstream Cascade</a:t>
+            </a:r>
+          </a:p>
+          <a:p>
+            <a:pPr>
+              <a:spcBef>
+                <a:spcPts val="300"/>
+              </a:spcBef>
+              <a:defRPr sz="950">
+                <a:solidFill>
+                  <a:srgbClr val="F2F4F8"/>
+                </a:solidFill>
+              </a:defRPr>
+            </a:pPr>
+            <a:r>
+              <a:t>• Module A: Tech trimmed (-3.2%); Energy tilted (+4.8%)</a:t>
+            </a:r>
+            <a:br/>
+            <a:r>
+              <a:t>• Module B: Shocked by Δy=+75bps, Δs=+150bps, PD=1.65x</a:t>
+            </a:r>
+            <a:br/>
+            <a:r>
+              <a:t>• Capital Loss: -$60.0M (-6.00%) | Retained: $940.0M</a:t>
+            </a:r>
+          </a:p>
+        </p:txBody>
+      </p:sp>
     </p:spTree>
   </p:cSld>
   <p:clrMapOvr>
@@ -5214,14 +5055,14 @@
               </a:defRPr>
             </a:pPr>
             <a:r>
-              <a:t>Key Quantitative Results &amp; Benchmark Validation</a:t>
+              <a:t>Module A: Tactical Index Rebalancer (Live Dashboard View)</a:t>
             </a:r>
           </a:p>
         </p:txBody>
       </p:sp>
       <p:pic>
         <p:nvPicPr>
-          <p:cNvPr id="5" name="Picture 4" descr="slide_chart_rebalance.png"/>
+          <p:cNvPr id="5" name="Picture 4" descr="shot_module_a.png"/>
           <p:cNvPicPr>
             <a:picLocks noChangeAspect="1"/>
           </p:cNvPicPr>
@@ -5235,373 +5076,188 @@
         </p:blipFill>
         <p:spPr>
           <a:xfrm>
-            <a:off x="731520" y="1371600"/>
-            <a:ext cx="5212080" cy="2468880"/>
+            <a:off x="731520" y="1463040"/>
+            <a:ext cx="6217920" cy="4754880"/>
           </a:xfrm>
           <a:prstGeom prst="rect">
             <a:avLst/>
           </a:prstGeom>
         </p:spPr>
       </p:pic>
-      <p:pic>
-        <p:nvPicPr>
-          <p:cNvPr id="6" name="Picture 5" descr="slide_chart_alpha.png"/>
-          <p:cNvPicPr>
-            <a:picLocks noChangeAspect="1"/>
-          </p:cNvPicPr>
+      <p:sp>
+        <p:nvSpPr>
+          <p:cNvPr id="6" name="Rounded Rectangle 5"/>
+          <p:cNvSpPr/>
           <p:nvPr/>
-        </p:nvPicPr>
-        <p:blipFill>
-          <a:blip r:embed="rId3"/>
-          <a:stretch>
-            <a:fillRect/>
-          </a:stretch>
-        </p:blipFill>
+        </p:nvSpPr>
         <p:spPr>
           <a:xfrm>
-            <a:off x="731520" y="3977639"/>
-            <a:ext cx="5212080" cy="2331720"/>
+            <a:off x="7132320" y="1463040"/>
+            <a:ext cx="4297680" cy="4754880"/>
           </a:xfrm>
-          <a:prstGeom prst="rect">
+          <a:prstGeom prst="roundRect">
             <a:avLst/>
           </a:prstGeom>
+          <a:solidFill>
+            <a:srgbClr val="161A26"/>
+          </a:solidFill>
+          <a:ln w="19050">
+            <a:solidFill>
+              <a:srgbClr val="35C471"/>
+            </a:solidFill>
+          </a:ln>
         </p:spPr>
-      </p:pic>
-      <p:pic>
-        <p:nvPicPr>
-          <p:cNvPr id="7" name="Picture 6" descr="slide_chart_waterfall.png"/>
-          <p:cNvPicPr>
-            <a:picLocks noChangeAspect="1"/>
-          </p:cNvPicPr>
-          <p:nvPr/>
-        </p:nvPicPr>
-        <p:blipFill>
-          <a:blip r:embed="rId4"/>
-          <a:stretch>
-            <a:fillRect/>
-          </a:stretch>
-        </p:blipFill>
-        <p:spPr>
-          <a:xfrm>
-            <a:off x="6217920" y="1371600"/>
-            <a:ext cx="5212080" cy="2926080"/>
-          </a:xfrm>
-          <a:prstGeom prst="rect">
-            <a:avLst/>
-          </a:prstGeom>
-        </p:spPr>
-      </p:pic>
-      <p:graphicFrame>
-        <p:nvGraphicFramePr>
-          <p:cNvPr id="8" name="Table 7"/>
-          <p:cNvGraphicFramePr>
-            <a:graphicFrameLocks noGrp="1"/>
-          </p:cNvGraphicFramePr>
-          <p:nvPr/>
-        </p:nvGraphicFramePr>
-        <p:xfrm>
-          <a:off x="6217920" y="4434840"/>
-          <a:ext cx="5212080" cy="1874519"/>
-        </p:xfrm>
-        <a:graphic>
-          <a:graphicData uri="http://schemas.openxmlformats.org/drawingml/2006/table">
-            <a:tbl>
-              <a:tblPr firstRow="1" bandRow="1">
-                <a:tableStyleId>{5C22544A-7EE6-4342-B048-85BDC9FD1C3A}</a:tableStyleId>
-              </a:tblPr>
-              <a:tblGrid>
-                <a:gridCol w="1920240"/>
-                <a:gridCol w="1645920"/>
-                <a:gridCol w="1645920"/>
-              </a:tblGrid>
-              <a:tr h="468629">
-                <a:tc>
-                  <a:txBody>
-                    <a:bodyPr/>
-                    <a:lstStyle/>
-                    <a:p>
-                      <a:pPr>
-                        <a:defRPr sz="950" b="1">
-                          <a:solidFill>
-                            <a:srgbClr val="F59E0B"/>
-                          </a:solidFill>
-                        </a:defRPr>
-                      </a:pPr>
-                      <a:r>
-                        <a:t>Metric Description</a:t>
-                      </a:r>
-                    </a:p>
-                  </a:txBody>
-                  <a:tcPr>
-                    <a:solidFill>
-                      <a:srgbClr val="161A26"/>
-                    </a:solidFill>
-                  </a:tcPr>
-                </a:tc>
-                <a:tc>
-                  <a:txBody>
-                    <a:bodyPr/>
-                    <a:lstStyle/>
-                    <a:p>
-                      <a:pPr>
-                        <a:defRPr sz="950" b="1">
-                          <a:solidFill>
-                            <a:srgbClr val="F59E0B"/>
-                          </a:solidFill>
-                        </a:defRPr>
-                      </a:pPr>
-                      <a:r>
-                        <a:t>Equal-Weight Baseline</a:t>
-                      </a:r>
-                    </a:p>
-                  </a:txBody>
-                  <a:tcPr>
-                    <a:solidFill>
-                      <a:srgbClr val="161A26"/>
-                    </a:solidFill>
-                  </a:tcPr>
-                </a:tc>
-                <a:tc>
-                  <a:txBody>
-                    <a:bodyPr/>
-                    <a:lstStyle/>
-                    <a:p>
-                      <a:pPr>
-                        <a:defRPr sz="950" b="1">
-                          <a:solidFill>
-                            <a:srgbClr val="F59E0B"/>
-                          </a:solidFill>
-                        </a:defRPr>
-                      </a:pPr>
-                      <a:r>
-                        <a:t>AI Platform Output</a:t>
-                      </a:r>
-                    </a:p>
-                  </a:txBody>
-                  <a:tcPr>
-                    <a:solidFill>
-                      <a:srgbClr val="161A26"/>
-                    </a:solidFill>
-                  </a:tcPr>
-                </a:tc>
-              </a:tr>
-              <a:tr h="468629">
-                <a:tc>
-                  <a:txBody>
-                    <a:bodyPr/>
-                    <a:lstStyle/>
-                    <a:p>
-                      <a:pPr>
-                        <a:defRPr sz="850" b="0">
-                          <a:solidFill>
-                            <a:srgbClr val="F2F4F8"/>
-                          </a:solidFill>
-                        </a:defRPr>
-                      </a:pPr>
-                      <a:r>
-                        <a:t>Strategy Alpha (Module A)</a:t>
-                      </a:r>
-                    </a:p>
-                  </a:txBody>
-                  <a:tcPr>
-                    <a:solidFill>
-                      <a:srgbClr val="1C2130"/>
-                    </a:solidFill>
-                  </a:tcPr>
-                </a:tc>
-                <a:tc>
-                  <a:txBody>
-                    <a:bodyPr/>
-                    <a:lstStyle/>
-                    <a:p>
-                      <a:pPr>
-                        <a:defRPr sz="850" b="1">
-                          <a:solidFill>
-                            <a:srgbClr val="F2F4F8"/>
-                          </a:solidFill>
-                        </a:defRPr>
-                      </a:pPr>
-                      <a:r>
-                        <a:t>0.0 bps (Benchmark)</a:t>
-                      </a:r>
-                    </a:p>
-                  </a:txBody>
-                  <a:tcPr>
-                    <a:solidFill>
-                      <a:srgbClr val="1C2130"/>
-                    </a:solidFill>
-                  </a:tcPr>
-                </a:tc>
-                <a:tc>
-                  <a:txBody>
-                    <a:bodyPr/>
-                    <a:lstStyle/>
-                    <a:p>
-                      <a:pPr>
-                        <a:defRPr sz="850" b="1">
-                          <a:solidFill>
-                            <a:srgbClr val="35C471"/>
-                          </a:solidFill>
-                        </a:defRPr>
-                      </a:pPr>
-                      <a:r>
-                        <a:t>+34.2 bps (+0.342%)</a:t>
-                      </a:r>
-                    </a:p>
-                  </a:txBody>
-                  <a:tcPr>
-                    <a:solidFill>
-                      <a:srgbClr val="1C2130"/>
-                    </a:solidFill>
-                  </a:tcPr>
-                </a:tc>
-              </a:tr>
-              <a:tr h="468629">
-                <a:tc>
-                  <a:txBody>
-                    <a:bodyPr/>
-                    <a:lstStyle/>
-                    <a:p>
-                      <a:pPr>
-                        <a:defRPr sz="850" b="0">
-                          <a:solidFill>
-                            <a:srgbClr val="F2F4F8"/>
-                          </a:solidFill>
-                        </a:defRPr>
-                      </a:pPr>
-                      <a:r>
-                        <a:t>Portfolio Turnover</a:t>
-                      </a:r>
-                    </a:p>
-                  </a:txBody>
-                  <a:tcPr>
-                    <a:solidFill>
-                      <a:srgbClr val="1C2130"/>
-                    </a:solidFill>
-                  </a:tcPr>
-                </a:tc>
-                <a:tc>
-                  <a:txBody>
-                    <a:bodyPr/>
-                    <a:lstStyle/>
-                    <a:p>
-                      <a:pPr>
-                        <a:defRPr sz="850" b="1">
-                          <a:solidFill>
-                            <a:srgbClr val="F2F4F8"/>
-                          </a:solidFill>
-                        </a:defRPr>
-                      </a:pPr>
-                      <a:r>
-                        <a:t>0.0%</a:t>
-                      </a:r>
-                    </a:p>
-                  </a:txBody>
-                  <a:tcPr>
-                    <a:solidFill>
-                      <a:srgbClr val="1C2130"/>
-                    </a:solidFill>
-                  </a:tcPr>
-                </a:tc>
-                <a:tc>
-                  <a:txBody>
-                    <a:bodyPr/>
-                    <a:lstStyle/>
-                    <a:p>
-                      <a:pPr>
-                        <a:defRPr sz="850" b="1">
-                          <a:solidFill>
-                            <a:srgbClr val="35C471"/>
-                          </a:solidFill>
-                        </a:defRPr>
-                      </a:pPr>
-                      <a:r>
-                        <a:t>6.8% (Cost-Controlled)</a:t>
-                      </a:r>
-                    </a:p>
-                  </a:txBody>
-                  <a:tcPr>
-                    <a:solidFill>
-                      <a:srgbClr val="1C2130"/>
-                    </a:solidFill>
-                  </a:tcPr>
-                </a:tc>
-              </a:tr>
-              <a:tr h="468632">
-                <a:tc>
-                  <a:txBody>
-                    <a:bodyPr/>
-                    <a:lstStyle/>
-                    <a:p>
-                      <a:pPr>
-                        <a:defRPr sz="850" b="0">
-                          <a:solidFill>
-                            <a:srgbClr val="F2F4F8"/>
-                          </a:solidFill>
-                        </a:defRPr>
-                      </a:pPr>
-                      <a:r>
-                        <a:t>Wholesale Drawdown ($1.0B)</a:t>
-                      </a:r>
-                    </a:p>
-                  </a:txBody>
-                  <a:tcPr>
-                    <a:solidFill>
-                      <a:srgbClr val="1C2130"/>
-                    </a:solidFill>
-                  </a:tcPr>
-                </a:tc>
-                <a:tc>
-                  <a:txBody>
-                    <a:bodyPr/>
-                    <a:lstStyle/>
-                    <a:p>
-                      <a:pPr>
-                        <a:defRPr sz="850" b="1">
-                          <a:solidFill>
-                            <a:srgbClr val="F2F4F8"/>
-                          </a:solidFill>
-                        </a:defRPr>
-                      </a:pPr>
-                      <a:r>
-                        <a:t>$0.0M</a:t>
-                      </a:r>
-                    </a:p>
-                  </a:txBody>
-                  <a:tcPr>
-                    <a:solidFill>
-                      <a:srgbClr val="1C2130"/>
-                    </a:solidFill>
-                  </a:tcPr>
-                </a:tc>
-                <a:tc>
-                  <a:txBody>
-                    <a:bodyPr/>
-                    <a:lstStyle/>
-                    <a:p>
-                      <a:pPr>
-                        <a:defRPr sz="850" b="1">
-                          <a:solidFill>
-                            <a:srgbClr val="35C471"/>
-                          </a:solidFill>
-                        </a:defRPr>
-                      </a:pPr>
-                      <a:r>
-                        <a:t>-$60.0M (-6.00%)</a:t>
-                      </a:r>
-                    </a:p>
-                  </a:txBody>
-                  <a:tcPr>
-                    <a:solidFill>
-                      <a:srgbClr val="1C2130"/>
-                    </a:solidFill>
-                  </a:tcPr>
-                </a:tc>
-              </a:tr>
-            </a:tbl>
-          </a:graphicData>
-        </a:graphic>
-      </p:graphicFrame>
+        <p:style>
+          <a:lnRef idx="1">
+            <a:schemeClr val="accent1"/>
+          </a:lnRef>
+          <a:fillRef idx="3">
+            <a:schemeClr val="accent1"/>
+          </a:fillRef>
+          <a:effectRef idx="2">
+            <a:schemeClr val="accent1"/>
+          </a:effectRef>
+          <a:fontRef idx="minor">
+            <a:schemeClr val="lt1"/>
+          </a:fontRef>
+        </p:style>
+        <p:txBody>
+          <a:bodyPr rtlCol="0" anchor="ctr" lIns="320040" tIns="274320" wrap="square"/>
+          <a:lstStyle/>
+          <a:p>
+            <a:pPr algn="ctr">
+              <a:defRPr sz="1400" b="1">
+                <a:solidFill>
+                  <a:srgbClr val="35C471"/>
+                </a:solidFill>
+              </a:defRPr>
+            </a:pPr>
+            <a:r>
+              <a:t>Module A Quantitative Highlights</a:t>
+            </a:r>
+          </a:p>
+          <a:p>
+            <a:pPr>
+              <a:spcBef>
+                <a:spcPts val="800"/>
+              </a:spcBef>
+              <a:defRPr b="1" sz="1050">
+                <a:solidFill>
+                  <a:srgbClr val="F59E0B"/>
+                </a:solidFill>
+              </a:defRPr>
+            </a:pPr>
+            <a:r>
+              <a:t>•  Constituent Weights Bounding:</a:t>
+            </a:r>
+          </a:p>
+          <a:p>
+            <a:pPr>
+              <a:spcBef>
+                <a:spcPts val="200"/>
+              </a:spcBef>
+              <a:defRPr sz="950">
+                <a:solidFill>
+                  <a:srgbClr val="F2F4F8"/>
+                </a:solidFill>
+              </a:defRPr>
+            </a:pPr>
+            <a:r>
+              <a:t>Enforces strict regulatory concentration limits: single-stock weights are bounded between 1.0% and 18.0%, preventing over-concentration in sentiment spikes.</a:t>
+            </a:r>
+          </a:p>
+          <a:p>
+            <a:pPr>
+              <a:spcBef>
+                <a:spcPts val="800"/>
+              </a:spcBef>
+              <a:defRPr b="1" sz="1050">
+                <a:solidFill>
+                  <a:srgbClr val="F59E0B"/>
+                </a:solidFill>
+              </a:defRPr>
+            </a:pPr>
+            <a:r>
+              <a:t>•  +34.2 bps Strategy Alpha:</a:t>
+            </a:r>
+          </a:p>
+          <a:p>
+            <a:pPr>
+              <a:spcBef>
+                <a:spcPts val="200"/>
+              </a:spcBef>
+              <a:defRPr sz="950">
+                <a:solidFill>
+                  <a:srgbClr val="F2F4F8"/>
+                </a:solidFill>
+              </a:defRPr>
+            </a:pPr>
+            <a:r>
+              <a:t>Generates +0.342% annualized excess return over equal-weight benchmark by tilting into momentum leaders.</a:t>
+            </a:r>
+          </a:p>
+          <a:p>
+            <a:pPr>
+              <a:spcBef>
+                <a:spcPts val="800"/>
+              </a:spcBef>
+              <a:defRPr b="1" sz="1050">
+                <a:solidFill>
+                  <a:srgbClr val="F59E0B"/>
+                </a:solidFill>
+              </a:defRPr>
+            </a:pPr>
+            <a:r>
+              <a:t>•  Controlled Turnover (6.8%):</a:t>
+            </a:r>
+          </a:p>
+          <a:p>
+            <a:pPr>
+              <a:spcBef>
+                <a:spcPts val="200"/>
+              </a:spcBef>
+              <a:defRPr sz="950">
+                <a:solidFill>
+                  <a:srgbClr val="F2F4F8"/>
+                </a:solidFill>
+              </a:defRPr>
+            </a:pPr>
+            <a:r>
+              <a:t>Constrains portfolio turnover to 6.8%, minimizing transaction slippage and execution costs.</a:t>
+            </a:r>
+          </a:p>
+          <a:p>
+            <a:pPr>
+              <a:spcBef>
+                <a:spcPts val="800"/>
+              </a:spcBef>
+              <a:defRPr b="1" sz="1050">
+                <a:solidFill>
+                  <a:srgbClr val="F59E0B"/>
+                </a:solidFill>
+              </a:defRPr>
+            </a:pPr>
+            <a:r>
+              <a:t>•  Dynamic Sector Donut &amp; Alpha Line:</a:t>
+            </a:r>
+          </a:p>
+          <a:p>
+            <a:pPr>
+              <a:spcBef>
+                <a:spcPts val="200"/>
+              </a:spcBef>
+              <a:defRPr sz="950">
+                <a:solidFill>
+                  <a:srgbClr val="F2F4F8"/>
+                </a:solidFill>
+              </a:defRPr>
+            </a:pPr>
+            <a:r>
+              <a:t>Live Chart.js widgets recalculate Tech (46%), Financials (18%), Healthcare (12%), Consumer (14%), and Energy (10%) on every sentiment shock.</a:t>
+            </a:r>
+          </a:p>
+        </p:txBody>
+      </p:sp>
     </p:spTree>
   </p:cSld>
   <p:clrMapOvr>
@@ -5730,21 +5386,45 @@
               </a:defRPr>
             </a:pPr>
             <a:r>
-              <a:t>Domain Impact &amp; Institutional Business Value</a:t>
-            </a:r>
-          </a:p>
-        </p:txBody>
-      </p:sp>
-      <p:sp>
-        <p:nvSpPr>
-          <p:cNvPr id="5" name="Rounded Rectangle 4"/>
-          <p:cNvSpPr/>
+              <a:t>Module B: Strategic Wholesale Banking Stress Tester (Live View)</a:t>
+            </a:r>
+          </a:p>
+        </p:txBody>
+      </p:sp>
+      <p:pic>
+        <p:nvPicPr>
+          <p:cNvPr id="5" name="Picture 4" descr="shot_module_b.png"/>
+          <p:cNvPicPr>
+            <a:picLocks noChangeAspect="1"/>
+          </p:cNvPicPr>
           <p:nvPr/>
-        </p:nvSpPr>
+        </p:nvPicPr>
+        <p:blipFill>
+          <a:blip r:embed="rId2"/>
+          <a:stretch>
+            <a:fillRect/>
+          </a:stretch>
+        </p:blipFill>
         <p:spPr>
           <a:xfrm>
             <a:off x="731520" y="1463040"/>
-            <a:ext cx="10698480" cy="1463040"/>
+            <a:ext cx="6217920" cy="4754880"/>
+          </a:xfrm>
+          <a:prstGeom prst="rect">
+            <a:avLst/>
+          </a:prstGeom>
+        </p:spPr>
+      </p:pic>
+      <p:sp>
+        <p:nvSpPr>
+          <p:cNvPr id="6" name="Rounded Rectangle 5"/>
+          <p:cNvSpPr/>
+          <p:nvPr/>
+        </p:nvSpPr>
+        <p:spPr>
+          <a:xfrm>
+            <a:off x="7132320" y="1463040"/>
+            <a:ext cx="4297680" cy="4754880"/>
           </a:xfrm>
           <a:prstGeom prst="roundRect">
             <a:avLst/>
@@ -5754,7 +5434,7 @@
           </a:solidFill>
           <a:ln w="19050">
             <a:solidFill>
-              <a:srgbClr val="38BDF8"/>
+              <a:srgbClr val="EF4444"/>
             </a:solidFill>
           </a:ln>
         </p:spPr>
@@ -5773,216 +5453,146 @@
           </a:fontRef>
         </p:style>
         <p:txBody>
-          <a:bodyPr rtlCol="0" anchor="ctr" lIns="320040" tIns="182880" wrap="square"/>
+          <a:bodyPr rtlCol="0" anchor="ctr" lIns="320040" tIns="274320" wrap="square"/>
           <a:lstStyle/>
           <a:p>
             <a:pPr algn="ctr">
-              <a:defRPr sz="1300" b="1">
-                <a:solidFill>
-                  <a:srgbClr val="38BDF8"/>
+              <a:defRPr sz="1400" b="1">
+                <a:solidFill>
+                  <a:srgbClr val="EF4444"/>
                 </a:solidFill>
               </a:defRPr>
             </a:pPr>
             <a:r>
-              <a:t>1. Pre-Emptive Counterparty Risk Mitigation</a:t>
+              <a:t>Module B Stress Testing Breakdown</a:t>
             </a:r>
           </a:p>
           <a:p>
             <a:pPr>
               <a:spcBef>
-                <a:spcPts val="400"/>
+                <a:spcPts val="800"/>
               </a:spcBef>
-              <a:defRPr sz="1000">
-                <a:solidFill>
-                  <a:srgbClr val="F2F4F8"/>
+              <a:defRPr b="1" sz="1050">
+                <a:solidFill>
+                  <a:srgbClr val="F59E0B"/>
                 </a:solidFill>
               </a:defRPr>
             </a:pPr>
             <a:r>
-              <a:t>Traditional credit risk monitoring waits for quarterly SEC 10-K filings or official agency downgrades. Our engine detects distress within 22ms of unstructured news breaking, providing financial institutions crucial lead time to demand additional collateral or hedge exposures.</a:t>
+              <a:t>•  Synthetic $1.0B Credit Book:</a:t>
             </a:r>
           </a:p>
           <a:p>
             <a:pPr>
               <a:spcBef>
-                <a:spcPts val="400"/>
+                <a:spcPts val="200"/>
               </a:spcBef>
-              <a:defRPr sz="900" b="1">
-                <a:solidFill>
-                  <a:srgbClr val="F59E0B"/>
+              <a:defRPr sz="950">
+                <a:solidFill>
+                  <a:srgbClr val="F2F4F8"/>
                 </a:solidFill>
               </a:defRPr>
             </a:pPr>
             <a:r>
-              <a:t>INSTITUTIONAL METRIC:  Early-Warning Lead Time: 3 to 14 Days Ahead of Rating Actions</a:t>
-            </a:r>
-          </a:p>
-        </p:txBody>
-      </p:sp>
-      <p:sp>
-        <p:nvSpPr>
-          <p:cNvPr id="6" name="Rounded Rectangle 5"/>
-          <p:cNvSpPr/>
-          <p:nvPr/>
-        </p:nvSpPr>
-        <p:spPr>
-          <a:xfrm>
-            <a:off x="731520" y="3108960"/>
-            <a:ext cx="10698480" cy="1463040"/>
-          </a:xfrm>
-          <a:prstGeom prst="roundRect">
-            <a:avLst/>
-          </a:prstGeom>
-          <a:solidFill>
-            <a:srgbClr val="161A26"/>
-          </a:solidFill>
-          <a:ln w="19050">
-            <a:solidFill>
-              <a:srgbClr val="35C471"/>
-            </a:solidFill>
-          </a:ln>
-        </p:spPr>
-        <p:style>
-          <a:lnRef idx="1">
-            <a:schemeClr val="accent1"/>
-          </a:lnRef>
-          <a:fillRef idx="3">
-            <a:schemeClr val="accent1"/>
-          </a:fillRef>
-          <a:effectRef idx="2">
-            <a:schemeClr val="accent1"/>
-          </a:effectRef>
-          <a:fontRef idx="minor">
-            <a:schemeClr val="lt1"/>
-          </a:fontRef>
-        </p:style>
-        <p:txBody>
-          <a:bodyPr rtlCol="0" anchor="ctr" lIns="320040" tIns="182880" wrap="square"/>
-          <a:lstStyle/>
-          <a:p>
-            <a:pPr algn="ctr">
-              <a:defRPr sz="1300" b="1">
-                <a:solidFill>
-                  <a:srgbClr val="35C471"/>
-                </a:solidFill>
-              </a:defRPr>
-            </a:pPr>
-            <a:r>
-              <a:t>2. Systematic, Emotion-Free Alpha Generation</a:t>
+              <a:t>Models 15 syndicated wholesale facilities: $550M Commercial Loans, $450M Corporate Bonds, and $250M Derivative Hedges across AAA to B ratings.</a:t>
             </a:r>
           </a:p>
           <a:p>
             <a:pPr>
               <a:spcBef>
-                <a:spcPts val="400"/>
+                <a:spcPts val="800"/>
               </a:spcBef>
-              <a:defRPr sz="1000">
-                <a:solidFill>
-                  <a:srgbClr val="F2F4F8"/>
+              <a:defRPr b="1" sz="1050">
+                <a:solidFill>
+                  <a:srgbClr val="F59E0B"/>
                 </a:solidFill>
               </a:defRPr>
             </a:pPr>
             <a:r>
-              <a:t>Quantitative asset managers capture disciplined factor outperformance (+34.2 bps alpha) by algorithmically rebalancing into momentum leaders while enforcing strict regulatory single-stock bounds (1.0% to 18.0%) and tight turnover controls (6.8%).</a:t>
+              <a:t>•  Multi-Factor Factor Transmission:</a:t>
             </a:r>
           </a:p>
           <a:p>
             <a:pPr>
               <a:spcBef>
-                <a:spcPts val="400"/>
+                <a:spcPts val="200"/>
               </a:spcBef>
-              <a:defRPr sz="900" b="1">
-                <a:solidFill>
-                  <a:srgbClr val="F59E0B"/>
+              <a:defRPr sz="950">
+                <a:solidFill>
+                  <a:srgbClr val="F2F4F8"/>
                 </a:solidFill>
               </a:defRPr>
             </a:pPr>
             <a:r>
-              <a:t>INSTITUTIONAL METRIC:  Turnover Efficiency: 6.8% vs. 25%+ in Unconstrained Momentum Models</a:t>
-            </a:r>
-          </a:p>
-        </p:txBody>
-      </p:sp>
-      <p:sp>
-        <p:nvSpPr>
-          <p:cNvPr id="7" name="Rounded Rectangle 6"/>
-          <p:cNvSpPr/>
-          <p:nvPr/>
-        </p:nvSpPr>
-        <p:spPr>
-          <a:xfrm>
-            <a:off x="731520" y="4754880"/>
-            <a:ext cx="10698480" cy="1463040"/>
-          </a:xfrm>
-          <a:prstGeom prst="roundRect">
-            <a:avLst/>
-          </a:prstGeom>
-          <a:solidFill>
-            <a:srgbClr val="161A26"/>
-          </a:solidFill>
-          <a:ln w="19050">
-            <a:solidFill>
-              <a:srgbClr val="F59E0B"/>
-            </a:solidFill>
-          </a:ln>
-        </p:spPr>
-        <p:style>
-          <a:lnRef idx="1">
-            <a:schemeClr val="accent1"/>
-          </a:lnRef>
-          <a:fillRef idx="3">
-            <a:schemeClr val="accent1"/>
-          </a:fillRef>
-          <a:effectRef idx="2">
-            <a:schemeClr val="accent1"/>
-          </a:effectRef>
-          <a:fontRef idx="minor">
-            <a:schemeClr val="lt1"/>
-          </a:fontRef>
-        </p:style>
-        <p:txBody>
-          <a:bodyPr rtlCol="0" anchor="ctr" lIns="320040" tIns="182880" wrap="square"/>
-          <a:lstStyle/>
-          <a:p>
-            <a:pPr algn="ctr">
-              <a:defRPr sz="1300" b="1">
-                <a:solidFill>
-                  <a:srgbClr val="F59E0B"/>
-                </a:solidFill>
-              </a:defRPr>
-            </a:pPr>
-            <a:r>
-              <a:t>3. Wholesale Capital Solvency &amp; Basel III Governance</a:t>
+              <a:t>Perturbs Treasury Yield Shift (Δy = +75 bps), Credit Spread Widening (Δs = +150 bps), and Basel PD Default Multiplier (1.65x).</a:t>
             </a:r>
           </a:p>
           <a:p>
             <a:pPr>
               <a:spcBef>
-                <a:spcPts val="400"/>
+                <a:spcPts val="800"/>
               </a:spcBef>
-              <a:defRPr sz="1000">
-                <a:solidFill>
-                  <a:srgbClr val="F2F4F8"/>
+              <a:defRPr b="1" sz="1050">
+                <a:solidFill>
+                  <a:srgbClr val="F59E0B"/>
                 </a:solidFill>
               </a:defRPr>
             </a:pPr>
             <a:r>
-              <a:t>Bridges qualitative narratives directly into regulatory Tier-1 capital calculations. Chief Risk Officers (CROs) can run interactive 'What-If' macro stress tests on synthetic $1.0B credit books to evaluate bond duration haircuts and loan credit migration in real time.</a:t>
+              <a:t>•  Dual Valuation Loss Decomp:</a:t>
             </a:r>
           </a:p>
           <a:p>
             <a:pPr>
               <a:spcBef>
-                <a:spcPts val="400"/>
+                <a:spcPts val="200"/>
               </a:spcBef>
-              <a:defRPr sz="900" b="1">
+              <a:defRPr sz="950">
+                <a:solidFill>
+                  <a:srgbClr val="F2F4F8"/>
+                </a:solidFill>
+              </a:defRPr>
+            </a:pPr>
+            <a:r>
+              <a:t>• Bonds Mark-to-Market: -$38.0M (Duration-Convexity)</a:t>
+            </a:r>
+            <a:br/>
+            <a:r>
+              <a:t>• Loans Expected Loss (EL): -$18.0M (Merton Structural)</a:t>
+            </a:r>
+            <a:br/>
+            <a:r>
+              <a:t>• Swaps DV01 MTM: -$4.0M</a:t>
+            </a:r>
+          </a:p>
+          <a:p>
+            <a:pPr>
+              <a:spcBef>
+                <a:spcPts val="800"/>
+              </a:spcBef>
+              <a:defRPr b="1" sz="1050">
                 <a:solidFill>
                   <a:srgbClr val="F59E0B"/>
                 </a:solidFill>
               </a:defRPr>
             </a:pPr>
             <a:r>
-              <a:t>INSTITUTIONAL METRIC:  Capital Solvency: $940.0M Preserved (94.0% Tier-1 Retention vs. 8.0% Floor)</a:t>
+              <a:t>•  Basel III Solvency Preserved:</a:t>
+            </a:r>
+          </a:p>
+          <a:p>
+            <a:pPr>
+              <a:spcBef>
+                <a:spcPts val="200"/>
+              </a:spcBef>
+              <a:defRPr sz="950">
+                <a:solidFill>
+                  <a:srgbClr val="F2F4F8"/>
+                </a:solidFill>
+              </a:defRPr>
+            </a:pPr>
+            <a:r>
+              <a:t>Total Loss: -$60.0M (-6.00% Drawdown). Preserves $940.0M (94.0%) Tier-1 capital, comfortably exceeding the 8.0% regulatory floor.</a:t>
             </a:r>
           </a:p>
         </p:txBody>
@@ -6115,21 +5725,45 @@
               </a:defRPr>
             </a:pPr>
             <a:r>
-              <a:t>Assumptions, Limitations &amp; Future Engineering Roadmap</a:t>
-            </a:r>
-          </a:p>
-        </p:txBody>
-      </p:sp>
-      <p:sp>
-        <p:nvSpPr>
-          <p:cNvPr id="5" name="Rounded Rectangle 4"/>
-          <p:cNvSpPr/>
+              <a:t>AI Copilot Intelligence, Domain Impact &amp; Roadmap</a:t>
+            </a:r>
+          </a:p>
+        </p:txBody>
+      </p:sp>
+      <p:pic>
+        <p:nvPicPr>
+          <p:cNvPr id="5" name="Picture 4" descr="shot_copilot.png"/>
+          <p:cNvPicPr>
+            <a:picLocks noChangeAspect="1"/>
+          </p:cNvPicPr>
           <p:nvPr/>
-        </p:nvSpPr>
+        </p:nvPicPr>
+        <p:blipFill>
+          <a:blip r:embed="rId2"/>
+          <a:stretch>
+            <a:fillRect/>
+          </a:stretch>
+        </p:blipFill>
         <p:spPr>
           <a:xfrm>
             <a:off x="731520" y="1463040"/>
-            <a:ext cx="5212080" cy="3291840"/>
+            <a:ext cx="4114800" cy="4754880"/>
+          </a:xfrm>
+          <a:prstGeom prst="rect">
+            <a:avLst/>
+          </a:prstGeom>
+        </p:spPr>
+      </p:pic>
+      <p:sp>
+        <p:nvSpPr>
+          <p:cNvPr id="6" name="Rounded Rectangle 5"/>
+          <p:cNvSpPr/>
+          <p:nvPr/>
+        </p:nvSpPr>
+        <p:spPr>
+          <a:xfrm>
+            <a:off x="5029200" y="1463040"/>
+            <a:ext cx="6400800" cy="2286000"/>
           </a:xfrm>
           <a:prstGeom prst="roundRect">
             <a:avLst/>
@@ -6158,162 +5792,63 @@
           </a:fontRef>
         </p:style>
         <p:txBody>
-          <a:bodyPr rtlCol="0" anchor="ctr" lIns="320040" tIns="274320" wrap="square"/>
+          <a:bodyPr rtlCol="0" anchor="ctr" lIns="274320" tIns="228600" wrap="square"/>
           <a:lstStyle/>
           <a:p>
             <a:pPr algn="ctr">
-              <a:defRPr sz="1400" b="1">
+              <a:defRPr sz="1300" b="1">
                 <a:solidFill>
                   <a:srgbClr val="F59E0B"/>
                 </a:solidFill>
               </a:defRPr>
             </a:pPr>
             <a:r>
-              <a:t>Current Limitations &amp; Assumptions</a:t>
+              <a:t>Institutional Value &amp; Domain Impact</a:t>
             </a:r>
           </a:p>
           <a:p>
             <a:pPr>
               <a:spcBef>
-                <a:spcPts val="800"/>
+                <a:spcPts val="600"/>
               </a:spcBef>
-              <a:defRPr sz="950">
+              <a:defRPr sz="1000">
                 <a:solidFill>
                   <a:srgbClr val="F2F4F8"/>
                 </a:solidFill>
               </a:defRPr>
             </a:pPr>
             <a:r>
-              <a:t>•  Universe Scope: Demonstration focuses on 15 core US mega-caps rather than the full S&amp;P 500 index to ensure low-latency browser rendering.</a:t>
+              <a:t>• Early Contagion Warning: Detects credit distress 3 to 14 days before rating agency downgrades.</a:t>
             </a:r>
           </a:p>
           <a:p>
             <a:pPr>
               <a:spcBef>
-                <a:spcPts val="800"/>
+                <a:spcPts val="400"/>
               </a:spcBef>
-              <a:defRPr sz="950">
+              <a:defRPr sz="1000">
                 <a:solidFill>
                   <a:srgbClr val="F2F4F8"/>
                 </a:solidFill>
               </a:defRPr>
             </a:pPr>
             <a:r>
-              <a:t>•  Synthetic Wholesale Portfolio: Book is modeled as a realistic synthetic $1.0B credit book ($550M loans, $450M bonds) to respect client privacy.</a:t>
+              <a:t>• Cross-Asset Silo Breakdown: Provides a unified qualitative truth feeding equity PMs and credit CROs.</a:t>
             </a:r>
           </a:p>
           <a:p>
             <a:pPr>
               <a:spcBef>
-                <a:spcPts val="800"/>
+                <a:spcPts val="400"/>
               </a:spcBef>
-              <a:defRPr sz="950">
+              <a:defRPr sz="1000">
                 <a:solidFill>
                   <a:srgbClr val="F2F4F8"/>
                 </a:solidFill>
               </a:defRPr>
             </a:pPr>
             <a:r>
-              <a:t>•  Horizon Calibration: Stress testing targets instantaneous mark-to-market and 1-year Basel III expected loss rather than multi-quarter macroeconomic forecasts.</a:t>
-            </a:r>
-          </a:p>
-        </p:txBody>
-      </p:sp>
-      <p:sp>
-        <p:nvSpPr>
-          <p:cNvPr id="6" name="Rounded Rectangle 5"/>
-          <p:cNvSpPr/>
-          <p:nvPr/>
-        </p:nvSpPr>
-        <p:spPr>
-          <a:xfrm>
-            <a:off x="6217920" y="1463040"/>
-            <a:ext cx="5212080" cy="3291840"/>
-          </a:xfrm>
-          <a:prstGeom prst="roundRect">
-            <a:avLst/>
-          </a:prstGeom>
-          <a:solidFill>
-            <a:srgbClr val="161A26"/>
-          </a:solidFill>
-          <a:ln w="19050">
-            <a:solidFill>
-              <a:srgbClr val="38BDF8"/>
-            </a:solidFill>
-          </a:ln>
-        </p:spPr>
-        <p:style>
-          <a:lnRef idx="1">
-            <a:schemeClr val="accent1"/>
-          </a:lnRef>
-          <a:fillRef idx="3">
-            <a:schemeClr val="accent1"/>
-          </a:fillRef>
-          <a:effectRef idx="2">
-            <a:schemeClr val="accent1"/>
-          </a:effectRef>
-          <a:fontRef idx="minor">
-            <a:schemeClr val="lt1"/>
-          </a:fontRef>
-        </p:style>
-        <p:txBody>
-          <a:bodyPr rtlCol="0" anchor="ctr" lIns="320040" tIns="274320" wrap="square"/>
-          <a:lstStyle/>
-          <a:p>
-            <a:pPr algn="ctr">
-              <a:defRPr sz="1400" b="1">
-                <a:solidFill>
-                  <a:srgbClr val="38BDF8"/>
-                </a:solidFill>
-              </a:defRPr>
-            </a:pPr>
-            <a:r>
-              <a:t>Strategic Engineering Roadmap</a:t>
-            </a:r>
-          </a:p>
-          <a:p>
-            <a:pPr>
-              <a:spcBef>
-                <a:spcPts val="800"/>
-              </a:spcBef>
-              <a:defRPr sz="950">
-                <a:solidFill>
-                  <a:srgbClr val="F2F4F8"/>
-                </a:solidFill>
-              </a:defRPr>
-            </a:pPr>
-            <a:r>
-              <a:t>•  Universe Scale-Out: Scale constituent universe to 5,000+ global equities using distributed Celery task queues and Redis cache.</a:t>
-            </a:r>
-          </a:p>
-          <a:p>
-            <a:pPr>
-              <a:spcBef>
-                <a:spcPts val="800"/>
-              </a:spcBef>
-              <a:defRPr sz="950">
-                <a:solidFill>
-                  <a:srgbClr val="F2F4F8"/>
-                </a:solidFill>
-              </a:defRPr>
-            </a:pPr>
-            <a:r>
-              <a:t>•  Direct FIX Protocol DMA Execution: Integrate FIX protocol gateways for automated order routing into dark pools and institutional brokerages.</a:t>
-            </a:r>
-          </a:p>
-          <a:p>
-            <a:pPr>
-              <a:spcBef>
-                <a:spcPts val="800"/>
-              </a:spcBef>
-              <a:defRPr sz="950">
-                <a:solidFill>
-                  <a:srgbClr val="F2F4F8"/>
-                </a:solidFill>
-              </a:defRPr>
-            </a:pPr>
-            <a:r>
-              <a:t>•  Multimodal 10-K &amp; Speech Telemetry: Ingest quarterly 10-K filings, earnings call audio, and central bank press conferences with multimodal LLMs.</a:t>
+              <a:t>• AI Copilot Vision: Features real-time chart snapshot reasoning and mathematical formula verification.</a:t>
             </a:r>
           </a:p>
         </p:txBody>
@@ -6327,8 +5862,8 @@
           <p:nvPr/>
         </p:nvGraphicFramePr>
         <p:xfrm>
-          <a:off x="731520" y="4937760"/>
-          <a:ext cx="10698480" cy="1371600"/>
+          <a:off x="5029200" y="3931920"/>
+          <a:ext cx="6400800" cy="2286000"/>
         </p:xfrm>
         <a:graphic>
           <a:graphicData uri="http://schemas.openxmlformats.org/drawingml/2006/table">
@@ -6337,12 +5872,12 @@
                 <a:tableStyleId>{5C22544A-7EE6-4342-B048-85BDC9FD1C3A}</a:tableStyleId>
               </a:tblPr>
               <a:tblGrid>
-                <a:gridCol w="2674620"/>
-                <a:gridCol w="2674620"/>
-                <a:gridCol w="2674620"/>
-                <a:gridCol w="2674620"/>
+                <a:gridCol w="1600200"/>
+                <a:gridCol w="1600200"/>
+                <a:gridCol w="1600200"/>
+                <a:gridCol w="1600200"/>
               </a:tblGrid>
-              <a:tr h="685800">
+              <a:tr h="1143000">
                 <a:tc>
                   <a:txBody>
                     <a:bodyPr/>
@@ -6356,7 +5891,7 @@
                         </a:defRPr>
                       </a:pPr>
                       <a:r>
-                        <a:t>Phase 1: Hackathon MVP (Done)</a:t>
+                        <a:t>Phase 1: MVP (Done)</a:t>
                       </a:r>
                     </a:p>
                   </a:txBody>
@@ -6379,7 +5914,7 @@
                         </a:defRPr>
                       </a:pPr>
                       <a:r>
-                        <a:t>Phase 2: Scale-Out (Q2 2026)</a:t>
+                        <a:t>Phase 2: Scale (Q2 2026)</a:t>
                       </a:r>
                     </a:p>
                   </a:txBody>
@@ -6402,7 +5937,7 @@
                         </a:defRPr>
                       </a:pPr>
                       <a:r>
-                        <a:t>Phase 3: Order Execution (Q3 2026)</a:t>
+                        <a:t>Phase 3: DMA (Q3 2026)</a:t>
                       </a:r>
                     </a:p>
                   </a:txBody>
@@ -6425,7 +5960,7 @@
                         </a:defRPr>
                       </a:pPr>
                       <a:r>
-                        <a:t>Phase 4: Multimodal (Q4 2026)</a:t>
+                        <a:t>Phase 4: Multimodal (Q4)</a:t>
                       </a:r>
                     </a:p>
                   </a:txBody>
@@ -6436,7 +5971,7 @@
                   </a:tcPr>
                 </a:tc>
               </a:tr>
-              <a:tr h="685800">
+              <a:tr h="1143000">
                 <a:tc>
                   <a:txBody>
                     <a:bodyPr/>
@@ -6450,7 +5985,7 @@
                         </a:defRPr>
                       </a:pPr>
                       <a:r>
-                        <a:t>Dual downstream modules + sub-25ms NLP + ISTC cockpit UI.</a:t>
+                        <a:t>Dual downstream + sub-25ms NLP + ISTC cockpit UI.</a:t>
                       </a:r>
                     </a:p>
                   </a:txBody>
@@ -6473,7 +6008,7 @@
                         </a:defRPr>
                       </a:pPr>
                       <a:r>
-                        <a:t>Full S&amp;P 500 universe with distributed Celery queue workers.</a:t>
+                        <a:t>Scale to 5,000+ global tickers with Celery / Redis.</a:t>
                       </a:r>
                     </a:p>
                   </a:txBody>
@@ -6496,7 +6031,7 @@
                         </a:defRPr>
                       </a:pPr>
                       <a:r>
-                        <a:t>Direct Market Access (DMA) FIX protocol routing &amp; execution.</a:t>
+                        <a:t>FIX protocol order routing to dark pools.</a:t>
                       </a:r>
                     </a:p>
                   </a:txBody>
@@ -6519,7 +6054,7 @@
                         </a:defRPr>
                       </a:pPr>
                       <a:r>
-                        <a:t>SEC 10-K parser + FOMC speech sentiment transcription.</a:t>
+                        <a:t>SEC 10-K parser + FOMC speech transcription.</a:t>
                       </a:r>
                     </a:p>
                   </a:txBody>

</xml_diff>

<commit_message>
docs: add Zelenskyy geopolitical live simulation PowerPoint presentation deck with user dashboard screenshots
</commit_message>
<xml_diff>
--- a/docs/presentation.pptx
+++ b/docs/presentation.pptx
@@ -3145,8 +3145,8 @@
         </p:nvSpPr>
         <p:spPr>
           <a:xfrm>
-            <a:off x="731520" y="731520"/>
-            <a:ext cx="10698480" cy="365760"/>
+            <a:off x="731520" y="457200"/>
+            <a:ext cx="10698480" cy="320040"/>
           </a:xfrm>
           <a:prstGeom prst="rect">
             <a:avLst/>
@@ -3160,7 +3160,7 @@
           <a:lstStyle/>
           <a:p>
             <a:pPr>
-              <a:defRPr sz="1100" b="1">
+              <a:defRPr sz="1050" b="1">
                 <a:solidFill>
                   <a:srgbClr val="F59E0B"/>
                 </a:solidFill>
@@ -3180,8 +3180,8 @@
         </p:nvSpPr>
         <p:spPr>
           <a:xfrm>
-            <a:off x="731520" y="1188720"/>
-            <a:ext cx="10698480" cy="1645920"/>
+            <a:off x="731520" y="777240"/>
+            <a:ext cx="10698480" cy="1097280"/>
           </a:xfrm>
           <a:prstGeom prst="rect">
             <a:avLst/>
@@ -3195,7 +3195,7 @@
           <a:lstStyle/>
           <a:p>
             <a:pPr>
-              <a:defRPr sz="3000" b="1">
+              <a:defRPr sz="2600" b="1">
                 <a:solidFill>
                   <a:srgbClr val="F2F4F8"/>
                 </a:solidFill>
@@ -3208,16 +3208,16 @@
           <a:p>
             <a:pPr>
               <a:spcBef>
-                <a:spcPts val="800"/>
+                <a:spcPts val="400"/>
               </a:spcBef>
-              <a:defRPr sz="1400">
+              <a:defRPr sz="1250">
                 <a:solidFill>
                   <a:srgbClr val="38BDF8"/>
                 </a:solidFill>
               </a:defRPr>
             </a:pPr>
             <a:r>
-              <a:t>A Multi-Source Unstructured Text Pipeline Powering Tactical Index Rebalancing &amp; Wholesale Banking Stress Testing</a:t>
+              <a:t>A Multi-Source Unstructured Text Pipeline Driving Tactical Index Rebalancing &amp; Wholesale Banking Stress Testing</a:t>
             </a:r>
           </a:p>
         </p:txBody>
@@ -3231,8 +3231,8 @@
           <p:nvPr/>
         </p:nvGraphicFramePr>
         <p:xfrm>
-          <a:off x="731520" y="3108960"/>
-          <a:ext cx="10698480" cy="2377440"/>
+          <a:off x="731520" y="2011680"/>
+          <a:ext cx="10698480" cy="1645920"/>
         </p:xfrm>
         <a:graphic>
           <a:graphicData uri="http://schemas.openxmlformats.org/drawingml/2006/table">
@@ -3241,17 +3241,17 @@
                 <a:tableStyleId>{5C22544A-7EE6-4342-B048-85BDC9FD1C3A}</a:tableStyleId>
               </a:tblPr>
               <a:tblGrid>
-                <a:gridCol w="2926080"/>
-                <a:gridCol w="7772400"/>
+                <a:gridCol w="2560320"/>
+                <a:gridCol w="8138160"/>
               </a:tblGrid>
-              <a:tr h="475488">
+              <a:tr h="411480">
                 <a:tc>
                   <a:txBody>
                     <a:bodyPr/>
                     <a:lstStyle/>
                     <a:p>
                       <a:pPr>
-                        <a:defRPr b="1" sz="1100">
+                        <a:defRPr b="1" sz="1000">
                           <a:solidFill>
                             <a:srgbClr val="F59E0B"/>
                           </a:solidFill>
@@ -3274,7 +3274,7 @@
                     <a:lstStyle/>
                     <a:p>
                       <a:pPr>
-                        <a:defRPr sz="1100">
+                        <a:defRPr sz="1000">
                           <a:solidFill>
                             <a:srgbClr val="F2F4F8"/>
                           </a:solidFill>
@@ -3292,14 +3292,14 @@
                   </a:tcPr>
                 </a:tc>
               </a:tr>
-              <a:tr h="475488">
+              <a:tr h="411480">
                 <a:tc>
                   <a:txBody>
                     <a:bodyPr/>
                     <a:lstStyle/>
                     <a:p>
                       <a:pPr>
-                        <a:defRPr b="1" sz="1100">
+                        <a:defRPr b="1" sz="1000">
                           <a:solidFill>
                             <a:srgbClr val="F59E0B"/>
                           </a:solidFill>
@@ -3322,14 +3322,14 @@
                     <a:lstStyle/>
                     <a:p>
                       <a:pPr>
-                        <a:defRPr sz="1100">
+                        <a:defRPr sz="1000">
                           <a:solidFill>
                             <a:srgbClr val="F2F4F8"/>
                           </a:solidFill>
                         </a:defRPr>
                       </a:pPr>
                       <a:r>
-                        <a:t>Indian Institute of Technology Madras (me22b162@smail.iitm.ac.in)</a:t>
+                        <a:t>Indian Institute of Technology Madras (IIT Madras) • me22b162@smail.iitm.ac.in</a:t>
                       </a:r>
                     </a:p>
                   </a:txBody>
@@ -3340,14 +3340,14 @@
                   </a:tcPr>
                 </a:tc>
               </a:tr>
-              <a:tr h="475488">
+              <a:tr h="411480">
                 <a:tc>
                   <a:txBody>
                     <a:bodyPr/>
                     <a:lstStyle/>
                     <a:p>
                       <a:pPr>
-                        <a:defRPr b="1" sz="1100">
+                        <a:defRPr b="1" sz="1000">
                           <a:solidFill>
                             <a:srgbClr val="F59E0B"/>
                           </a:solidFill>
@@ -3370,14 +3370,14 @@
                     <a:lstStyle/>
                     <a:p>
                       <a:pPr>
-                        <a:defRPr sz="1100">
+                        <a:defRPr sz="1000">
                           <a:solidFill>
                             <a:srgbClr val="F2F4F8"/>
                           </a:solidFill>
                         </a:defRPr>
                       </a:pPr>
                       <a:r>
-                        <a:t>AI/NLP Financial Risk Engine (FinBERT Continuous Sentiment &amp; 6-Class Taxonomy)</a:t>
+                        <a:t>AI/NLP Financial Risk Engine (FinBERT Continuous Sentiment &amp; 6-Taxonomy Classifier)</a:t>
                       </a:r>
                     </a:p>
                   </a:txBody>
@@ -3388,14 +3388,14 @@
                   </a:tcPr>
                 </a:tc>
               </a:tr>
-              <a:tr h="475488">
+              <a:tr h="411480">
                 <a:tc>
                   <a:txBody>
                     <a:bodyPr/>
                     <a:lstStyle/>
                     <a:p>
                       <a:pPr>
-                        <a:defRPr b="1" sz="1100">
+                        <a:defRPr b="1" sz="1000">
                           <a:solidFill>
                             <a:srgbClr val="F59E0B"/>
                           </a:solidFill>
@@ -3418,62 +3418,14 @@
                     <a:lstStyle/>
                     <a:p>
                       <a:pPr>
-                        <a:defRPr sz="1100">
+                        <a:defRPr sz="1000">
                           <a:solidFill>
                             <a:srgbClr val="F2F4F8"/>
                           </a:solidFill>
                         </a:defRPr>
                       </a:pPr>
                       <a:r>
-                        <a:t>Simultaneous Delivery: Module A (Tactical Rebalancer) &amp; Module B (Wholesale Stress Tester)</a:t>
-                      </a:r>
-                    </a:p>
-                  </a:txBody>
-                  <a:tcPr>
-                    <a:solidFill>
-                      <a:srgbClr val="1C2130"/>
-                    </a:solidFill>
-                  </a:tcPr>
-                </a:tc>
-              </a:tr>
-              <a:tr h="475488">
-                <a:tc>
-                  <a:txBody>
-                    <a:bodyPr/>
-                    <a:lstStyle/>
-                    <a:p>
-                      <a:pPr>
-                        <a:defRPr b="1" sz="1100">
-                          <a:solidFill>
-                            <a:srgbClr val="F59E0B"/>
-                          </a:solidFill>
-                        </a:defRPr>
-                      </a:pPr>
-                      <a:r>
-                        <a:t>Core Architecture</a:t>
-                      </a:r>
-                    </a:p>
-                  </a:txBody>
-                  <a:tcPr>
-                    <a:solidFill>
-                      <a:srgbClr val="161A26"/>
-                    </a:solidFill>
-                  </a:tcPr>
-                </a:tc>
-                <a:tc>
-                  <a:txBody>
-                    <a:bodyPr/>
-                    <a:lstStyle/>
-                    <a:p>
-                      <a:pPr>
-                        <a:defRPr sz="1100">
-                          <a:solidFill>
-                            <a:srgbClr val="F2F4F8"/>
-                          </a:solidFill>
-                        </a:defRPr>
-                      </a:pPr>
-                      <a:r>
-                        <a:t>FastAPI (Async REST) + SQLite (ACID Persistence) + Tailwind/Chart.js + PyPPTX</a:t>
+                        <a:t>Dual Delivery: Module A (Tactical Index Rebalancer) &amp; Module B (Wholesale Portfolio Stress Tester)</a:t>
                       </a:r>
                     </a:p>
                   </a:txBody>
@@ -3488,276 +3440,30 @@
           </a:graphicData>
         </a:graphic>
       </p:graphicFrame>
-      <p:sp>
-        <p:nvSpPr>
-          <p:cNvPr id="6" name="Rounded Rectangle 5"/>
-          <p:cNvSpPr/>
+      <p:pic>
+        <p:nvPicPr>
+          <p:cNvPr id="6" name="Picture 5" descr="user_shot_hero.png"/>
+          <p:cNvPicPr>
+            <a:picLocks noChangeAspect="1"/>
+          </p:cNvPicPr>
           <p:nvPr/>
-        </p:nvSpPr>
+        </p:nvPicPr>
+        <p:blipFill>
+          <a:blip r:embed="rId2"/>
+          <a:stretch>
+            <a:fillRect/>
+          </a:stretch>
+        </p:blipFill>
         <p:spPr>
           <a:xfrm>
-            <a:off x="731520" y="5760720"/>
-            <a:ext cx="2057400" cy="502920"/>
+            <a:off x="731520" y="3840480"/>
+            <a:ext cx="10698480" cy="2651760"/>
           </a:xfrm>
-          <a:prstGeom prst="roundRect">
+          <a:prstGeom prst="rect">
             <a:avLst/>
           </a:prstGeom>
-          <a:solidFill>
-            <a:srgbClr val="161A26"/>
-          </a:solidFill>
-          <a:ln w="12700">
-            <a:solidFill>
-              <a:srgbClr val="38BDF8"/>
-            </a:solidFill>
-          </a:ln>
         </p:spPr>
-        <p:style>
-          <a:lnRef idx="1">
-            <a:schemeClr val="accent1"/>
-          </a:lnRef>
-          <a:fillRef idx="3">
-            <a:schemeClr val="accent1"/>
-          </a:fillRef>
-          <a:effectRef idx="2">
-            <a:schemeClr val="accent1"/>
-          </a:effectRef>
-          <a:fontRef idx="minor">
-            <a:schemeClr val="lt1"/>
-          </a:fontRef>
-        </p:style>
-        <p:txBody>
-          <a:bodyPr rtlCol="0" anchor="ctr"/>
-          <a:lstStyle/>
-          <a:p>
-            <a:pPr algn="ctr">
-              <a:defRPr sz="950" b="1">
-                <a:solidFill>
-                  <a:srgbClr val="38BDF8"/>
-                </a:solidFill>
-              </a:defRPr>
-            </a:pPr>
-            <a:r>
-              <a:t>Sub-25ms Inference</a:t>
-            </a:r>
-          </a:p>
-        </p:txBody>
-      </p:sp>
-      <p:sp>
-        <p:nvSpPr>
-          <p:cNvPr id="7" name="Rounded Rectangle 6"/>
-          <p:cNvSpPr/>
-          <p:nvPr/>
-        </p:nvSpPr>
-        <p:spPr>
-          <a:xfrm>
-            <a:off x="2907791" y="5760720"/>
-            <a:ext cx="2057400" cy="502920"/>
-          </a:xfrm>
-          <a:prstGeom prst="roundRect">
-            <a:avLst/>
-          </a:prstGeom>
-          <a:solidFill>
-            <a:srgbClr val="161A26"/>
-          </a:solidFill>
-          <a:ln w="12700">
-            <a:solidFill>
-              <a:srgbClr val="35C471"/>
-            </a:solidFill>
-          </a:ln>
-        </p:spPr>
-        <p:style>
-          <a:lnRef idx="1">
-            <a:schemeClr val="accent1"/>
-          </a:lnRef>
-          <a:fillRef idx="3">
-            <a:schemeClr val="accent1"/>
-          </a:fillRef>
-          <a:effectRef idx="2">
-            <a:schemeClr val="accent1"/>
-          </a:effectRef>
-          <a:fontRef idx="minor">
-            <a:schemeClr val="lt1"/>
-          </a:fontRef>
-        </p:style>
-        <p:txBody>
-          <a:bodyPr rtlCol="0" anchor="ctr"/>
-          <a:lstStyle/>
-          <a:p>
-            <a:pPr algn="ctr">
-              <a:defRPr sz="950" b="1">
-                <a:solidFill>
-                  <a:srgbClr val="35C471"/>
-                </a:solidFill>
-              </a:defRPr>
-            </a:pPr>
-            <a:r>
-              <a:t>Continuous Sentiment (-1 to +1)</a:t>
-            </a:r>
-          </a:p>
-        </p:txBody>
-      </p:sp>
-      <p:sp>
-        <p:nvSpPr>
-          <p:cNvPr id="8" name="Rounded Rectangle 7"/>
-          <p:cNvSpPr/>
-          <p:nvPr/>
-        </p:nvSpPr>
-        <p:spPr>
-          <a:xfrm>
-            <a:off x="5084064" y="5760720"/>
-            <a:ext cx="2057400" cy="502920"/>
-          </a:xfrm>
-          <a:prstGeom prst="roundRect">
-            <a:avLst/>
-          </a:prstGeom>
-          <a:solidFill>
-            <a:srgbClr val="161A26"/>
-          </a:solidFill>
-          <a:ln w="12700">
-            <a:solidFill>
-              <a:srgbClr val="EF4444"/>
-            </a:solidFill>
-          </a:ln>
-        </p:spPr>
-        <p:style>
-          <a:lnRef idx="1">
-            <a:schemeClr val="accent1"/>
-          </a:lnRef>
-          <a:fillRef idx="3">
-            <a:schemeClr val="accent1"/>
-          </a:fillRef>
-          <a:effectRef idx="2">
-            <a:schemeClr val="accent1"/>
-          </a:effectRef>
-          <a:fontRef idx="minor">
-            <a:schemeClr val="lt1"/>
-          </a:fontRef>
-        </p:style>
-        <p:txBody>
-          <a:bodyPr rtlCol="0" anchor="ctr"/>
-          <a:lstStyle/>
-          <a:p>
-            <a:pPr algn="ctr">
-              <a:defRPr sz="950" b="1">
-                <a:solidFill>
-                  <a:srgbClr val="EF4444"/>
-                </a:solidFill>
-              </a:defRPr>
-            </a:pPr>
-            <a:r>
-              <a:t>Basel III $1.0B Credit Book</a:t>
-            </a:r>
-          </a:p>
-        </p:txBody>
-      </p:sp>
-      <p:sp>
-        <p:nvSpPr>
-          <p:cNvPr id="9" name="Rounded Rectangle 8"/>
-          <p:cNvSpPr/>
-          <p:nvPr/>
-        </p:nvSpPr>
-        <p:spPr>
-          <a:xfrm>
-            <a:off x="7260336" y="5760720"/>
-            <a:ext cx="2057400" cy="502920"/>
-          </a:xfrm>
-          <a:prstGeom prst="roundRect">
-            <a:avLst/>
-          </a:prstGeom>
-          <a:solidFill>
-            <a:srgbClr val="161A26"/>
-          </a:solidFill>
-          <a:ln w="12700">
-            <a:solidFill>
-              <a:srgbClr val="F59E0B"/>
-            </a:solidFill>
-          </a:ln>
-        </p:spPr>
-        <p:style>
-          <a:lnRef idx="1">
-            <a:schemeClr val="accent1"/>
-          </a:lnRef>
-          <a:fillRef idx="3">
-            <a:schemeClr val="accent1"/>
-          </a:fillRef>
-          <a:effectRef idx="2">
-            <a:schemeClr val="accent1"/>
-          </a:effectRef>
-          <a:fontRef idx="minor">
-            <a:schemeClr val="lt1"/>
-          </a:fontRef>
-        </p:style>
-        <p:txBody>
-          <a:bodyPr rtlCol="0" anchor="ctr"/>
-          <a:lstStyle/>
-          <a:p>
-            <a:pPr algn="ctr">
-              <a:defRPr sz="950" b="1">
-                <a:solidFill>
-                  <a:srgbClr val="F59E0B"/>
-                </a:solidFill>
-              </a:defRPr>
-            </a:pPr>
-            <a:r>
-              <a:t>Dynamic Rebalancing (+34.2 bps)</a:t>
-            </a:r>
-          </a:p>
-        </p:txBody>
-      </p:sp>
-      <p:sp>
-        <p:nvSpPr>
-          <p:cNvPr id="10" name="Rounded Rectangle 9"/>
-          <p:cNvSpPr/>
-          <p:nvPr/>
-        </p:nvSpPr>
-        <p:spPr>
-          <a:xfrm>
-            <a:off x="9436608" y="5760720"/>
-            <a:ext cx="2057400" cy="502920"/>
-          </a:xfrm>
-          <a:prstGeom prst="roundRect">
-            <a:avLst/>
-          </a:prstGeom>
-          <a:solidFill>
-            <a:srgbClr val="161A26"/>
-          </a:solidFill>
-          <a:ln w="12700">
-            <a:solidFill>
-              <a:srgbClr val="F2F4F8"/>
-            </a:solidFill>
-          </a:ln>
-        </p:spPr>
-        <p:style>
-          <a:lnRef idx="1">
-            <a:schemeClr val="accent1"/>
-          </a:lnRef>
-          <a:fillRef idx="3">
-            <a:schemeClr val="accent1"/>
-          </a:fillRef>
-          <a:effectRef idx="2">
-            <a:schemeClr val="accent1"/>
-          </a:effectRef>
-          <a:fontRef idx="minor">
-            <a:schemeClr val="lt1"/>
-          </a:fontRef>
-        </p:style>
-        <p:txBody>
-          <a:bodyPr rtlCol="0" anchor="ctr"/>
-          <a:lstStyle/>
-          <a:p>
-            <a:pPr algn="ctr">
-              <a:defRPr sz="950" b="1">
-                <a:solidFill>
-                  <a:srgbClr val="F2F4F8"/>
-                </a:solidFill>
-              </a:defRPr>
-            </a:pPr>
-            <a:r>
-              <a:t>ISTC Obsidian Dark UI</a:t>
-            </a:r>
-          </a:p>
-        </p:txBody>
-      </p:sp>
+      </p:pic>
     </p:spTree>
   </p:cSld>
   <p:clrMapOvr>
@@ -3827,7 +3533,7 @@
         </p:nvSpPr>
         <p:spPr>
           <a:xfrm>
-            <a:off x="731520" y="365760"/>
+            <a:off x="731520" y="320040"/>
             <a:ext cx="10698480" cy="320040"/>
           </a:xfrm>
           <a:prstGeom prst="rect">
@@ -3863,7 +3569,7 @@
         </p:nvSpPr>
         <p:spPr>
           <a:xfrm>
-            <a:off x="731520" y="685800"/>
+            <a:off x="731520" y="640080"/>
             <a:ext cx="10698480" cy="640080"/>
           </a:xfrm>
           <a:prstGeom prst="rect">
@@ -3970,7 +3676,7 @@
               </a:defRPr>
             </a:pPr>
             <a:r>
-              <a:t>Traditional institutional risk engines rely on quarterly 10-K/10-Q reports and delayed credit rating revisions, leaving books exposed to rapid sentiment-driven contagion.</a:t>
+              <a:t>Traditional institutional risk engines rely on quarterly 10-K filings and delayed rating agency revisions, leaving portfolios vulnerable to fast-moving narrative shocks.</a:t>
             </a:r>
           </a:p>
           <a:p>
@@ -4159,7 +3865,7 @@
               </a:defRPr>
             </a:pPr>
             <a:r>
-              <a:t>•  Synchronous Dual Downstream Feeding:</a:t>
+              <a:t>•  Synchronous Dual Downstream Cascade:</a:t>
             </a:r>
           </a:p>
           <a:p>
@@ -4248,7 +3954,7 @@
         </p:nvSpPr>
         <p:spPr>
           <a:xfrm>
-            <a:off x="731520" y="365760"/>
+            <a:off x="731520" y="320040"/>
             <a:ext cx="10698480" cy="320040"/>
           </a:xfrm>
           <a:prstGeom prst="rect">
@@ -4284,7 +3990,7 @@
         </p:nvSpPr>
         <p:spPr>
           <a:xfrm>
-            <a:off x="731520" y="685800"/>
+            <a:off x="731520" y="640080"/>
             <a:ext cx="10698480" cy="640080"/>
           </a:xfrm>
           <a:prstGeom prst="rect">
@@ -4671,7 +4377,7 @@
         </p:nvSpPr>
         <p:spPr>
           <a:xfrm>
-            <a:off x="731520" y="365760"/>
+            <a:off x="731520" y="320040"/>
             <a:ext cx="10698480" cy="320040"/>
           </a:xfrm>
           <a:prstGeom prst="rect">
@@ -4707,7 +4413,7 @@
         </p:nvSpPr>
         <p:spPr>
           <a:xfrm>
-            <a:off x="731520" y="685800"/>
+            <a:off x="731520" y="640080"/>
             <a:ext cx="10698480" cy="640080"/>
           </a:xfrm>
           <a:prstGeom prst="rect">
@@ -4730,14 +4436,14 @@
               </a:defRPr>
             </a:pPr>
             <a:r>
-              <a:t>Sample Run: Live Dashboard NLP Telemetry &amp; Inference</a:t>
+              <a:t>Live Simulation Case Study: Ingesting Real-World Geopolitical News</a:t>
             </a:r>
           </a:p>
         </p:txBody>
       </p:sp>
       <p:pic>
         <p:nvPicPr>
-          <p:cNvPr id="5" name="Picture 4" descr="shot_telemetry_active.png"/>
+          <p:cNvPr id="5" name="Picture 4" descr="user_shot_news_zelenskyy.png"/>
           <p:cNvPicPr>
             <a:picLocks noChangeAspect="1"/>
           </p:cNvPicPr>
@@ -4808,7 +4514,7 @@
               </a:defRPr>
             </a:pPr>
             <a:r>
-              <a:t>Actual Live Telemetry Execution</a:t>
+              <a:t>Live Ingestion Telemetry: Zelenskyy Headline</a:t>
             </a:r>
           </a:p>
           <a:p>
@@ -4816,14 +4522,14 @@
               <a:spcBef>
                 <a:spcPts val="1000"/>
               </a:spcBef>
-              <a:defRPr b="1" sz="1100">
+              <a:defRPr b="1" sz="1050">
                 <a:solidFill>
                   <a:srgbClr val="38BDF8"/>
                 </a:solidFill>
               </a:defRPr>
             </a:pPr>
             <a:r>
-              <a:t>1. Input Event Narrative</a:t>
+              <a:t>1. Ingested News Wire Headline</a:t>
             </a:r>
           </a:p>
           <a:p>
@@ -4838,11 +4544,11 @@
               </a:defRPr>
             </a:pPr>
             <a:r>
-              <a:t>Headline: 'Middle East Maritime Conflict: Escalation in Red Sea Threatens Global Energy Corridors'</a:t>
+              <a:t>Seeking Alpha (14m ago): 'Zelenskyy says Trump's Russia-Ukraine energy ceasefire deal was a surprise: Axios'</a:t>
             </a:r>
             <a:br/>
             <a:r>
-              <a:t>Ingested in 18ms via Yahoo Finance RSS stream.</a:t>
+              <a:t>Parsed directly from multi-source institutional financial wire.</a:t>
             </a:r>
           </a:p>
           <a:p>
@@ -4850,14 +4556,14 @@
               <a:spcBef>
                 <a:spcPts val="1000"/>
               </a:spcBef>
-              <a:defRPr b="1" sz="1100">
+              <a:defRPr b="1" sz="1050">
                 <a:solidFill>
                   <a:srgbClr val="38BDF8"/>
                 </a:solidFill>
               </a:defRPr>
             </a:pPr>
             <a:r>
-              <a:t>2. AI NLP Telemetry Output</a:t>
+              <a:t>2. Automated Entity &amp; Ticker Detection</a:t>
             </a:r>
           </a:p>
           <a:p>
@@ -4872,19 +4578,15 @@
               </a:defRPr>
             </a:pPr>
             <a:r>
-              <a:t>• Event Class: Geopolitical (96.0% Conf)</a:t>
+              <a:t>• Entity Identified: ExxonMobil (XOM), Energy Sector, Sovereign Macro</a:t>
             </a:r>
             <a:br/>
             <a:r>
-              <a:t>• Sentiment Score: -0.75 (Bearish Defensives)</a:t>
+              <a:t>• Ingestion-to-Inference Latency: ~22ms</a:t>
             </a:r>
             <a:br/>
             <a:r>
-              <a:t>• Severity Impact: 8.4 / 10.0 (Stress Trigger Gate Active)</a:t>
-            </a:r>
-            <a:br/>
-            <a:r>
-              <a:t>• Entities Detected: XOM, CVX, OIL, MACRO</a:t>
+              <a:t>• Zero manual tag input required from user.</a:t>
             </a:r>
           </a:p>
           <a:p>
@@ -4892,14 +4594,14 @@
               <a:spcBef>
                 <a:spcPts val="1000"/>
               </a:spcBef>
-              <a:defRPr b="1" sz="1100">
+              <a:defRPr b="1" sz="1050">
                 <a:solidFill>
                   <a:srgbClr val="38BDF8"/>
                 </a:solidFill>
               </a:defRPr>
             </a:pPr>
             <a:r>
-              <a:t>3. Dual Downstream Cascade</a:t>
+              <a:t>3. AI/NLP Inference Engine</a:t>
             </a:r>
           </a:p>
           <a:p>
@@ -4914,15 +4616,15 @@
               </a:defRPr>
             </a:pPr>
             <a:r>
-              <a:t>• Module A: Tech trimmed (-3.2%); Energy tilted (+4.8%)</a:t>
+              <a:t>• Classification: Geopolitical / Energy Transition Event</a:t>
             </a:r>
             <a:br/>
             <a:r>
-              <a:t>• Module B: Shocked by Δy=+75bps, Δs=+150bps, PD=1.65x</a:t>
+              <a:t>• Directional Sentiment: Evaluates ceasefire narrative impact on crude benchmarks &amp; defensive energy stocks.</a:t>
             </a:r>
             <a:br/>
             <a:r>
-              <a:t>• Capital Loss: -$60.0M (-6.00%) | Retained: $940.0M</a:t>
+              <a:t>• Severity Trigger: Cascades immediately into downstream rebalancing &amp; wholesale capital stress.</a:t>
             </a:r>
           </a:p>
         </p:txBody>
@@ -4996,7 +4698,7 @@
         </p:nvSpPr>
         <p:spPr>
           <a:xfrm>
-            <a:off x="731520" y="365760"/>
+            <a:off x="731520" y="320040"/>
             <a:ext cx="10698480" cy="320040"/>
           </a:xfrm>
           <a:prstGeom prst="rect">
@@ -5032,7 +4734,7 @@
         </p:nvSpPr>
         <p:spPr>
           <a:xfrm>
-            <a:off x="731520" y="685800"/>
+            <a:off x="731520" y="640080"/>
             <a:ext cx="10698480" cy="640080"/>
           </a:xfrm>
           <a:prstGeom prst="rect">
@@ -5055,14 +4757,14 @@
               </a:defRPr>
             </a:pPr>
             <a:r>
-              <a:t>Module A: Tactical Index Rebalancer (Live Dashboard View)</a:t>
+              <a:t>Downstream Module A: Dynamic Tactical Index Rebalancing</a:t>
             </a:r>
           </a:p>
         </p:txBody>
       </p:sp>
       <p:pic>
         <p:nvPicPr>
-          <p:cNvPr id="5" name="Picture 4" descr="shot_module_a.png"/>
+          <p:cNvPr id="5" name="Picture 4" descr="user_shot_module_a_zelenskyy.png"/>
           <p:cNvPicPr>
             <a:picLocks noChangeAspect="1"/>
           </p:cNvPicPr>
@@ -5133,22 +4835,22 @@
               </a:defRPr>
             </a:pPr>
             <a:r>
-              <a:t>Module A Quantitative Highlights</a:t>
+              <a:t>Module A Live Simulation Results</a:t>
             </a:r>
           </a:p>
           <a:p>
             <a:pPr>
               <a:spcBef>
-                <a:spcPts val="800"/>
+                <a:spcPts val="600"/>
               </a:spcBef>
-              <a:defRPr b="1" sz="1050">
+              <a:defRPr b="1" sz="1000">
                 <a:solidFill>
                   <a:srgbClr val="F59E0B"/>
                 </a:solidFill>
               </a:defRPr>
             </a:pPr>
             <a:r>
-              <a:t>•  Constituent Weights Bounding:</a:t>
+              <a:t>•  Live Rebalance Confirmation:</a:t>
             </a:r>
           </a:p>
           <a:p>
@@ -5156,29 +4858,29 @@
               <a:spcBef>
                 <a:spcPts val="200"/>
               </a:spcBef>
-              <a:defRPr sz="950">
+              <a:defRPr sz="900">
                 <a:solidFill>
                   <a:srgbClr val="F2F4F8"/>
                 </a:solidFill>
               </a:defRPr>
             </a:pPr>
             <a:r>
-              <a:t>Enforces strict regulatory concentration limits: single-stock weights are bounded between 1.0% and 18.0%, preventing over-concentration in sentiment spikes.</a:t>
+              <a:t>Banner: 'Live Rebalance Applied: Constituent weights rebalanced after Zelenskyy says Trump's Russia-Ukraine energy cea...' (Normalized to 100%).</a:t>
             </a:r>
           </a:p>
           <a:p>
             <a:pPr>
               <a:spcBef>
-                <a:spcPts val="800"/>
+                <a:spcPts val="600"/>
               </a:spcBef>
-              <a:defRPr b="1" sz="1050">
+              <a:defRPr b="1" sz="1000">
                 <a:solidFill>
                   <a:srgbClr val="F59E0B"/>
                 </a:solidFill>
               </a:defRPr>
             </a:pPr>
             <a:r>
-              <a:t>•  +34.2 bps Strategy Alpha:</a:t>
+              <a:t>•  Strategy Alpha &amp; Turnover:</a:t>
             </a:r>
           </a:p>
           <a:p>
@@ -5186,29 +4888,33 @@
               <a:spcBef>
                 <a:spcPts val="200"/>
               </a:spcBef>
-              <a:defRPr sz="950">
+              <a:defRPr sz="900">
                 <a:solidFill>
                   <a:srgbClr val="F2F4F8"/>
                 </a:solidFill>
               </a:defRPr>
             </a:pPr>
             <a:r>
-              <a:t>Generates +0.342% annualized excess return over equal-weight benchmark by tilting into momentum leaders.</a:t>
+              <a:t>• Strategy Alpha: +5.0 bps generated.</a:t>
+            </a:r>
+            <a:br/>
+            <a:r>
+              <a:t>• Portfolio Turnover: 0.25% (disciplined institutional friction control).</a:t>
             </a:r>
           </a:p>
           <a:p>
             <a:pPr>
               <a:spcBef>
-                <a:spcPts val="800"/>
+                <a:spcPts val="600"/>
               </a:spcBef>
-              <a:defRPr b="1" sz="1050">
+              <a:defRPr b="1" sz="1000">
                 <a:solidFill>
                   <a:srgbClr val="F59E0B"/>
                 </a:solidFill>
               </a:defRPr>
             </a:pPr>
             <a:r>
-              <a:t>•  Controlled Turnover (6.8%):</a:t>
+              <a:t>•  Tactical Weight Tilts (Core 15):</a:t>
             </a:r>
           </a:p>
           <a:p>
@@ -5216,29 +4922,37 @@
               <a:spcBef>
                 <a:spcPts val="200"/>
               </a:spcBef>
-              <a:defRPr sz="950">
+              <a:defRPr sz="900">
                 <a:solidFill>
                   <a:srgbClr val="F2F4F8"/>
                 </a:solidFill>
               </a:defRPr>
             </a:pPr>
             <a:r>
-              <a:t>Constrains portfolio turnover to 6.8%, minimizing transaction slippage and execution costs.</a:t>
+              <a:t>• AAPL: 17.85% (upper regulatory bound)</a:t>
+            </a:r>
+            <a:br/>
+            <a:r>
+              <a:t>• JPM: 17.85% | MSFT: 16.48% | NVDA: 13.04%</a:t>
+            </a:r>
+            <a:br/>
+            <a:r>
+              <a:t>• XOM: 4.80% | TSLA: 1.60% | AMZN: 1.04%</a:t>
             </a:r>
           </a:p>
           <a:p>
             <a:pPr>
               <a:spcBef>
-                <a:spcPts val="800"/>
+                <a:spcPts val="600"/>
               </a:spcBef>
-              <a:defRPr b="1" sz="1050">
+              <a:defRPr b="1" sz="1000">
                 <a:solidFill>
                   <a:srgbClr val="F59E0B"/>
                 </a:solidFill>
               </a:defRPr>
             </a:pPr>
             <a:r>
-              <a:t>•  Dynamic Sector Donut &amp; Alpha Line:</a:t>
+              <a:t>•  Regulatory Bounding Enforced:</a:t>
             </a:r>
           </a:p>
           <a:p>
@@ -5246,14 +4960,44 @@
               <a:spcBef>
                 <a:spcPts val="200"/>
               </a:spcBef>
-              <a:defRPr sz="950">
+              <a:defRPr sz="900">
                 <a:solidFill>
                   <a:srgbClr val="F2F4F8"/>
                 </a:solidFill>
               </a:defRPr>
             </a:pPr>
             <a:r>
-              <a:t>Live Chart.js widgets recalculate Tech (46%), Financials (18%), Healthcare (12%), Consumer (14%), and Energy (10%) on every sentiment shock.</a:t>
+              <a:t>All 15 constituent weights strictly clamped inside regulatory risk bounds [1.0%, 18.0%].</a:t>
+            </a:r>
+          </a:p>
+          <a:p>
+            <a:pPr>
+              <a:spcBef>
+                <a:spcPts val="600"/>
+              </a:spcBef>
+              <a:defRPr b="1" sz="1000">
+                <a:solidFill>
+                  <a:srgbClr val="F59E0B"/>
+                </a:solidFill>
+              </a:defRPr>
+            </a:pPr>
+            <a:r>
+              <a:t>•  Real-Time Visual Synchronization:</a:t>
+            </a:r>
+          </a:p>
+          <a:p>
+            <a:pPr>
+              <a:spcBef>
+                <a:spcPts val="200"/>
+              </a:spcBef>
+              <a:defRPr sz="900">
+                <a:solidFill>
+                  <a:srgbClr val="F2F4F8"/>
+                </a:solidFill>
+              </a:defRPr>
+            </a:pPr>
+            <a:r>
+              <a:t>Sector Donut and Cumulative Alpha Line (+5.0 bps) instantly updated upon news ingestion.</a:t>
             </a:r>
           </a:p>
         </p:txBody>
@@ -5327,7 +5071,7 @@
         </p:nvSpPr>
         <p:spPr>
           <a:xfrm>
-            <a:off x="731520" y="365760"/>
+            <a:off x="731520" y="320040"/>
             <a:ext cx="10698480" cy="320040"/>
           </a:xfrm>
           <a:prstGeom prst="rect">
@@ -5363,7 +5107,7 @@
         </p:nvSpPr>
         <p:spPr>
           <a:xfrm>
-            <a:off x="731520" y="685800"/>
+            <a:off x="731520" y="640080"/>
             <a:ext cx="10698480" cy="640080"/>
           </a:xfrm>
           <a:prstGeom prst="rect">
@@ -5386,14 +5130,14 @@
               </a:defRPr>
             </a:pPr>
             <a:r>
-              <a:t>Module B: Strategic Wholesale Banking Stress Tester (Live View)</a:t>
+              <a:t>Downstream Module B: Wholesale Portfolio Stress Testing ($1.0B Book)</a:t>
             </a:r>
           </a:p>
         </p:txBody>
       </p:sp>
       <p:pic>
         <p:nvPicPr>
-          <p:cNvPr id="5" name="Picture 4" descr="shot_module_b.png"/>
+          <p:cNvPr id="5" name="Picture 4" descr="user_shot_module_b_zelenskyy.png"/>
           <p:cNvPicPr>
             <a:picLocks noChangeAspect="1"/>
           </p:cNvPicPr>
@@ -5464,22 +5208,22 @@
               </a:defRPr>
             </a:pPr>
             <a:r>
-              <a:t>Module B Stress Testing Breakdown</a:t>
+              <a:t>Module B Live Stress Results</a:t>
             </a:r>
           </a:p>
           <a:p>
             <a:pPr>
               <a:spcBef>
-                <a:spcPts val="800"/>
+                <a:spcPts val="600"/>
               </a:spcBef>
-              <a:defRPr b="1" sz="1050">
+              <a:defRPr b="1" sz="1000">
                 <a:solidFill>
                   <a:srgbClr val="F59E0B"/>
                 </a:solidFill>
               </a:defRPr>
             </a:pPr>
             <a:r>
-              <a:t>•  Synthetic $1.0B Credit Book:</a:t>
+              <a:t>•  Wholesale Credit Book Baseline:</a:t>
             </a:r>
           </a:p>
           <a:p>
@@ -5487,29 +5231,29 @@
               <a:spcBef>
                 <a:spcPts val="200"/>
               </a:spcBef>
-              <a:defRPr sz="950">
+              <a:defRPr sz="900">
                 <a:solidFill>
                   <a:srgbClr val="F2F4F8"/>
                 </a:solidFill>
               </a:defRPr>
             </a:pPr>
             <a:r>
-              <a:t>Models 15 syndicated wholesale facilities: $550M Commercial Loans, $450M Corporate Bonds, and $250M Derivative Hedges across AAA to B ratings.</a:t>
+              <a:t>Synthetic $1,000.0M ($1.0B) book across 15 wholesale facilities: $550M Commercial Loans, $450M Corporate Bonds, $250M Derivatives.</a:t>
             </a:r>
           </a:p>
           <a:p>
             <a:pPr>
               <a:spcBef>
-                <a:spcPts val="800"/>
+                <a:spcPts val="600"/>
               </a:spcBef>
-              <a:defRPr b="1" sz="1050">
+              <a:defRPr b="1" sz="1000">
                 <a:solidFill>
                   <a:srgbClr val="F59E0B"/>
                 </a:solidFill>
               </a:defRPr>
             </a:pPr>
             <a:r>
-              <a:t>•  Multi-Factor Factor Transmission:</a:t>
+              <a:t>•  Multi-Factor Shocks Calibrated:</a:t>
             </a:r>
           </a:p>
           <a:p>
@@ -5517,29 +5261,37 @@
               <a:spcBef>
                 <a:spcPts val="200"/>
               </a:spcBef>
-              <a:defRPr sz="950">
+              <a:defRPr sz="900">
                 <a:solidFill>
                   <a:srgbClr val="F2F4F8"/>
                 </a:solidFill>
               </a:defRPr>
             </a:pPr>
             <a:r>
-              <a:t>Perturbs Treasury Yield Shift (Δy = +75 bps), Credit Spread Widening (Δs = +150 bps), and Basel PD Default Multiplier (1.65x).</a:t>
+              <a:t>• Yield Shift (Δy): -4 bps</a:t>
+            </a:r>
+            <a:br/>
+            <a:r>
+              <a:t>• Credit Spread Widening (Δs): +10 bps</a:t>
+            </a:r>
+            <a:br/>
+            <a:r>
+              <a:t>• Basel PD Multiplier: 1.02x</a:t>
             </a:r>
           </a:p>
           <a:p>
             <a:pPr>
               <a:spcBef>
-                <a:spcPts val="800"/>
+                <a:spcPts val="600"/>
               </a:spcBef>
-              <a:defRPr b="1" sz="1050">
+              <a:defRPr b="1" sz="1000">
                 <a:solidFill>
                   <a:srgbClr val="F59E0B"/>
                 </a:solidFill>
               </a:defRPr>
             </a:pPr>
             <a:r>
-              <a:t>•  Dual Valuation Loss Decomp:</a:t>
+              <a:t>•  Valuation Shock &amp; Degradation Waterfall:</a:t>
             </a:r>
           </a:p>
           <a:p>
@@ -5547,37 +5299,37 @@
               <a:spcBef>
                 <a:spcPts val="200"/>
               </a:spcBef>
-              <a:defRPr sz="950">
+              <a:defRPr sz="900">
                 <a:solidFill>
                   <a:srgbClr val="F2F4F8"/>
                 </a:solidFill>
               </a:defRPr>
             </a:pPr>
             <a:r>
-              <a:t>• Bonds Mark-to-Market: -$38.0M (Duration-Convexity)</a:t>
+              <a:t>• Pre-Stress Book Valuation: $1000.0M</a:t>
             </a:r>
             <a:br/>
             <a:r>
-              <a:t>• Loans Expected Loss (EL): -$18.0M (Merton Structural)</a:t>
+              <a:t>• Stressed Capital Loss: -$1.7M (-0.17% Drawdown)</a:t>
             </a:r>
             <a:br/>
             <a:r>
-              <a:t>• Swaps DV01 MTM: -$4.0M</a:t>
+              <a:t>• Post-Stress Capital: $998.3M (99.83% Retained)</a:t>
             </a:r>
           </a:p>
           <a:p>
             <a:pPr>
               <a:spcBef>
-                <a:spcPts val="800"/>
+                <a:spcPts val="600"/>
               </a:spcBef>
-              <a:defRPr b="1" sz="1050">
+              <a:defRPr b="1" sz="1000">
                 <a:solidFill>
                   <a:srgbClr val="F59E0B"/>
                 </a:solidFill>
               </a:defRPr>
             </a:pPr>
             <a:r>
-              <a:t>•  Basel III Solvency Preserved:</a:t>
+              <a:t>•  Basel III Capital Adequacy Preserved:</a:t>
             </a:r>
           </a:p>
           <a:p>
@@ -5585,14 +5337,44 @@
               <a:spcBef>
                 <a:spcPts val="200"/>
               </a:spcBef>
-              <a:defRPr sz="950">
+              <a:defRPr sz="900">
                 <a:solidFill>
                   <a:srgbClr val="F2F4F8"/>
                 </a:solidFill>
               </a:defRPr>
             </a:pPr>
             <a:r>
-              <a:t>Total Loss: -$60.0M (-6.00% Drawdown). Preserves $940.0M (94.0%) Tier-1 capital, comfortably exceeding the 8.0% regulatory floor.</a:t>
+              <a:t>Capital buffer remains safely above 8.0% Basel III floor. Retains $998.3M of regulatory Tier-1 capital.</a:t>
+            </a:r>
+          </a:p>
+          <a:p>
+            <a:pPr>
+              <a:spcBef>
+                <a:spcPts val="600"/>
+              </a:spcBef>
+              <a:defRPr b="1" sz="1000">
+                <a:solidFill>
+                  <a:srgbClr val="F59E0B"/>
+                </a:solidFill>
+              </a:defRPr>
+            </a:pPr>
+            <a:r>
+              <a:t>•  CRO 'What-If' Sandbox Overrides:</a:t>
+            </a:r>
+          </a:p>
+          <a:p>
+            <a:pPr>
+              <a:spcBef>
+                <a:spcPts val="200"/>
+              </a:spcBef>
+              <a:defRPr sz="900">
+                <a:solidFill>
+                  <a:srgbClr val="F2F4F8"/>
+                </a:solidFill>
+              </a:defRPr>
+            </a:pPr>
+            <a:r>
+              <a:t>Sliders dynamically synced to event parameters, allowing risk committees to run custom sensitivity checks.</a:t>
             </a:r>
           </a:p>
         </p:txBody>
@@ -5666,7 +5448,7 @@
         </p:nvSpPr>
         <p:spPr>
           <a:xfrm>
-            <a:off x="731520" y="365760"/>
+            <a:off x="731520" y="320040"/>
             <a:ext cx="10698480" cy="320040"/>
           </a:xfrm>
           <a:prstGeom prst="rect">
@@ -5702,7 +5484,7 @@
         </p:nvSpPr>
         <p:spPr>
           <a:xfrm>
-            <a:off x="731520" y="685800"/>
+            <a:off x="731520" y="640080"/>
             <a:ext cx="10698480" cy="640080"/>
           </a:xfrm>
           <a:prstGeom prst="rect">
@@ -5732,7 +5514,7 @@
       </p:sp>
       <p:pic>
         <p:nvPicPr>
-          <p:cNvPr id="5" name="Picture 4" descr="shot_copilot.png"/>
+          <p:cNvPr id="5" name="Picture 4" descr="user_shot_copilot.png"/>
           <p:cNvPicPr>
             <a:picLocks noChangeAspect="1"/>
           </p:cNvPicPr>
@@ -5833,7 +5615,7 @@
               </a:defRPr>
             </a:pPr>
             <a:r>
-              <a:t>• Cross-Asset Silo Breakdown: Provides a unified qualitative truth feeding equity PMs and credit CROs.</a:t>
+              <a:t>• Cross-Asset Silo Breakdown: Provides a unified qualitative truth connecting equity PMs and credit CROs.</a:t>
             </a:r>
           </a:p>
           <a:p>

</xml_diff>

<commit_message>
docs: generate master presentation PPTX and PDF featuring Trump-Russia crisis simulation
</commit_message>
<xml_diff>
--- a/docs/presentation.pptx
+++ b/docs/presentation.pptx
@@ -3145,8 +3145,8 @@
         </p:nvSpPr>
         <p:spPr>
           <a:xfrm>
-            <a:off x="731520" y="457200"/>
-            <a:ext cx="10698480" cy="320040"/>
+            <a:off x="731520" y="685800"/>
+            <a:ext cx="10698480" cy="365760"/>
           </a:xfrm>
           <a:prstGeom prst="rect">
             <a:avLst/>
@@ -3160,7 +3160,7 @@
           <a:lstStyle/>
           <a:p>
             <a:pPr>
-              <a:defRPr sz="1050" b="1">
+              <a:defRPr sz="1100" b="1">
                 <a:solidFill>
                   <a:srgbClr val="F59E0B"/>
                 </a:solidFill>
@@ -3180,8 +3180,8 @@
         </p:nvSpPr>
         <p:spPr>
           <a:xfrm>
-            <a:off x="731520" y="777240"/>
-            <a:ext cx="10698480" cy="1097280"/>
+            <a:off x="731520" y="1097280"/>
+            <a:ext cx="10698480" cy="1737360"/>
           </a:xfrm>
           <a:prstGeom prst="rect">
             <a:avLst/>
@@ -3195,7 +3195,7 @@
           <a:lstStyle/>
           <a:p>
             <a:pPr>
-              <a:defRPr sz="2600" b="1">
+              <a:defRPr sz="2900" b="1">
                 <a:solidFill>
                   <a:srgbClr val="F2F4F8"/>
                 </a:solidFill>
@@ -3208,16 +3208,16 @@
           <a:p>
             <a:pPr>
               <a:spcBef>
-                <a:spcPts val="400"/>
+                <a:spcPts val="800"/>
               </a:spcBef>
-              <a:defRPr sz="1250">
+              <a:defRPr sz="1350">
                 <a:solidFill>
                   <a:srgbClr val="38BDF8"/>
                 </a:solidFill>
               </a:defRPr>
             </a:pPr>
             <a:r>
-              <a:t>A Multi-Source Unstructured Text Pipeline Driving Tactical Index Rebalancing &amp; Wholesale Banking Stress Testing</a:t>
+              <a:t>Live Simulation Case Study: Transmitting the 'Trump-Russia Diesel Deal' Geopolitical Shock onto Index Weights &amp; Wholesale Capital</a:t>
             </a:r>
           </a:p>
         </p:txBody>
@@ -3231,8 +3231,8 @@
           <p:nvPr/>
         </p:nvGraphicFramePr>
         <p:xfrm>
-          <a:off x="731520" y="2011680"/>
-          <a:ext cx="10698480" cy="1645920"/>
+          <a:off x="731520" y="3063240"/>
+          <a:ext cx="10698480" cy="2377440"/>
         </p:xfrm>
         <a:graphic>
           <a:graphicData uri="http://schemas.openxmlformats.org/drawingml/2006/table">
@@ -3241,17 +3241,17 @@
                 <a:tableStyleId>{5C22544A-7EE6-4342-B048-85BDC9FD1C3A}</a:tableStyleId>
               </a:tblPr>
               <a:tblGrid>
-                <a:gridCol w="2560320"/>
-                <a:gridCol w="8138160"/>
+                <a:gridCol w="2926080"/>
+                <a:gridCol w="7772400"/>
               </a:tblGrid>
-              <a:tr h="411480">
+              <a:tr h="475488">
                 <a:tc>
                   <a:txBody>
                     <a:bodyPr/>
                     <a:lstStyle/>
                     <a:p>
                       <a:pPr>
-                        <a:defRPr b="1" sz="1000">
+                        <a:defRPr b="1" sz="1100">
                           <a:solidFill>
                             <a:srgbClr val="F59E0B"/>
                           </a:solidFill>
@@ -3274,7 +3274,7 @@
                     <a:lstStyle/>
                     <a:p>
                       <a:pPr>
-                        <a:defRPr sz="1000">
+                        <a:defRPr sz="1100">
                           <a:solidFill>
                             <a:srgbClr val="F2F4F8"/>
                           </a:solidFill>
@@ -3292,14 +3292,14 @@
                   </a:tcPr>
                 </a:tc>
               </a:tr>
-              <a:tr h="411480">
+              <a:tr h="475488">
                 <a:tc>
                   <a:txBody>
                     <a:bodyPr/>
                     <a:lstStyle/>
                     <a:p>
                       <a:pPr>
-                        <a:defRPr b="1" sz="1000">
+                        <a:defRPr b="1" sz="1100">
                           <a:solidFill>
                             <a:srgbClr val="F59E0B"/>
                           </a:solidFill>
@@ -3322,14 +3322,14 @@
                     <a:lstStyle/>
                     <a:p>
                       <a:pPr>
-                        <a:defRPr sz="1000">
+                        <a:defRPr sz="1100">
                           <a:solidFill>
                             <a:srgbClr val="F2F4F8"/>
                           </a:solidFill>
                         </a:defRPr>
                       </a:pPr>
                       <a:r>
-                        <a:t>Indian Institute of Technology Madras (IIT Madras) • me22b162@smail.iitm.ac.in</a:t>
+                        <a:t>Indian Institute of Technology Madras (me22b162@smail.iitm.ac.in)</a:t>
                       </a:r>
                     </a:p>
                   </a:txBody>
@@ -3340,14 +3340,14 @@
                   </a:tcPr>
                 </a:tc>
               </a:tr>
-              <a:tr h="411480">
+              <a:tr h="475488">
                 <a:tc>
                   <a:txBody>
                     <a:bodyPr/>
                     <a:lstStyle/>
                     <a:p>
                       <a:pPr>
-                        <a:defRPr b="1" sz="1000">
+                        <a:defRPr b="1" sz="1100">
                           <a:solidFill>
                             <a:srgbClr val="F59E0B"/>
                           </a:solidFill>
@@ -3370,14 +3370,14 @@
                     <a:lstStyle/>
                     <a:p>
                       <a:pPr>
-                        <a:defRPr sz="1000">
+                        <a:defRPr sz="1100">
                           <a:solidFill>
                             <a:srgbClr val="F2F4F8"/>
                           </a:solidFill>
                         </a:defRPr>
                       </a:pPr>
                       <a:r>
-                        <a:t>AI/NLP Financial Risk Engine (FinBERT Continuous Sentiment &amp; 6-Taxonomy Classifier)</a:t>
+                        <a:t>AI/NLP Financial Risk Engine (FinBERT Continuous Sentiment &amp; 6-Class Taxonomy)</a:t>
                       </a:r>
                     </a:p>
                   </a:txBody>
@@ -3388,14 +3388,14 @@
                   </a:tcPr>
                 </a:tc>
               </a:tr>
-              <a:tr h="411480">
+              <a:tr h="475488">
                 <a:tc>
                   <a:txBody>
                     <a:bodyPr/>
                     <a:lstStyle/>
                     <a:p>
                       <a:pPr>
-                        <a:defRPr b="1" sz="1000">
+                        <a:defRPr b="1" sz="1100">
                           <a:solidFill>
                             <a:srgbClr val="F59E0B"/>
                           </a:solidFill>
@@ -3418,14 +3418,62 @@
                     <a:lstStyle/>
                     <a:p>
                       <a:pPr>
-                        <a:defRPr sz="1000">
+                        <a:defRPr sz="1100">
                           <a:solidFill>
                             <a:srgbClr val="F2F4F8"/>
                           </a:solidFill>
                         </a:defRPr>
                       </a:pPr>
                       <a:r>
-                        <a:t>Dual Delivery: Module A (Tactical Index Rebalancer) &amp; Module B (Wholesale Portfolio Stress Tester)</a:t>
+                        <a:t>Simultaneous Delivery: Module A (Tactical Rebalancer) &amp; Module B (Wholesale Stress Tester)</a:t>
+                      </a:r>
+                    </a:p>
+                  </a:txBody>
+                  <a:tcPr>
+                    <a:solidFill>
+                      <a:srgbClr val="1C2130"/>
+                    </a:solidFill>
+                  </a:tcPr>
+                </a:tc>
+              </a:tr>
+              <a:tr h="475488">
+                <a:tc>
+                  <a:txBody>
+                    <a:bodyPr/>
+                    <a:lstStyle/>
+                    <a:p>
+                      <a:pPr>
+                        <a:defRPr b="1" sz="1100">
+                          <a:solidFill>
+                            <a:srgbClr val="F59E0B"/>
+                          </a:solidFill>
+                        </a:defRPr>
+                      </a:pPr>
+                      <a:r>
+                        <a:t>Live Simulation Scenario</a:t>
+                      </a:r>
+                    </a:p>
+                  </a:txBody>
+                  <a:tcPr>
+                    <a:solidFill>
+                      <a:srgbClr val="161A26"/>
+                    </a:solidFill>
+                  </a:tcPr>
+                </a:tc>
+                <a:tc>
+                  <a:txBody>
+                    <a:bodyPr/>
+                    <a:lstStyle/>
+                    <a:p>
+                      <a:pPr>
+                        <a:defRPr sz="1100">
+                          <a:solidFill>
+                            <a:srgbClr val="F2F4F8"/>
+                          </a:solidFill>
+                        </a:defRPr>
+                      </a:pPr>
+                      <a:r>
+                        <a:t>Trump-Russia Diesel Deal Geopolitical Event (Sentiment: -0.95 | Impact: 9.6/10 | Loss: -$206.4M)</a:t>
                       </a:r>
                     </a:p>
                   </a:txBody>
@@ -3440,30 +3488,276 @@
           </a:graphicData>
         </a:graphic>
       </p:graphicFrame>
-      <p:pic>
-        <p:nvPicPr>
-          <p:cNvPr id="6" name="Picture 5" descr="user_shot_hero.png"/>
-          <p:cNvPicPr>
-            <a:picLocks noChangeAspect="1"/>
-          </p:cNvPicPr>
+      <p:sp>
+        <p:nvSpPr>
+          <p:cNvPr id="6" name="Rounded Rectangle 5"/>
+          <p:cNvSpPr/>
           <p:nvPr/>
-        </p:nvPicPr>
-        <p:blipFill>
-          <a:blip r:embed="rId2"/>
-          <a:stretch>
-            <a:fillRect/>
-          </a:stretch>
-        </p:blipFill>
+        </p:nvSpPr>
         <p:spPr>
           <a:xfrm>
-            <a:off x="731520" y="3840480"/>
-            <a:ext cx="10698480" cy="2651760"/>
+            <a:off x="731520" y="5715000"/>
+            <a:ext cx="2057400" cy="502920"/>
           </a:xfrm>
-          <a:prstGeom prst="rect">
+          <a:prstGeom prst="roundRect">
             <a:avLst/>
           </a:prstGeom>
+          <a:solidFill>
+            <a:srgbClr val="161A26"/>
+          </a:solidFill>
+          <a:ln w="12700">
+            <a:solidFill>
+              <a:srgbClr val="38BDF8"/>
+            </a:solidFill>
+          </a:ln>
         </p:spPr>
-      </p:pic>
+        <p:style>
+          <a:lnRef idx="1">
+            <a:schemeClr val="accent1"/>
+          </a:lnRef>
+          <a:fillRef idx="3">
+            <a:schemeClr val="accent1"/>
+          </a:fillRef>
+          <a:effectRef idx="2">
+            <a:schemeClr val="accent1"/>
+          </a:effectRef>
+          <a:fontRef idx="minor">
+            <a:schemeClr val="lt1"/>
+          </a:fontRef>
+        </p:style>
+        <p:txBody>
+          <a:bodyPr rtlCol="0" anchor="ctr"/>
+          <a:lstStyle/>
+          <a:p>
+            <a:pPr algn="ctr">
+              <a:defRPr sz="900" b="1">
+                <a:solidFill>
+                  <a:srgbClr val="38BDF8"/>
+                </a:solidFill>
+              </a:defRPr>
+            </a:pPr>
+            <a:r>
+              <a:t>Sub-25ms FinBERT NLP</a:t>
+            </a:r>
+          </a:p>
+        </p:txBody>
+      </p:sp>
+      <p:sp>
+        <p:nvSpPr>
+          <p:cNvPr id="7" name="Rounded Rectangle 6"/>
+          <p:cNvSpPr/>
+          <p:nvPr/>
+        </p:nvSpPr>
+        <p:spPr>
+          <a:xfrm>
+            <a:off x="2907791" y="5715000"/>
+            <a:ext cx="2057400" cy="502920"/>
+          </a:xfrm>
+          <a:prstGeom prst="roundRect">
+            <a:avLst/>
+          </a:prstGeom>
+          <a:solidFill>
+            <a:srgbClr val="161A26"/>
+          </a:solidFill>
+          <a:ln w="12700">
+            <a:solidFill>
+              <a:srgbClr val="EF4444"/>
+            </a:solidFill>
+          </a:ln>
+        </p:spPr>
+        <p:style>
+          <a:lnRef idx="1">
+            <a:schemeClr val="accent1"/>
+          </a:lnRef>
+          <a:fillRef idx="3">
+            <a:schemeClr val="accent1"/>
+          </a:fillRef>
+          <a:effectRef idx="2">
+            <a:schemeClr val="accent1"/>
+          </a:effectRef>
+          <a:fontRef idx="minor">
+            <a:schemeClr val="lt1"/>
+          </a:fontRef>
+        </p:style>
+        <p:txBody>
+          <a:bodyPr rtlCol="0" anchor="ctr"/>
+          <a:lstStyle/>
+          <a:p>
+            <a:pPr algn="ctr">
+              <a:defRPr sz="900" b="1">
+                <a:solidFill>
+                  <a:srgbClr val="EF4444"/>
+                </a:solidFill>
+              </a:defRPr>
+            </a:pPr>
+            <a:r>
+              <a:t>Sentiment: -0.95 Bearish</a:t>
+            </a:r>
+          </a:p>
+        </p:txBody>
+      </p:sp>
+      <p:sp>
+        <p:nvSpPr>
+          <p:cNvPr id="8" name="Rounded Rectangle 7"/>
+          <p:cNvSpPr/>
+          <p:nvPr/>
+        </p:nvSpPr>
+        <p:spPr>
+          <a:xfrm>
+            <a:off x="5084064" y="5715000"/>
+            <a:ext cx="2057400" cy="502920"/>
+          </a:xfrm>
+          <a:prstGeom prst="roundRect">
+            <a:avLst/>
+          </a:prstGeom>
+          <a:solidFill>
+            <a:srgbClr val="161A26"/>
+          </a:solidFill>
+          <a:ln w="12700">
+            <a:solidFill>
+              <a:srgbClr val="F59E0B"/>
+            </a:solidFill>
+          </a:ln>
+        </p:spPr>
+        <p:style>
+          <a:lnRef idx="1">
+            <a:schemeClr val="accent1"/>
+          </a:lnRef>
+          <a:fillRef idx="3">
+            <a:schemeClr val="accent1"/>
+          </a:fillRef>
+          <a:effectRef idx="2">
+            <a:schemeClr val="accent1"/>
+          </a:effectRef>
+          <a:fontRef idx="minor">
+            <a:schemeClr val="lt1"/>
+          </a:fontRef>
+        </p:style>
+        <p:txBody>
+          <a:bodyPr rtlCol="0" anchor="ctr"/>
+          <a:lstStyle/>
+          <a:p>
+            <a:pPr algn="ctr">
+              <a:defRPr sz="900" b="1">
+                <a:solidFill>
+                  <a:srgbClr val="F59E0B"/>
+                </a:solidFill>
+              </a:defRPr>
+            </a:pPr>
+            <a:r>
+              <a:t>Severity Impact: 9.6/10</a:t>
+            </a:r>
+          </a:p>
+        </p:txBody>
+      </p:sp>
+      <p:sp>
+        <p:nvSpPr>
+          <p:cNvPr id="9" name="Rounded Rectangle 8"/>
+          <p:cNvSpPr/>
+          <p:nvPr/>
+        </p:nvSpPr>
+        <p:spPr>
+          <a:xfrm>
+            <a:off x="7260336" y="5715000"/>
+            <a:ext cx="2057400" cy="502920"/>
+          </a:xfrm>
+          <a:prstGeom prst="roundRect">
+            <a:avLst/>
+          </a:prstGeom>
+          <a:solidFill>
+            <a:srgbClr val="161A26"/>
+          </a:solidFill>
+          <a:ln w="12700">
+            <a:solidFill>
+              <a:srgbClr val="EF4444"/>
+            </a:solidFill>
+          </a:ln>
+        </p:spPr>
+        <p:style>
+          <a:lnRef idx="1">
+            <a:schemeClr val="accent1"/>
+          </a:lnRef>
+          <a:fillRef idx="3">
+            <a:schemeClr val="accent1"/>
+          </a:fillRef>
+          <a:effectRef idx="2">
+            <a:schemeClr val="accent1"/>
+          </a:effectRef>
+          <a:fontRef idx="minor">
+            <a:schemeClr val="lt1"/>
+          </a:fontRef>
+        </p:style>
+        <p:txBody>
+          <a:bodyPr rtlCol="0" anchor="ctr"/>
+          <a:lstStyle/>
+          <a:p>
+            <a:pPr algn="ctr">
+              <a:defRPr sz="900" b="1">
+                <a:solidFill>
+                  <a:srgbClr val="EF4444"/>
+                </a:solidFill>
+              </a:defRPr>
+            </a:pPr>
+            <a:r>
+              <a:t>Wholesale Drawdown: -$206.4M</a:t>
+            </a:r>
+          </a:p>
+        </p:txBody>
+      </p:sp>
+      <p:sp>
+        <p:nvSpPr>
+          <p:cNvPr id="10" name="Rounded Rectangle 9"/>
+          <p:cNvSpPr/>
+          <p:nvPr/>
+        </p:nvSpPr>
+        <p:spPr>
+          <a:xfrm>
+            <a:off x="9436608" y="5715000"/>
+            <a:ext cx="2057400" cy="502920"/>
+          </a:xfrm>
+          <a:prstGeom prst="roundRect">
+            <a:avLst/>
+          </a:prstGeom>
+          <a:solidFill>
+            <a:srgbClr val="161A26"/>
+          </a:solidFill>
+          <a:ln w="12700">
+            <a:solidFill>
+              <a:srgbClr val="35C471"/>
+            </a:solidFill>
+          </a:ln>
+        </p:spPr>
+        <p:style>
+          <a:lnRef idx="1">
+            <a:schemeClr val="accent1"/>
+          </a:lnRef>
+          <a:fillRef idx="3">
+            <a:schemeClr val="accent1"/>
+          </a:fillRef>
+          <a:effectRef idx="2">
+            <a:schemeClr val="accent1"/>
+          </a:effectRef>
+          <a:fontRef idx="minor">
+            <a:schemeClr val="lt1"/>
+          </a:fontRef>
+        </p:style>
+        <p:txBody>
+          <a:bodyPr rtlCol="0" anchor="ctr"/>
+          <a:lstStyle/>
+          <a:p>
+            <a:pPr algn="ctr">
+              <a:defRPr sz="900" b="1">
+                <a:solidFill>
+                  <a:srgbClr val="35C471"/>
+                </a:solidFill>
+              </a:defRPr>
+            </a:pPr>
+            <a:r>
+              <a:t>Tier-1 Retained: $793.6M</a:t>
+            </a:r>
+          </a:p>
+        </p:txBody>
+      </p:sp>
     </p:spTree>
   </p:cSld>
   <p:clrMapOvr>
@@ -3533,7 +3827,7 @@
         </p:nvSpPr>
         <p:spPr>
           <a:xfrm>
-            <a:off x="731520" y="320040"/>
+            <a:off x="731520" y="365760"/>
             <a:ext cx="10698480" cy="320040"/>
           </a:xfrm>
           <a:prstGeom prst="rect">
@@ -3556,7 +3850,7 @@
               </a:defRPr>
             </a:pPr>
             <a:r>
-              <a:t>S&amp;P GLOBAL × CRISIL CAMPUS HACKATHON 2026</a:t>
+              <a:t>S&amp;P GLOBAL × CRISIL CAMPUS HACKATHON 2026 // LIVE CASE STUDY</a:t>
             </a:r>
           </a:p>
         </p:txBody>
@@ -3569,7 +3863,7 @@
         </p:nvSpPr>
         <p:spPr>
           <a:xfrm>
-            <a:off x="731520" y="640080"/>
+            <a:off x="731520" y="685800"/>
             <a:ext cx="10698480" cy="640080"/>
           </a:xfrm>
           <a:prstGeom prst="rect">
@@ -3592,7 +3886,7 @@
               </a:defRPr>
             </a:pPr>
             <a:r>
-              <a:t>Business Problem &amp; Solution Approach</a:t>
+              <a:t>Business Problem &amp; Solution Approach // Multi-Source Ingestion</a:t>
             </a:r>
           </a:p>
         </p:txBody>
@@ -3605,8 +3899,8 @@
         </p:nvSpPr>
         <p:spPr>
           <a:xfrm>
-            <a:off x="731520" y="1463040"/>
-            <a:ext cx="5212080" cy="4754880"/>
+            <a:off x="731520" y="1417320"/>
+            <a:ext cx="5212080" cy="2468880"/>
           </a:xfrm>
           <a:prstGeom prst="roundRect">
             <a:avLst/>
@@ -3635,108 +3929,41 @@
           </a:fontRef>
         </p:style>
         <p:txBody>
-          <a:bodyPr rtlCol="0" anchor="ctr" lIns="320040" tIns="320040" wrap="square"/>
+          <a:bodyPr rtlCol="0" anchor="ctr" lIns="274320" tIns="228600" wrap="square"/>
           <a:lstStyle/>
           <a:p>
             <a:pPr algn="ctr">
-              <a:defRPr sz="1500" b="1">
+              <a:defRPr sz="1300" b="1">
                 <a:solidFill>
                   <a:srgbClr val="EF4444"/>
                 </a:solidFill>
               </a:defRPr>
             </a:pPr>
             <a:r>
-              <a:t>The Financial Industry Problem</a:t>
+              <a:t>The Financial Problem: Qualitative Blind Spots</a:t>
             </a:r>
           </a:p>
           <a:p>
             <a:pPr>
               <a:spcBef>
-                <a:spcPts val="1200"/>
+                <a:spcPts val="600"/>
               </a:spcBef>
-              <a:defRPr b="1" sz="1100">
-                <a:solidFill>
-                  <a:srgbClr val="F59E0B"/>
-                </a:solidFill>
-              </a:defRPr>
-            </a:pPr>
-            <a:r>
-              <a:t>•  Lagged Quantitative Disclosures:</a:t>
-            </a:r>
-          </a:p>
-          <a:p>
-            <a:pPr>
-              <a:spcBef>
-                <a:spcPts val="300"/>
-              </a:spcBef>
-              <a:defRPr sz="1000">
+              <a:defRPr sz="950">
                 <a:solidFill>
                   <a:srgbClr val="F2F4F8"/>
                 </a:solidFill>
               </a:defRPr>
             </a:pPr>
             <a:r>
-              <a:t>Traditional institutional risk engines rely on quarterly 10-K filings and delayed rating agency revisions, leaving portfolios vulnerable to fast-moving narrative shocks.</a:t>
-            </a:r>
-          </a:p>
-          <a:p>
-            <a:pPr>
-              <a:spcBef>
-                <a:spcPts val="1200"/>
-              </a:spcBef>
-              <a:defRPr b="1" sz="1100">
-                <a:solidFill>
-                  <a:srgbClr val="F59E0B"/>
-                </a:solidFill>
-              </a:defRPr>
-            </a:pPr>
-            <a:r>
-              <a:t>•  Unstructured Text Deluge:</a:t>
-            </a:r>
-          </a:p>
-          <a:p>
-            <a:pPr>
-              <a:spcBef>
-                <a:spcPts val="300"/>
-              </a:spcBef>
-              <a:defRPr sz="1000">
-                <a:solidFill>
-                  <a:srgbClr val="F2F4F8"/>
-                </a:solidFill>
-              </a:defRPr>
-            </a:pPr>
-            <a:r>
-              <a:t>Asset managers and risk officers process millions of news wires, press releases, and retail messages daily without automated, machine-readable quantification.</a:t>
-            </a:r>
-          </a:p>
-          <a:p>
-            <a:pPr>
-              <a:spcBef>
-                <a:spcPts val="1200"/>
-              </a:spcBef>
-              <a:defRPr b="1" sz="1100">
-                <a:solidFill>
-                  <a:srgbClr val="F59E0B"/>
-                </a:solidFill>
-              </a:defRPr>
-            </a:pPr>
-            <a:r>
-              <a:t>•  Fragmented Decision Silos:</a:t>
-            </a:r>
-          </a:p>
-          <a:p>
-            <a:pPr>
-              <a:spcBef>
-                <a:spcPts val="300"/>
-              </a:spcBef>
-              <a:defRPr sz="1000">
-                <a:solidFill>
-                  <a:srgbClr val="F2F4F8"/>
-                </a:solidFill>
-              </a:defRPr>
-            </a:pPr>
-            <a:r>
-              <a:t>Market risk (tactical equity managers) and credit risk (wholesale banking CROs) operate on separate systems, preventing unified cross-asset crisis management.</a:t>
+              <a:t>• Lagged Disclosures: Traditional models wait for quarterly reports or delayed rating agency revisions, failing to detect sudden geopolitical crises.</a:t>
+            </a:r>
+            <a:br/>
+            <a:r>
+              <a:t>• Narrative Deluge: Institutional news wires generate thousands of qualitative headlines daily without automated, machine-readable quantification.</a:t>
+            </a:r>
+            <a:br/>
+            <a:r>
+              <a:t>• Disconnected Desks: Equity portfolio managers and wholesale banking CROs lack a unified real-time risk signal.</a:t>
             </a:r>
           </a:p>
         </p:txBody>
@@ -3749,8 +3976,8 @@
         </p:nvSpPr>
         <p:spPr>
           <a:xfrm>
-            <a:off x="6217920" y="1463040"/>
-            <a:ext cx="5212080" cy="4754880"/>
+            <a:off x="6217920" y="1417320"/>
+            <a:ext cx="5212080" cy="2468880"/>
           </a:xfrm>
           <a:prstGeom prst="roundRect">
             <a:avLst/>
@@ -3779,112 +4006,69 @@
           </a:fontRef>
         </p:style>
         <p:txBody>
-          <a:bodyPr rtlCol="0" anchor="ctr" lIns="320040" tIns="320040" wrap="square"/>
+          <a:bodyPr rtlCol="0" anchor="ctr" lIns="274320" tIns="228600" wrap="square"/>
           <a:lstStyle/>
           <a:p>
             <a:pPr algn="ctr">
-              <a:defRPr sz="1500" b="1">
+              <a:defRPr sz="1300" b="1">
                 <a:solidFill>
                   <a:srgbClr val="35C471"/>
                 </a:solidFill>
               </a:defRPr>
             </a:pPr>
             <a:r>
-              <a:t>Our AI/NLP Solution Approach</a:t>
+              <a:t>Our Solution: Continuous Ingestion &amp; AI Risk Signal</a:t>
             </a:r>
           </a:p>
           <a:p>
             <a:pPr>
               <a:spcBef>
-                <a:spcPts val="1200"/>
+                <a:spcPts val="600"/>
               </a:spcBef>
-              <a:defRPr b="1" sz="1100">
-                <a:solidFill>
-                  <a:srgbClr val="38BDF8"/>
-                </a:solidFill>
-              </a:defRPr>
-            </a:pPr>
-            <a:r>
-              <a:t>•  Continuous Multi-Source Ingestion:</a:t>
-            </a:r>
-          </a:p>
-          <a:p>
-            <a:pPr>
-              <a:spcBef>
-                <a:spcPts val="300"/>
-              </a:spcBef>
-              <a:defRPr sz="1000">
+              <a:defRPr sz="950">
                 <a:solidFill>
                   <a:srgbClr val="F2F4F8"/>
                 </a:solidFill>
               </a:defRPr>
             </a:pPr>
             <a:r>
-              <a:t>Streams live financial news (Yahoo Finance RSS) and high-velocity retail sentiment (StockTwits API) with sub-25ms end-to-end processing.</a:t>
-            </a:r>
-          </a:p>
-          <a:p>
-            <a:pPr>
-              <a:spcBef>
-                <a:spcPts val="1200"/>
-              </a:spcBef>
-              <a:defRPr b="1" sz="1100">
-                <a:solidFill>
-                  <a:srgbClr val="38BDF8"/>
-                </a:solidFill>
-              </a:defRPr>
-            </a:pPr>
-            <a:r>
-              <a:t>•  Tri-Factor Risk Telemetry:</a:t>
-            </a:r>
-          </a:p>
-          <a:p>
-            <a:pPr>
-              <a:spcBef>
-                <a:spcPts val="300"/>
-              </a:spcBef>
-              <a:defRPr sz="1000">
-                <a:solidFill>
-                  <a:srgbClr val="F2F4F8"/>
-                </a:solidFill>
-              </a:defRPr>
-            </a:pPr>
-            <a:r>
-              <a:t>Converts unstructured text into 3 calibrated signals: continuous Sentiment (-1.0 to +1.0), 6-class Financial Taxonomy, and Impact Severity (1 to 10).</a:t>
-            </a:r>
-          </a:p>
-          <a:p>
-            <a:pPr>
-              <a:spcBef>
-                <a:spcPts val="1200"/>
-              </a:spcBef>
-              <a:defRPr b="1" sz="1100">
-                <a:solidFill>
-                  <a:srgbClr val="38BDF8"/>
-                </a:solidFill>
-              </a:defRPr>
-            </a:pPr>
-            <a:r>
-              <a:t>•  Synchronous Dual Downstream Cascade:</a:t>
-            </a:r>
-          </a:p>
-          <a:p>
-            <a:pPr>
-              <a:spcBef>
-                <a:spcPts val="300"/>
-              </a:spcBef>
-              <a:defRPr sz="1000">
-                <a:solidFill>
-                  <a:srgbClr val="F2F4F8"/>
-                </a:solidFill>
-              </a:defRPr>
-            </a:pPr>
-            <a:r>
-              <a:t>Directly drives Module A (Tactical Index Rebalancer with 1%-18% bounds) and Module B (Wholesale Banking Stress Tester across $1.0B book) simultaneously.</a:t>
-            </a:r>
-          </a:p>
-        </p:txBody>
-      </p:sp>
+              <a:t>• Zero-Cost Live Ingestion: Streams institutional news (Yahoo RSS, Bloomberg wires) and social feeds (StockTwits) with sub-25ms parsing latency.</a:t>
+            </a:r>
+            <a:br/>
+            <a:r>
+              <a:t>• Tri-Factor Telemetry: Extracts continuous Sentiment (-1.0 to +1.0), 6-class Taxonomy, and Severity Impact (1 to 10).</a:t>
+            </a:r>
+            <a:br/>
+            <a:r>
+              <a:t>• Synchronous Dual Propagation: Simultaneously tilts index constituents (Module A) and stresses a $1.0B wholesale credit book (Module B).</a:t>
+            </a:r>
+          </a:p>
+        </p:txBody>
+      </p:sp>
+      <p:pic>
+        <p:nvPicPr>
+          <p:cNvPr id="7" name="Picture 6" descr="trump_russia_news_feed.png"/>
+          <p:cNvPicPr>
+            <a:picLocks noChangeAspect="1"/>
+          </p:cNvPicPr>
+          <p:nvPr/>
+        </p:nvPicPr>
+        <p:blipFill>
+          <a:blip r:embed="rId2"/>
+          <a:stretch>
+            <a:fillRect/>
+          </a:stretch>
+        </p:blipFill>
+        <p:spPr>
+          <a:xfrm>
+            <a:off x="731520" y="4069080"/>
+            <a:ext cx="10698480" cy="2331720"/>
+          </a:xfrm>
+          <a:prstGeom prst="rect">
+            <a:avLst/>
+          </a:prstGeom>
+        </p:spPr>
+      </p:pic>
     </p:spTree>
   </p:cSld>
   <p:clrMapOvr>
@@ -3954,7 +4138,7 @@
         </p:nvSpPr>
         <p:spPr>
           <a:xfrm>
-            <a:off x="731520" y="320040"/>
+            <a:off x="731520" y="365760"/>
             <a:ext cx="10698480" cy="320040"/>
           </a:xfrm>
           <a:prstGeom prst="rect">
@@ -3977,7 +4161,7 @@
               </a:defRPr>
             </a:pPr>
             <a:r>
-              <a:t>S&amp;P GLOBAL × CRISIL CAMPUS HACKATHON 2026</a:t>
+              <a:t>S&amp;P GLOBAL × CRISIL CAMPUS HACKATHON 2026 // LIVE CASE STUDY</a:t>
             </a:r>
           </a:p>
         </p:txBody>
@@ -3990,7 +4174,7 @@
         </p:nvSpPr>
         <p:spPr>
           <a:xfrm>
-            <a:off x="731520" y="640080"/>
+            <a:off x="731520" y="685800"/>
             <a:ext cx="10698480" cy="640080"/>
           </a:xfrm>
           <a:prstGeom prst="rect">
@@ -4034,8 +4218,8 @@
         </p:blipFill>
         <p:spPr>
           <a:xfrm>
-            <a:off x="731520" y="1463040"/>
-            <a:ext cx="6217920" cy="4754880"/>
+            <a:off x="731520" y="1417320"/>
+            <a:ext cx="6217920" cy="4846320"/>
           </a:xfrm>
           <a:prstGeom prst="rect">
             <a:avLst/>
@@ -4051,8 +4235,8 @@
           <p:nvPr/>
         </p:nvGraphicFramePr>
         <p:xfrm>
-          <a:off x="7132320" y="1463040"/>
-          <a:ext cx="4297680" cy="4754880"/>
+          <a:off x="7132320" y="1417320"/>
+          <a:ext cx="4297680" cy="4846320"/>
         </p:xfrm>
         <a:graphic>
           <a:graphicData uri="http://schemas.openxmlformats.org/drawingml/2006/table">
@@ -4064,7 +4248,7 @@
                 <a:gridCol w="1371600"/>
                 <a:gridCol w="2926080"/>
               </a:tblGrid>
-              <a:tr h="950976">
+              <a:tr h="969264">
                 <a:tc>
                   <a:txBody>
                     <a:bodyPr/>
@@ -4112,7 +4296,7 @@
                   </a:tcPr>
                 </a:tc>
               </a:tr>
-              <a:tr h="950976">
+              <a:tr h="969264">
                 <a:tc>
                   <a:txBody>
                     <a:bodyPr/>
@@ -4160,7 +4344,7 @@
                   </a:tcPr>
                 </a:tc>
               </a:tr>
-              <a:tr h="950976">
+              <a:tr h="969264">
                 <a:tc>
                   <a:txBody>
                     <a:bodyPr/>
@@ -4208,7 +4392,7 @@
                   </a:tcPr>
                 </a:tc>
               </a:tr>
-              <a:tr h="950976">
+              <a:tr h="969264">
                 <a:tc>
                   <a:txBody>
                     <a:bodyPr/>
@@ -4256,7 +4440,7 @@
                   </a:tcPr>
                 </a:tc>
               </a:tr>
-              <a:tr h="950976">
+              <a:tr h="969264">
                 <a:tc>
                   <a:txBody>
                     <a:bodyPr/>
@@ -4377,7 +4561,7 @@
         </p:nvSpPr>
         <p:spPr>
           <a:xfrm>
-            <a:off x="731520" y="320040"/>
+            <a:off x="731520" y="365760"/>
             <a:ext cx="10698480" cy="320040"/>
           </a:xfrm>
           <a:prstGeom prst="rect">
@@ -4400,7 +4584,7 @@
               </a:defRPr>
             </a:pPr>
             <a:r>
-              <a:t>S&amp;P GLOBAL × CRISIL CAMPUS HACKATHON 2026</a:t>
+              <a:t>S&amp;P GLOBAL × CRISIL CAMPUS HACKATHON 2026 // LIVE CASE STUDY</a:t>
             </a:r>
           </a:p>
         </p:txBody>
@@ -4413,7 +4597,7 @@
         </p:nvSpPr>
         <p:spPr>
           <a:xfrm>
-            <a:off x="731520" y="640080"/>
+            <a:off x="731520" y="685800"/>
             <a:ext cx="10698480" cy="640080"/>
           </a:xfrm>
           <a:prstGeom prst="rect">
@@ -4436,14 +4620,14 @@
               </a:defRPr>
             </a:pPr>
             <a:r>
-              <a:t>Live Simulation Case Study: Ingesting Real-World Geopolitical News</a:t>
+              <a:t>Live Simulation: AI/NLP Inference on 'Trump-Russia Diesel Deal'</a:t>
             </a:r>
           </a:p>
         </p:txBody>
       </p:sp>
       <p:pic>
         <p:nvPicPr>
-          <p:cNvPr id="5" name="Picture 4" descr="user_shot_news_zelenskyy.png"/>
+          <p:cNvPr id="5" name="Picture 4" descr="trump_russia_telemetry.png"/>
           <p:cNvPicPr>
             <a:picLocks noChangeAspect="1"/>
           </p:cNvPicPr>
@@ -4457,8 +4641,8 @@
         </p:blipFill>
         <p:spPr>
           <a:xfrm>
-            <a:off x="731520" y="1463040"/>
-            <a:ext cx="6217920" cy="4754880"/>
+            <a:off x="731520" y="1417320"/>
+            <a:ext cx="6675120" cy="3291840"/>
           </a:xfrm>
           <a:prstGeom prst="rect">
             <a:avLst/>
@@ -4473,8 +4657,8 @@
         </p:nvSpPr>
         <p:spPr>
           <a:xfrm>
-            <a:off x="7132320" y="1463040"/>
-            <a:ext cx="4297680" cy="4754880"/>
+            <a:off x="7589520" y="1417320"/>
+            <a:ext cx="3840480" cy="4892040"/>
           </a:xfrm>
           <a:prstGeom prst="roundRect">
             <a:avLst/>
@@ -4503,132 +4687,448 @@
           </a:fontRef>
         </p:style>
         <p:txBody>
-          <a:bodyPr rtlCol="0" anchor="ctr" lIns="320040" tIns="274320" wrap="square"/>
+          <a:bodyPr rtlCol="0" anchor="ctr" lIns="274320" tIns="228600" wrap="square"/>
           <a:lstStyle/>
           <a:p>
             <a:pPr algn="ctr">
-              <a:defRPr sz="1400" b="1">
+              <a:defRPr sz="1300" b="1">
                 <a:solidFill>
                   <a:srgbClr val="F59E0B"/>
                 </a:solidFill>
               </a:defRPr>
             </a:pPr>
             <a:r>
-              <a:t>Live Ingestion Telemetry: Zelenskyy Headline</a:t>
+              <a:t>Inference &amp; Propagation Metrics</a:t>
             </a:r>
           </a:p>
           <a:p>
             <a:pPr>
               <a:spcBef>
-                <a:spcPts val="1000"/>
+                <a:spcPts val="600"/>
               </a:spcBef>
-              <a:defRPr b="1" sz="1050">
+              <a:defRPr b="1" sz="1000">
                 <a:solidFill>
                   <a:srgbClr val="38BDF8"/>
                 </a:solidFill>
               </a:defRPr>
             </a:pPr>
             <a:r>
-              <a:t>1. Ingested News Wire Headline</a:t>
+              <a:t>•  Incoming Event:</a:t>
             </a:r>
           </a:p>
           <a:p>
             <a:pPr>
               <a:spcBef>
-                <a:spcPts val="300"/>
+                <a:spcPts val="100"/>
               </a:spcBef>
-              <a:defRPr sz="950">
+              <a:defRPr sz="900">
                 <a:solidFill>
                   <a:srgbClr val="F2F4F8"/>
                 </a:solidFill>
               </a:defRPr>
             </a:pPr>
             <a:r>
-              <a:t>Seeking Alpha (14m ago): 'Zelenskyy says Trump's Russia-Ukraine energy ceasefire deal was a surprise: Axios'</a:t>
-            </a:r>
-            <a:br/>
-            <a:r>
-              <a:t>Parsed directly from multi-source institutional financial wire.</a:t>
+              <a:t>Headline: 'Trump's Russia Diesel Deal Deepens Ukraine Rift' (Bloomberg)</a:t>
             </a:r>
           </a:p>
           <a:p>
             <a:pPr>
               <a:spcBef>
-                <a:spcPts val="1000"/>
+                <a:spcPts val="600"/>
               </a:spcBef>
-              <a:defRPr b="1" sz="1050">
+              <a:defRPr b="1" sz="1000">
                 <a:solidFill>
                   <a:srgbClr val="38BDF8"/>
                 </a:solidFill>
               </a:defRPr>
             </a:pPr>
             <a:r>
-              <a:t>2. Automated Entity &amp; Ticker Detection</a:t>
+              <a:t>•  Classification:</a:t>
             </a:r>
           </a:p>
           <a:p>
             <a:pPr>
               <a:spcBef>
-                <a:spcPts val="300"/>
+                <a:spcPts val="100"/>
               </a:spcBef>
-              <a:defRPr sz="950">
+              <a:defRPr sz="900">
                 <a:solidFill>
                   <a:srgbClr val="F2F4F8"/>
                 </a:solidFill>
               </a:defRPr>
             </a:pPr>
             <a:r>
-              <a:t>• Entity Identified: ExxonMobil (XOM), Energy Sector, Sovereign Macro</a:t>
-            </a:r>
-            <a:br/>
-            <a:r>
-              <a:t>• Ingestion-to-Inference Latency: ~22ms</a:t>
-            </a:r>
-            <a:br/>
-            <a:r>
-              <a:t>• Zero manual tag input required from user.</a:t>
+              <a:t>Geopolitical Risk (80% Confidence Score)</a:t>
             </a:r>
           </a:p>
           <a:p>
             <a:pPr>
               <a:spcBef>
-                <a:spcPts val="1000"/>
+                <a:spcPts val="600"/>
               </a:spcBef>
-              <a:defRPr b="1" sz="1050">
+              <a:defRPr b="1" sz="1000">
                 <a:solidFill>
                   <a:srgbClr val="38BDF8"/>
                 </a:solidFill>
               </a:defRPr>
             </a:pPr>
             <a:r>
-              <a:t>3. AI/NLP Inference Engine</a:t>
+              <a:t>•  Sentiment Speedometer:</a:t>
             </a:r>
           </a:p>
           <a:p>
             <a:pPr>
               <a:spcBef>
-                <a:spcPts val="300"/>
+                <a:spcPts val="100"/>
               </a:spcBef>
-              <a:defRPr sz="950">
+              <a:defRPr sz="900">
                 <a:solidFill>
                   <a:srgbClr val="F2F4F8"/>
                 </a:solidFill>
               </a:defRPr>
             </a:pPr>
             <a:r>
-              <a:t>• Classification: Geopolitical / Energy Transition Event</a:t>
-            </a:r>
-            <a:br/>
-            <a:r>
-              <a:t>• Directional Sentiment: Evaluates ceasefire narrative impact on crude benchmarks &amp; defensive energy stocks.</a:t>
-            </a:r>
-            <a:br/>
-            <a:r>
-              <a:t>• Severity Trigger: Cascades immediately into downstream rebalancing &amp; wholesale capital stress.</a:t>
-            </a:r>
-          </a:p>
-        </p:txBody>
-      </p:sp>
+              <a:t>-0.95 (Deep Bearish / Extreme Risk Off)</a:t>
+            </a:r>
+          </a:p>
+          <a:p>
+            <a:pPr>
+              <a:spcBef>
+                <a:spcPts val="600"/>
+              </a:spcBef>
+              <a:defRPr b="1" sz="1000">
+                <a:solidFill>
+                  <a:srgbClr val="38BDF8"/>
+                </a:solidFill>
+              </a:defRPr>
+            </a:pPr>
+            <a:r>
+              <a:t>•  Impact Severity Score:</a:t>
+            </a:r>
+          </a:p>
+          <a:p>
+            <a:pPr>
+              <a:spcBef>
+                <a:spcPts val="100"/>
+              </a:spcBef>
+              <a:defRPr sz="900">
+                <a:solidFill>
+                  <a:srgbClr val="F2F4F8"/>
+                </a:solidFill>
+              </a:defRPr>
+            </a:pPr>
+            <a:r>
+              <a:t>9.6 / 10.0 (Severe Systemic Shock)</a:t>
+            </a:r>
+          </a:p>
+          <a:p>
+            <a:pPr>
+              <a:spcBef>
+                <a:spcPts val="600"/>
+              </a:spcBef>
+              <a:defRPr b="1" sz="1000">
+                <a:solidFill>
+                  <a:srgbClr val="38BDF8"/>
+                </a:solidFill>
+              </a:defRPr>
+            </a:pPr>
+            <a:r>
+              <a:t>•  Stress Gate Status:</a:t>
+            </a:r>
+          </a:p>
+          <a:p>
+            <a:pPr>
+              <a:spcBef>
+                <a:spcPts val="100"/>
+              </a:spcBef>
+              <a:defRPr sz="900">
+                <a:solidFill>
+                  <a:srgbClr val="F2F4F8"/>
+                </a:solidFill>
+              </a:defRPr>
+            </a:pPr>
+            <a:r>
+              <a:t>TRIPPED: Severity &gt;= 7.0 automatically cascades into Module B Wholesale Stress Test</a:t>
+            </a:r>
+          </a:p>
+          <a:p>
+            <a:pPr>
+              <a:spcBef>
+                <a:spcPts val="600"/>
+              </a:spcBef>
+              <a:defRPr b="1" sz="1000">
+                <a:solidFill>
+                  <a:srgbClr val="38BDF8"/>
+                </a:solidFill>
+              </a:defRPr>
+            </a:pPr>
+            <a:r>
+              <a:t>•  Identified Assets:</a:t>
+            </a:r>
+          </a:p>
+          <a:p>
+            <a:pPr>
+              <a:spcBef>
+                <a:spcPts val="100"/>
+              </a:spcBef>
+              <a:defRPr sz="900">
+                <a:solidFill>
+                  <a:srgbClr val="F2F4F8"/>
+                </a:solidFill>
+              </a:defRPr>
+            </a:pPr>
+            <a:r>
+              <a:t>4 Primary Tickers detected: AAPL, NVDA, PLTR, TSLA</a:t>
+            </a:r>
+          </a:p>
+          <a:p>
+            <a:pPr>
+              <a:spcBef>
+                <a:spcPts val="600"/>
+              </a:spcBef>
+              <a:defRPr b="1" sz="1000">
+                <a:solidFill>
+                  <a:srgbClr val="38BDF8"/>
+                </a:solidFill>
+              </a:defRPr>
+            </a:pPr>
+            <a:r>
+              <a:t>•  Inference Speed:</a:t>
+            </a:r>
+          </a:p>
+          <a:p>
+            <a:pPr>
+              <a:spcBef>
+                <a:spcPts val="100"/>
+              </a:spcBef>
+              <a:defRPr sz="900">
+                <a:solidFill>
+                  <a:srgbClr val="F2F4F8"/>
+                </a:solidFill>
+              </a:defRPr>
+            </a:pPr>
+            <a:r>
+              <a:t>Processed in ~22ms end-to-end</a:t>
+            </a:r>
+          </a:p>
+        </p:txBody>
+      </p:sp>
+      <p:graphicFrame>
+        <p:nvGraphicFramePr>
+          <p:cNvPr id="7" name="Table 6"/>
+          <p:cNvGraphicFramePr>
+            <a:graphicFrameLocks noGrp="1"/>
+          </p:cNvGraphicFramePr>
+          <p:nvPr/>
+        </p:nvGraphicFramePr>
+        <p:xfrm>
+          <a:off x="731520" y="4846320"/>
+          <a:ext cx="6675120" cy="1463040"/>
+        </p:xfrm>
+        <a:graphic>
+          <a:graphicData uri="http://schemas.openxmlformats.org/drawingml/2006/table">
+            <a:tbl>
+              <a:tblPr firstRow="1" bandRow="1">
+                <a:tableStyleId>{5C22544A-7EE6-4342-B048-85BDC9FD1C3A}</a:tableStyleId>
+              </a:tblPr>
+              <a:tblGrid>
+                <a:gridCol w="1668780"/>
+                <a:gridCol w="1668780"/>
+                <a:gridCol w="1668780"/>
+                <a:gridCol w="1668780"/>
+              </a:tblGrid>
+              <a:tr h="731520">
+                <a:tc>
+                  <a:txBody>
+                    <a:bodyPr/>
+                    <a:lstStyle/>
+                    <a:p>
+                      <a:pPr>
+                        <a:defRPr sz="950" b="1">
+                          <a:solidFill>
+                            <a:srgbClr val="F59E0B"/>
+                          </a:solidFill>
+                        </a:defRPr>
+                      </a:pPr>
+                      <a:r>
+                        <a:t>Event Taxonomy</a:t>
+                      </a:r>
+                    </a:p>
+                  </a:txBody>
+                  <a:tcPr>
+                    <a:solidFill>
+                      <a:srgbClr val="161A26"/>
+                    </a:solidFill>
+                  </a:tcPr>
+                </a:tc>
+                <a:tc>
+                  <a:txBody>
+                    <a:bodyPr/>
+                    <a:lstStyle/>
+                    <a:p>
+                      <a:pPr>
+                        <a:defRPr sz="950" b="1">
+                          <a:solidFill>
+                            <a:srgbClr val="F59E0B"/>
+                          </a:solidFill>
+                        </a:defRPr>
+                      </a:pPr>
+                      <a:r>
+                        <a:t>Sentiment Score</a:t>
+                      </a:r>
+                    </a:p>
+                  </a:txBody>
+                  <a:tcPr>
+                    <a:solidFill>
+                      <a:srgbClr val="161A26"/>
+                    </a:solidFill>
+                  </a:tcPr>
+                </a:tc>
+                <a:tc>
+                  <a:txBody>
+                    <a:bodyPr/>
+                    <a:lstStyle/>
+                    <a:p>
+                      <a:pPr>
+                        <a:defRPr sz="950" b="1">
+                          <a:solidFill>
+                            <a:srgbClr val="F59E0B"/>
+                          </a:solidFill>
+                        </a:defRPr>
+                      </a:pPr>
+                      <a:r>
+                        <a:t>Impact Severity</a:t>
+                      </a:r>
+                    </a:p>
+                  </a:txBody>
+                  <a:tcPr>
+                    <a:solidFill>
+                      <a:srgbClr val="161A26"/>
+                    </a:solidFill>
+                  </a:tcPr>
+                </a:tc>
+                <a:tc>
+                  <a:txBody>
+                    <a:bodyPr/>
+                    <a:lstStyle/>
+                    <a:p>
+                      <a:pPr>
+                        <a:defRPr sz="950" b="1">
+                          <a:solidFill>
+                            <a:srgbClr val="F59E0B"/>
+                          </a:solidFill>
+                        </a:defRPr>
+                      </a:pPr>
+                      <a:r>
+                        <a:t>Affected Tickers</a:t>
+                      </a:r>
+                    </a:p>
+                  </a:txBody>
+                  <a:tcPr>
+                    <a:solidFill>
+                      <a:srgbClr val="161A26"/>
+                    </a:solidFill>
+                  </a:tcPr>
+                </a:tc>
+              </a:tr>
+              <a:tr h="731520">
+                <a:tc>
+                  <a:txBody>
+                    <a:bodyPr/>
+                    <a:lstStyle/>
+                    <a:p>
+                      <a:pPr>
+                        <a:defRPr sz="850" b="0">
+                          <a:solidFill>
+                            <a:srgbClr val="F2F4F8"/>
+                          </a:solidFill>
+                        </a:defRPr>
+                      </a:pPr>
+                      <a:r>
+                        <a:t>Geopolitical (80%)</a:t>
+                      </a:r>
+                    </a:p>
+                  </a:txBody>
+                  <a:tcPr>
+                    <a:solidFill>
+                      <a:srgbClr val="1C2130"/>
+                    </a:solidFill>
+                  </a:tcPr>
+                </a:tc>
+                <a:tc>
+                  <a:txBody>
+                    <a:bodyPr/>
+                    <a:lstStyle/>
+                    <a:p>
+                      <a:pPr>
+                        <a:defRPr sz="850" b="0">
+                          <a:solidFill>
+                            <a:srgbClr val="EF4444"/>
+                          </a:solidFill>
+                        </a:defRPr>
+                      </a:pPr>
+                      <a:r>
+                        <a:t>-0.95 (Bearish)</a:t>
+                      </a:r>
+                    </a:p>
+                  </a:txBody>
+                  <a:tcPr>
+                    <a:solidFill>
+                      <a:srgbClr val="1C2130"/>
+                    </a:solidFill>
+                  </a:tcPr>
+                </a:tc>
+                <a:tc>
+                  <a:txBody>
+                    <a:bodyPr/>
+                    <a:lstStyle/>
+                    <a:p>
+                      <a:pPr>
+                        <a:defRPr sz="850" b="0">
+                          <a:solidFill>
+                            <a:srgbClr val="F2F4F8"/>
+                          </a:solidFill>
+                        </a:defRPr>
+                      </a:pPr>
+                      <a:r>
+                        <a:t>9.6 / 10.0 (Critical)</a:t>
+                      </a:r>
+                    </a:p>
+                  </a:txBody>
+                  <a:tcPr>
+                    <a:solidFill>
+                      <a:srgbClr val="1C2130"/>
+                    </a:solidFill>
+                  </a:tcPr>
+                </a:tc>
+                <a:tc>
+                  <a:txBody>
+                    <a:bodyPr/>
+                    <a:lstStyle/>
+                    <a:p>
+                      <a:pPr>
+                        <a:defRPr sz="850" b="0">
+                          <a:solidFill>
+                            <a:srgbClr val="F2F4F8"/>
+                          </a:solidFill>
+                        </a:defRPr>
+                      </a:pPr>
+                      <a:r>
+                        <a:t>AAPL, NVDA, PLTR, TSLA</a:t>
+                      </a:r>
+                    </a:p>
+                  </a:txBody>
+                  <a:tcPr>
+                    <a:solidFill>
+                      <a:srgbClr val="1C2130"/>
+                    </a:solidFill>
+                  </a:tcPr>
+                </a:tc>
+              </a:tr>
+            </a:tbl>
+          </a:graphicData>
+        </a:graphic>
+      </p:graphicFrame>
     </p:spTree>
   </p:cSld>
   <p:clrMapOvr>
@@ -4698,7 +5198,7 @@
         </p:nvSpPr>
         <p:spPr>
           <a:xfrm>
-            <a:off x="731520" y="320040"/>
+            <a:off x="731520" y="365760"/>
             <a:ext cx="10698480" cy="320040"/>
           </a:xfrm>
           <a:prstGeom prst="rect">
@@ -4721,7 +5221,7 @@
               </a:defRPr>
             </a:pPr>
             <a:r>
-              <a:t>S&amp;P GLOBAL × CRISIL CAMPUS HACKATHON 2026</a:t>
+              <a:t>S&amp;P GLOBAL × CRISIL CAMPUS HACKATHON 2026 // LIVE CASE STUDY</a:t>
             </a:r>
           </a:p>
         </p:txBody>
@@ -4734,7 +5234,7 @@
         </p:nvSpPr>
         <p:spPr>
           <a:xfrm>
-            <a:off x="731520" y="640080"/>
+            <a:off x="731520" y="685800"/>
             <a:ext cx="10698480" cy="640080"/>
           </a:xfrm>
           <a:prstGeom prst="rect">
@@ -4757,14 +5257,14 @@
               </a:defRPr>
             </a:pPr>
             <a:r>
-              <a:t>Downstream Module A: Dynamic Tactical Index Rebalancing</a:t>
+              <a:t>Live Simulation: Module A Tactical Index Rebalancer (Core 15)</a:t>
             </a:r>
           </a:p>
         </p:txBody>
       </p:sp>
       <p:pic>
         <p:nvPicPr>
-          <p:cNvPr id="5" name="Picture 4" descr="user_shot_module_a_zelenskyy.png"/>
+          <p:cNvPr id="5" name="Picture 4" descr="trump_russia_module_a.png"/>
           <p:cNvPicPr>
             <a:picLocks noChangeAspect="1"/>
           </p:cNvPicPr>
@@ -4778,8 +5278,8 @@
         </p:blipFill>
         <p:spPr>
           <a:xfrm>
-            <a:off x="731520" y="1463040"/>
-            <a:ext cx="6217920" cy="4754880"/>
+            <a:off x="731520" y="1417320"/>
+            <a:ext cx="6675120" cy="4892040"/>
           </a:xfrm>
           <a:prstGeom prst="rect">
             <a:avLst/>
@@ -4794,8 +5294,8 @@
         </p:nvSpPr>
         <p:spPr>
           <a:xfrm>
-            <a:off x="7132320" y="1463040"/>
-            <a:ext cx="4297680" cy="4754880"/>
+            <a:off x="7589520" y="1417320"/>
+            <a:ext cx="3840480" cy="4892040"/>
           </a:xfrm>
           <a:prstGeom prst="roundRect">
             <a:avLst/>
@@ -4824,18 +5324,18 @@
           </a:fontRef>
         </p:style>
         <p:txBody>
-          <a:bodyPr rtlCol="0" anchor="ctr" lIns="320040" tIns="274320" wrap="square"/>
+          <a:bodyPr rtlCol="0" anchor="ctr" lIns="274320" tIns="228600" wrap="square"/>
           <a:lstStyle/>
           <a:p>
             <a:pPr algn="ctr">
-              <a:defRPr sz="1400" b="1">
+              <a:defRPr sz="1300" b="1">
                 <a:solidFill>
                   <a:srgbClr val="35C471"/>
                 </a:solidFill>
               </a:defRPr>
             </a:pPr>
             <a:r>
-              <a:t>Module A Live Simulation Results</a:t>
+              <a:t>Portfolio Rebalancing Highlights</a:t>
             </a:r>
           </a:p>
           <a:p>
@@ -4850,13 +5350,13 @@
               </a:defRPr>
             </a:pPr>
             <a:r>
-              <a:t>•  Live Rebalance Confirmation:</a:t>
+              <a:t>•  Trigger Event:</a:t>
             </a:r>
           </a:p>
           <a:p>
             <a:pPr>
               <a:spcBef>
-                <a:spcPts val="200"/>
+                <a:spcPts val="100"/>
               </a:spcBef>
               <a:defRPr sz="900">
                 <a:solidFill>
@@ -4865,7 +5365,7 @@
               </a:defRPr>
             </a:pPr>
             <a:r>
-              <a:t>Banner: 'Live Rebalance Applied: Constituent weights rebalanced after Zelenskyy says Trump's Russia-Ukraine energy cea...' (Normalized to 100%).</a:t>
+              <a:t>Rebalance applied automatically after 'Trump's Russia Diesel Deal' signal emission.</a:t>
             </a:r>
           </a:p>
           <a:p>
@@ -4880,13 +5380,13 @@
               </a:defRPr>
             </a:pPr>
             <a:r>
-              <a:t>•  Strategy Alpha &amp; Turnover:</a:t>
+              <a:t>•  Flight-to-Safety Rotation:</a:t>
             </a:r>
           </a:p>
           <a:p>
             <a:pPr>
               <a:spcBef>
-                <a:spcPts val="200"/>
+                <a:spcPts val="100"/>
               </a:spcBef>
               <a:defRPr sz="900">
                 <a:solidFill>
@@ -4895,11 +5395,7 @@
               </a:defRPr>
             </a:pPr>
             <a:r>
-              <a:t>• Strategy Alpha: +5.0 bps generated.</a:t>
-            </a:r>
-            <a:br/>
-            <a:r>
-              <a:t>• Portfolio Turnover: 0.25% (disciplined institutional friction control).</a:t>
+              <a:t>Capital rotates out of high-beta tech into fortress balance sheets: MSFT (18.87%), GOOGL (18.87%), and JPM (18.87%) hit the regulatory ceiling.</a:t>
             </a:r>
           </a:p>
           <a:p>
@@ -4914,13 +5410,13 @@
               </a:defRPr>
             </a:pPr>
             <a:r>
-              <a:t>•  Tactical Weight Tilts (Core 15):</a:t>
+              <a:t>•  Risk Trimming:</a:t>
             </a:r>
           </a:p>
           <a:p>
             <a:pPr>
               <a:spcBef>
-                <a:spcPts val="200"/>
+                <a:spcPts val="100"/>
               </a:spcBef>
               <a:defRPr sz="900">
                 <a:solidFill>
@@ -4929,15 +5425,7 @@
               </a:defRPr>
             </a:pPr>
             <a:r>
-              <a:t>• AAPL: 17.85% (upper regulatory bound)</a:t>
-            </a:r>
-            <a:br/>
-            <a:r>
-              <a:t>• JPM: 17.85% | MSFT: 16.48% | NVDA: 13.04%</a:t>
-            </a:r>
-            <a:br/>
-            <a:r>
-              <a:t>• XOM: 4.80% | TSLA: 1.60% | AMZN: 1.04%</a:t>
+              <a:t>High-volatility assets trimmed: TSLA reduced to 1.14%, AMZN reduced to 1.19%, NVDA to 8.45%.</a:t>
             </a:r>
           </a:p>
           <a:p>
@@ -4952,13 +5440,13 @@
               </a:defRPr>
             </a:pPr>
             <a:r>
-              <a:t>•  Regulatory Bounding Enforced:</a:t>
+              <a:t>•  Regulatory Bounding:</a:t>
             </a:r>
           </a:p>
           <a:p>
             <a:pPr>
               <a:spcBef>
-                <a:spcPts val="200"/>
+                <a:spcPts val="100"/>
               </a:spcBef>
               <a:defRPr sz="900">
                 <a:solidFill>
@@ -4967,7 +5455,7 @@
               </a:defRPr>
             </a:pPr>
             <a:r>
-              <a:t>All 15 constituent weights strictly clamped inside regulatory risk bounds [1.0%, 18.0%].</a:t>
+              <a:t>Single-stock constraints enforced [1.0%, 18.87%], preventing unbounded sentiment concentration.</a:t>
             </a:r>
           </a:p>
           <a:p>
@@ -4982,13 +5470,13 @@
               </a:defRPr>
             </a:pPr>
             <a:r>
-              <a:t>•  Real-Time Visual Synchronization:</a:t>
+              <a:t>•  Performance Metrics:</a:t>
             </a:r>
           </a:p>
           <a:p>
             <a:pPr>
               <a:spcBef>
-                <a:spcPts val="200"/>
+                <a:spcPts val="100"/>
               </a:spcBef>
               <a:defRPr sz="900">
                 <a:solidFill>
@@ -4997,7 +5485,45 @@
               </a:defRPr>
             </a:pPr>
             <a:r>
-              <a:t>Sector Donut and Cumulative Alpha Line (+5.0 bps) instantly updated upon news ingestion.</a:t>
+              <a:t>• Strategy Alpha: +5 bps (+0.05% excess return)</a:t>
+            </a:r>
+            <a:br/>
+            <a:r>
+              <a:t>• Portfolio Turnover: 9.49% (controlled cost)</a:t>
+            </a:r>
+            <a:br/>
+            <a:r>
+              <a:t>• Weights Normalized: Exactly 100.0% sum</a:t>
+            </a:r>
+          </a:p>
+          <a:p>
+            <a:pPr>
+              <a:spcBef>
+                <a:spcPts val="600"/>
+              </a:spcBef>
+              <a:defRPr b="1" sz="1000">
+                <a:solidFill>
+                  <a:srgbClr val="F59E0B"/>
+                </a:solidFill>
+              </a:defRPr>
+            </a:pPr>
+            <a:r>
+              <a:t>•  Dynamic Telemetry:</a:t>
+            </a:r>
+          </a:p>
+          <a:p>
+            <a:pPr>
+              <a:spcBef>
+                <a:spcPts val="100"/>
+              </a:spcBef>
+              <a:defRPr sz="900">
+                <a:solidFill>
+                  <a:srgbClr val="F2F4F8"/>
+                </a:solidFill>
+              </a:defRPr>
+            </a:pPr>
+            <a:r>
+              <a:t>Sector donut and cumulative alpha timeline update in real time.</a:t>
             </a:r>
           </a:p>
         </p:txBody>
@@ -5071,7 +5597,7 @@
         </p:nvSpPr>
         <p:spPr>
           <a:xfrm>
-            <a:off x="731520" y="320040"/>
+            <a:off x="731520" y="365760"/>
             <a:ext cx="10698480" cy="320040"/>
           </a:xfrm>
           <a:prstGeom prst="rect">
@@ -5094,7 +5620,7 @@
               </a:defRPr>
             </a:pPr>
             <a:r>
-              <a:t>S&amp;P GLOBAL × CRISIL CAMPUS HACKATHON 2026</a:t>
+              <a:t>S&amp;P GLOBAL × CRISIL CAMPUS HACKATHON 2026 // LIVE CASE STUDY</a:t>
             </a:r>
           </a:p>
         </p:txBody>
@@ -5107,7 +5633,7 @@
         </p:nvSpPr>
         <p:spPr>
           <a:xfrm>
-            <a:off x="731520" y="640080"/>
+            <a:off x="731520" y="685800"/>
             <a:ext cx="10698480" cy="640080"/>
           </a:xfrm>
           <a:prstGeom prst="rect">
@@ -5130,14 +5656,14 @@
               </a:defRPr>
             </a:pPr>
             <a:r>
-              <a:t>Downstream Module B: Wholesale Portfolio Stress Testing ($1.0B Book)</a:t>
+              <a:t>Live Simulation: Module B Wholesale Stress Testing ($1.0B Book)</a:t>
             </a:r>
           </a:p>
         </p:txBody>
       </p:sp>
       <p:pic>
         <p:nvPicPr>
-          <p:cNvPr id="5" name="Picture 4" descr="user_shot_module_b_zelenskyy.png"/>
+          <p:cNvPr id="5" name="Picture 4" descr="trump_russia_module_b.png"/>
           <p:cNvPicPr>
             <a:picLocks noChangeAspect="1"/>
           </p:cNvPicPr>
@@ -5151,8 +5677,8 @@
         </p:blipFill>
         <p:spPr>
           <a:xfrm>
-            <a:off x="731520" y="1463040"/>
-            <a:ext cx="6217920" cy="4754880"/>
+            <a:off x="731520" y="1417320"/>
+            <a:ext cx="6675120" cy="4892040"/>
           </a:xfrm>
           <a:prstGeom prst="rect">
             <a:avLst/>
@@ -5167,8 +5693,8 @@
         </p:nvSpPr>
         <p:spPr>
           <a:xfrm>
-            <a:off x="7132320" y="1463040"/>
-            <a:ext cx="4297680" cy="4754880"/>
+            <a:off x="7589520" y="1417320"/>
+            <a:ext cx="3840480" cy="4892040"/>
           </a:xfrm>
           <a:prstGeom prst="roundRect">
             <a:avLst/>
@@ -5197,24 +5723,24 @@
           </a:fontRef>
         </p:style>
         <p:txBody>
-          <a:bodyPr rtlCol="0" anchor="ctr" lIns="320040" tIns="274320" wrap="square"/>
+          <a:bodyPr rtlCol="0" anchor="ctr" lIns="274320" tIns="228600" wrap="square"/>
           <a:lstStyle/>
           <a:p>
             <a:pPr algn="ctr">
-              <a:defRPr sz="1400" b="1">
+              <a:defRPr sz="1300" b="1">
                 <a:solidFill>
                   <a:srgbClr val="EF4444"/>
                 </a:solidFill>
               </a:defRPr>
             </a:pPr>
             <a:r>
-              <a:t>Module B Live Stress Results</a:t>
+              <a:t>Wholesale Capital Stress Breakdown</a:t>
             </a:r>
           </a:p>
           <a:p>
             <a:pPr>
               <a:spcBef>
-                <a:spcPts val="600"/>
+                <a:spcPts val="500"/>
               </a:spcBef>
               <a:defRPr b="1" sz="1000">
                 <a:solidFill>
@@ -5223,28 +5749,36 @@
               </a:defRPr>
             </a:pPr>
             <a:r>
-              <a:t>•  Wholesale Credit Book Baseline:</a:t>
+              <a:t>•  Macro Shocks Applied:</a:t>
             </a:r>
           </a:p>
           <a:p>
             <a:pPr>
               <a:spcBef>
-                <a:spcPts val="200"/>
+                <a:spcPts val="100"/>
               </a:spcBef>
-              <a:defRPr sz="900">
+              <a:defRPr sz="880">
                 <a:solidFill>
                   <a:srgbClr val="F2F4F8"/>
                 </a:solidFill>
               </a:defRPr>
             </a:pPr>
             <a:r>
-              <a:t>Synthetic $1,000.0M ($1.0B) book across 15 wholesale facilities: $550M Commercial Loans, $450M Corporate Bonds, $250M Derivatives.</a:t>
+              <a:t>• Interest Rate Shift (Δy): +104 bps</a:t>
+            </a:r>
+            <a:br/>
+            <a:r>
+              <a:t>• Credit Spread Widening (Δs): +351 bps</a:t>
+            </a:r>
+            <a:br/>
+            <a:r>
+              <a:t>• Basel PD Multiplier: 2.52x (jump-to-default)</a:t>
             </a:r>
           </a:p>
           <a:p>
             <a:pPr>
               <a:spcBef>
-                <a:spcPts val="600"/>
+                <a:spcPts val="500"/>
               </a:spcBef>
               <a:defRPr b="1" sz="1000">
                 <a:solidFill>
@@ -5253,36 +5787,36 @@
               </a:defRPr>
             </a:pPr>
             <a:r>
-              <a:t>•  Multi-Factor Shocks Calibrated:</a:t>
+              <a:t>•  Capital Loss Breakdown:</a:t>
             </a:r>
           </a:p>
           <a:p>
             <a:pPr>
               <a:spcBef>
-                <a:spcPts val="200"/>
+                <a:spcPts val="100"/>
               </a:spcBef>
-              <a:defRPr sz="900">
+              <a:defRPr sz="880">
                 <a:solidFill>
                   <a:srgbClr val="F2F4F8"/>
                 </a:solidFill>
               </a:defRPr>
             </a:pPr>
             <a:r>
-              <a:t>• Yield Shift (Δy): -4 bps</a:t>
+              <a:t>• Pre-Stress Book: $1,000.0M ($1.0B)</a:t>
             </a:r>
             <a:br/>
             <a:r>
-              <a:t>• Credit Spread Widening (Δs): +10 bps</a:t>
+              <a:t>• Total Capital Drawdown: -$206.4M (-20.64%)</a:t>
             </a:r>
             <a:br/>
             <a:r>
-              <a:t>• Basel PD Multiplier: 1.02x</a:t>
+              <a:t>• Decomposed across Loans (EL) and Bond mark-to-market duration-convexity</a:t>
             </a:r>
           </a:p>
           <a:p>
             <a:pPr>
               <a:spcBef>
-                <a:spcPts val="600"/>
+                <a:spcPts val="500"/>
               </a:spcBef>
               <a:defRPr b="1" sz="1000">
                 <a:solidFill>
@@ -5291,36 +5825,28 @@
               </a:defRPr>
             </a:pPr>
             <a:r>
-              <a:t>•  Valuation Shock &amp; Degradation Waterfall:</a:t>
+              <a:t>•  Post-Stress Valuation:</a:t>
             </a:r>
           </a:p>
           <a:p>
             <a:pPr>
               <a:spcBef>
-                <a:spcPts val="200"/>
+                <a:spcPts val="100"/>
               </a:spcBef>
-              <a:defRPr sz="900">
+              <a:defRPr sz="880">
                 <a:solidFill>
                   <a:srgbClr val="F2F4F8"/>
                 </a:solidFill>
               </a:defRPr>
             </a:pPr>
             <a:r>
-              <a:t>• Pre-Stress Book Valuation: $1000.0M</a:t>
-            </a:r>
-            <a:br/>
-            <a:r>
-              <a:t>• Stressed Capital Loss: -$1.7M (-0.17% Drawdown)</a:t>
-            </a:r>
-            <a:br/>
-            <a:r>
-              <a:t>• Post-Stress Capital: $998.3M (99.83% Retained)</a:t>
+              <a:t>Retained Tier-1 Capital: $793.6M (79.36% preservation)</a:t>
             </a:r>
           </a:p>
           <a:p>
             <a:pPr>
               <a:spcBef>
-                <a:spcPts val="600"/>
+                <a:spcPts val="500"/>
               </a:spcBef>
               <a:defRPr b="1" sz="1000">
                 <a:solidFill>
@@ -5329,28 +5855,28 @@
               </a:defRPr>
             </a:pPr>
             <a:r>
-              <a:t>•  Basel III Capital Adequacy Preserved:</a:t>
+              <a:t>•  Basel III Solvency Floor:</a:t>
             </a:r>
           </a:p>
           <a:p>
             <a:pPr>
               <a:spcBef>
-                <a:spcPts val="200"/>
+                <a:spcPts val="100"/>
               </a:spcBef>
-              <a:defRPr sz="900">
+              <a:defRPr sz="880">
                 <a:solidFill>
                   <a:srgbClr val="F2F4F8"/>
                 </a:solidFill>
               </a:defRPr>
             </a:pPr>
             <a:r>
-              <a:t>Capital buffer remains safely above 8.0% Basel III floor. Retains $998.3M of regulatory Tier-1 capital.</a:t>
+              <a:t>Comfortably survives the 8.0% regulatory minimum capital threshold without breaching bank capital adequacy</a:t>
             </a:r>
           </a:p>
           <a:p>
             <a:pPr>
               <a:spcBef>
-                <a:spcPts val="600"/>
+                <a:spcPts val="500"/>
               </a:spcBef>
               <a:defRPr b="1" sz="1000">
                 <a:solidFill>
@@ -5359,22 +5885,64 @@
               </a:defRPr>
             </a:pPr>
             <a:r>
-              <a:t>•  CRO 'What-If' Sandbox Overrides:</a:t>
+              <a:t>•  Credit Migration Heatmap:</a:t>
             </a:r>
           </a:p>
           <a:p>
             <a:pPr>
               <a:spcBef>
-                <a:spcPts val="200"/>
+                <a:spcPts val="100"/>
               </a:spcBef>
-              <a:defRPr sz="900">
+              <a:defRPr sz="880">
                 <a:solidFill>
                   <a:srgbClr val="F2F4F8"/>
                 </a:solidFill>
               </a:defRPr>
             </a:pPr>
             <a:r>
-              <a:t>Sliders dynamically synced to event parameters, allowing risk committees to run custom sensitivity checks.</a:t>
+              <a:t>• AAA: 0.10% -&gt; 0.25%</a:t>
+            </a:r>
+            <a:br/>
+            <a:r>
+              <a:t>• A: 0.80% -&gt; 2.00%</a:t>
+            </a:r>
+            <a:br/>
+            <a:r>
+              <a:t>• BBB: 1.80% -&gt; 4.50%</a:t>
+            </a:r>
+            <a:br/>
+            <a:r>
+              <a:t>• B: 9.50% -&gt; 23.75% default rate</a:t>
+            </a:r>
+          </a:p>
+          <a:p>
+            <a:pPr>
+              <a:spcBef>
+                <a:spcPts val="500"/>
+              </a:spcBef>
+              <a:defRPr b="1" sz="1000">
+                <a:solidFill>
+                  <a:srgbClr val="F59E0B"/>
+                </a:solidFill>
+              </a:defRPr>
+            </a:pPr>
+            <a:r>
+              <a:t>•  CRO 'What-If' Overrides:</a:t>
+            </a:r>
+          </a:p>
+          <a:p>
+            <a:pPr>
+              <a:spcBef>
+                <a:spcPts val="100"/>
+              </a:spcBef>
+              <a:defRPr sz="880">
+                <a:solidFill>
+                  <a:srgbClr val="F2F4F8"/>
+                </a:solidFill>
+              </a:defRPr>
+            </a:pPr>
+            <a:r>
+              <a:t>Sliders dynamically synced to the event shock</a:t>
             </a:r>
           </a:p>
         </p:txBody>
@@ -5448,7 +6016,7 @@
         </p:nvSpPr>
         <p:spPr>
           <a:xfrm>
-            <a:off x="731520" y="320040"/>
+            <a:off x="731520" y="365760"/>
             <a:ext cx="10698480" cy="320040"/>
           </a:xfrm>
           <a:prstGeom prst="rect">
@@ -5471,7 +6039,7 @@
               </a:defRPr>
             </a:pPr>
             <a:r>
-              <a:t>S&amp;P GLOBAL × CRISIL CAMPUS HACKATHON 2026</a:t>
+              <a:t>S&amp;P GLOBAL × CRISIL CAMPUS HACKATHON 2026 // LIVE CASE STUDY</a:t>
             </a:r>
           </a:p>
         </p:txBody>
@@ -5484,7 +6052,7 @@
         </p:nvSpPr>
         <p:spPr>
           <a:xfrm>
-            <a:off x="731520" y="640080"/>
+            <a:off x="731520" y="685800"/>
             <a:ext cx="10698480" cy="640080"/>
           </a:xfrm>
           <a:prstGeom prst="rect">
@@ -5507,14 +6075,14 @@
               </a:defRPr>
             </a:pPr>
             <a:r>
-              <a:t>AI Copilot Intelligence, Domain Impact &amp; Roadmap</a:t>
+              <a:t>Institutional Domain Impact, AI Copilot &amp; Strategic Roadmap</a:t>
             </a:r>
           </a:p>
         </p:txBody>
       </p:sp>
       <p:pic>
         <p:nvPicPr>
-          <p:cNvPr id="5" name="Picture 4" descr="user_shot_copilot.png"/>
+          <p:cNvPr id="5" name="Picture 4" descr="shot_copilot.png"/>
           <p:cNvPicPr>
             <a:picLocks noChangeAspect="1"/>
           </p:cNvPicPr>
@@ -5528,8 +6096,8 @@
         </p:blipFill>
         <p:spPr>
           <a:xfrm>
-            <a:off x="731520" y="1463040"/>
-            <a:ext cx="4114800" cy="4754880"/>
+            <a:off x="731520" y="1417320"/>
+            <a:ext cx="3931920" cy="4892040"/>
           </a:xfrm>
           <a:prstGeom prst="rect">
             <a:avLst/>
@@ -5544,8 +6112,8 @@
         </p:nvSpPr>
         <p:spPr>
           <a:xfrm>
-            <a:off x="5029200" y="1463040"/>
-            <a:ext cx="6400800" cy="2286000"/>
+            <a:off x="4846320" y="1417320"/>
+            <a:ext cx="6583680" cy="2468880"/>
           </a:xfrm>
           <a:prstGeom prst="roundRect">
             <a:avLst/>
@@ -5574,7 +6142,7 @@
           </a:fontRef>
         </p:style>
         <p:txBody>
-          <a:bodyPr rtlCol="0" anchor="ctr" lIns="274320" tIns="228600" wrap="square"/>
+          <a:bodyPr rtlCol="0" anchor="ctr" lIns="274320" tIns="182880" wrap="square"/>
           <a:lstStyle/>
           <a:p>
             <a:pPr algn="ctr">
@@ -5585,22 +6153,22 @@
               </a:defRPr>
             </a:pPr>
             <a:r>
-              <a:t>Institutional Value &amp; Domain Impact</a:t>
+              <a:t>Institutional Business Value &amp; Domain Impact</a:t>
             </a:r>
           </a:p>
           <a:p>
             <a:pPr>
               <a:spcBef>
-                <a:spcPts val="600"/>
+                <a:spcPts val="500"/>
               </a:spcBef>
-              <a:defRPr sz="1000">
+              <a:defRPr sz="950">
                 <a:solidFill>
                   <a:srgbClr val="F2F4F8"/>
                 </a:solidFill>
               </a:defRPr>
             </a:pPr>
             <a:r>
-              <a:t>• Early Contagion Warning: Detects credit distress 3 to 14 days before rating agency downgrades.</a:t>
+              <a:t>• Pre-Emptive Counterparty Protection: Detects acute geopolitical and credit contagion 3 to 14 days before credit rating agency actions.</a:t>
             </a:r>
           </a:p>
           <a:p>
@@ -5608,14 +6176,14 @@
               <a:spcBef>
                 <a:spcPts val="400"/>
               </a:spcBef>
-              <a:defRPr sz="1000">
+              <a:defRPr sz="950">
                 <a:solidFill>
                   <a:srgbClr val="F2F4F8"/>
                 </a:solidFill>
               </a:defRPr>
             </a:pPr>
             <a:r>
-              <a:t>• Cross-Asset Silo Breakdown: Provides a unified qualitative truth connecting equity PMs and credit CROs.</a:t>
+              <a:t>• Unifying Risk &amp; Alpha: Bridges quantitative equity managers (tactical rebalancing) and wholesale credit officers (Basel III stress testing) onto a single source of qualitative truth.</a:t>
             </a:r>
           </a:p>
           <a:p>
@@ -5623,14 +6191,14 @@
               <a:spcBef>
                 <a:spcPts val="400"/>
               </a:spcBef>
-              <a:defRPr sz="1000">
+              <a:defRPr sz="950">
                 <a:solidFill>
                   <a:srgbClr val="F2F4F8"/>
                 </a:solidFill>
               </a:defRPr>
             </a:pPr>
             <a:r>
-              <a:t>• AI Copilot Vision: Features real-time chart snapshot reasoning and mathematical formula verification.</a:t>
+              <a:t>• AI Copilot Vision &amp; Mathematical Proof: Risk committees can verify dashboard figures with chart snapshot analysis and Merton Expected Loss formulations.</a:t>
             </a:r>
           </a:p>
         </p:txBody>
@@ -5644,8 +6212,8 @@
           <p:nvPr/>
         </p:nvGraphicFramePr>
         <p:xfrm>
-          <a:off x="5029200" y="3931920"/>
-          <a:ext cx="6400800" cy="2286000"/>
+          <a:off x="4846320" y="4069080"/>
+          <a:ext cx="6583680" cy="2240280"/>
         </p:xfrm>
         <a:graphic>
           <a:graphicData uri="http://schemas.openxmlformats.org/drawingml/2006/table">
@@ -5654,12 +6222,12 @@
                 <a:tableStyleId>{5C22544A-7EE6-4342-B048-85BDC9FD1C3A}</a:tableStyleId>
               </a:tblPr>
               <a:tblGrid>
-                <a:gridCol w="1600200"/>
-                <a:gridCol w="1600200"/>
-                <a:gridCol w="1600200"/>
-                <a:gridCol w="1600200"/>
+                <a:gridCol w="1645920"/>
+                <a:gridCol w="1645920"/>
+                <a:gridCol w="1645920"/>
+                <a:gridCol w="1645920"/>
               </a:tblGrid>
-              <a:tr h="1143000">
+              <a:tr h="1120140">
                 <a:tc>
                   <a:txBody>
                     <a:bodyPr/>
@@ -5753,7 +6321,7 @@
                   </a:tcPr>
                 </a:tc>
               </a:tr>
-              <a:tr h="1143000">
+              <a:tr h="1120140">
                 <a:tc>
                   <a:txBody>
                     <a:bodyPr/>
@@ -5767,7 +6335,7 @@
                         </a:defRPr>
                       </a:pPr>
                       <a:r>
-                        <a:t>Dual downstream + sub-25ms NLP + ISTC cockpit UI.</a:t>
+                        <a:t>Dual downstream modules + sub-25ms NLP + live crisis simulation.</a:t>
                       </a:r>
                     </a:p>
                   </a:txBody>
@@ -5790,7 +6358,7 @@
                         </a:defRPr>
                       </a:pPr>
                       <a:r>
-                        <a:t>Scale to 5,000+ global tickers with Celery / Redis.</a:t>
+                        <a:t>Scale to 5,000+ global equities with distributed Celery &amp; Redis.</a:t>
                       </a:r>
                     </a:p>
                   </a:txBody>
@@ -5813,7 +6381,7 @@
                         </a:defRPr>
                       </a:pPr>
                       <a:r>
-                        <a:t>FIX protocol order routing to dark pools.</a:t>
+                        <a:t>Direct Market Access (DMA) FIX protocol order routing into dark pools.</a:t>
                       </a:r>
                     </a:p>
                   </a:txBody>
@@ -5836,7 +6404,7 @@
                         </a:defRPr>
                       </a:pPr>
                       <a:r>
-                        <a:t>SEC 10-K parser + FOMC speech transcription.</a:t>
+                        <a:t>SEC 10-K filing parser + central bank press conference audio transcription.</a:t>
                       </a:r>
                     </a:p>
                   </a:txBody>

</xml_diff>

<commit_message>
docs: add RiskPulse AI Copilot live screenshot to Slide 7 in PPTX and PDF decks
</commit_message>
<xml_diff>
--- a/docs/presentation.pptx
+++ b/docs/presentation.pptx
@@ -6082,7 +6082,7 @@
       </p:sp>
       <p:pic>
         <p:nvPicPr>
-          <p:cNvPr id="5" name="Picture 4" descr="shot_copilot.png"/>
+          <p:cNvPr id="5" name="Picture 4" descr="trump_russia_copilot.png"/>
           <p:cNvPicPr>
             <a:picLocks noChangeAspect="1"/>
           </p:cNvPicPr>
@@ -6097,7 +6097,7 @@
         <p:spPr>
           <a:xfrm>
             <a:off x="731520" y="1417320"/>
-            <a:ext cx="3931920" cy="4892040"/>
+            <a:ext cx="3657600" cy="4690872"/>
           </a:xfrm>
           <a:prstGeom prst="rect">
             <a:avLst/>
@@ -6112,8 +6112,8 @@
         </p:nvSpPr>
         <p:spPr>
           <a:xfrm>
-            <a:off x="4846320" y="1417320"/>
-            <a:ext cx="6583680" cy="2468880"/>
+            <a:off x="4663440" y="1417320"/>
+            <a:ext cx="6766560" cy="2468880"/>
           </a:xfrm>
           <a:prstGeom prst="roundRect">
             <a:avLst/>

</xml_diff>